<commit_message>
Update presentation, add Display
</commit_message>
<xml_diff>
--- a/Docs/Chess Display and Computers.pptx
+++ b/Docs/Chess Display and Computers.pptx
@@ -5,10 +5,10 @@
     <p:sldMasterId id="2147483687" r:id="rId1"/>
   </p:sldMasterIdLst>
   <p:notesMasterIdLst>
-    <p:notesMasterId r:id="rId29"/>
+    <p:notesMasterId r:id="rId28"/>
   </p:notesMasterIdLst>
   <p:handoutMasterIdLst>
-    <p:handoutMasterId r:id="rId30"/>
+    <p:handoutMasterId r:id="rId29"/>
   </p:handoutMasterIdLst>
   <p:sldIdLst>
     <p:sldId id="256" r:id="rId2"/>
@@ -23,21 +23,20 @@
     <p:sldId id="408" r:id="rId11"/>
     <p:sldId id="409" r:id="rId12"/>
     <p:sldId id="410" r:id="rId13"/>
-    <p:sldId id="413" r:id="rId14"/>
-    <p:sldId id="414" r:id="rId15"/>
-    <p:sldId id="415" r:id="rId16"/>
-    <p:sldId id="416" r:id="rId17"/>
-    <p:sldId id="421" r:id="rId18"/>
-    <p:sldId id="424" r:id="rId19"/>
-    <p:sldId id="418" r:id="rId20"/>
-    <p:sldId id="420" r:id="rId21"/>
-    <p:sldId id="422" r:id="rId22"/>
-    <p:sldId id="423" r:id="rId23"/>
-    <p:sldId id="417" r:id="rId24"/>
-    <p:sldId id="427" r:id="rId25"/>
-    <p:sldId id="430" r:id="rId26"/>
-    <p:sldId id="429" r:id="rId27"/>
-    <p:sldId id="403" r:id="rId28"/>
+    <p:sldId id="414" r:id="rId14"/>
+    <p:sldId id="415" r:id="rId15"/>
+    <p:sldId id="416" r:id="rId16"/>
+    <p:sldId id="421" r:id="rId17"/>
+    <p:sldId id="424" r:id="rId18"/>
+    <p:sldId id="418" r:id="rId19"/>
+    <p:sldId id="420" r:id="rId20"/>
+    <p:sldId id="422" r:id="rId21"/>
+    <p:sldId id="423" r:id="rId22"/>
+    <p:sldId id="417" r:id="rId23"/>
+    <p:sldId id="427" r:id="rId24"/>
+    <p:sldId id="430" r:id="rId25"/>
+    <p:sldId id="429" r:id="rId26"/>
+    <p:sldId id="403" r:id="rId27"/>
   </p:sldIdLst>
   <p:sldSz cx="12192000" cy="6858000"/>
   <p:notesSz cx="7102475" cy="9388475"/>
@@ -257,7 +256,7 @@
           <a:p>
             <a:fld id="{71F68F6A-2B9C-4819-AC3B-6AE3589F1402}" type="datetime1">
               <a:rPr lang="en-US" smtClean="0"/>
-              <a:t>7/24/2026</a:t>
+              <a:t>7/27/2026</a:t>
             </a:fld>
             <a:endParaRPr lang="en-US" dirty="0"/>
           </a:p>
@@ -441,7 +440,7 @@
           <a:p>
             <a:fld id="{5397933D-7A1B-4403-8C00-DE52D8FE2162}" type="datetime1">
               <a:rPr lang="en-US" smtClean="0"/>
-              <a:t>7/24/2026</a:t>
+              <a:t>7/27/2026</a:t>
             </a:fld>
             <a:endParaRPr lang="en-US" dirty="0"/>
           </a:p>
@@ -806,7 +805,7 @@
           <a:p>
             <a:fld id="{DC084F0E-41CF-4207-8B70-198F21418836}" type="datetime1">
               <a:rPr lang="en-US" smtClean="0"/>
-              <a:t>7/24/2026</a:t>
+              <a:t>7/27/2026</a:t>
             </a:fld>
             <a:endParaRPr lang="en-US" dirty="0"/>
           </a:p>
@@ -871,206 +870,6 @@
 </file>
 
 <file path=ppt/notesSlides/notesSlide10.xml><?xml version="1.0" encoding="utf-8"?>
-<p:notes xmlns:a="http://schemas.openxmlformats.org/drawingml/2006/main" xmlns:r="http://schemas.openxmlformats.org/officeDocument/2006/relationships" xmlns:p="http://schemas.openxmlformats.org/presentationml/2006/main">
-  <p:cSld>
-    <p:spTree>
-      <p:nvGrpSpPr>
-        <p:cNvPr id="1" name="">
-          <a:extLst>
-            <a:ext uri="{FF2B5EF4-FFF2-40B4-BE49-F238E27FC236}">
-              <a16:creationId xmlns:a16="http://schemas.microsoft.com/office/drawing/2014/main" id="{A3B580B5-1130-1A94-C82A-CF4D68A02B51}"/>
-            </a:ext>
-          </a:extLst>
-        </p:cNvPr>
-        <p:cNvGrpSpPr/>
-        <p:nvPr/>
-      </p:nvGrpSpPr>
-      <p:grpSpPr>
-        <a:xfrm>
-          <a:off x="0" y="0"/>
-          <a:ext cx="0" cy="0"/>
-          <a:chOff x="0" y="0"/>
-          <a:chExt cx="0" cy="0"/>
-        </a:xfrm>
-      </p:grpSpPr>
-      <p:sp>
-        <p:nvSpPr>
-          <p:cNvPr id="2" name="Slide Image Placeholder 1">
-            <a:extLst>
-              <a:ext uri="{FF2B5EF4-FFF2-40B4-BE49-F238E27FC236}">
-                <a16:creationId xmlns:a16="http://schemas.microsoft.com/office/drawing/2014/main" id="{12CFE8CC-EC09-7070-44E6-14742E1E3A35}"/>
-              </a:ext>
-            </a:extLst>
-          </p:cNvPr>
-          <p:cNvSpPr>
-            <a:spLocks noGrp="1" noRot="1" noChangeAspect="1"/>
-          </p:cNvSpPr>
-          <p:nvPr>
-            <p:ph type="sldImg"/>
-          </p:nvPr>
-        </p:nvSpPr>
-        <p:spPr/>
-        <p:txBody>
-          <a:bodyPr/>
-          <a:lstStyle/>
-          <a:p>
-            <a:endParaRPr lang="en-US"/>
-          </a:p>
-        </p:txBody>
-      </p:sp>
-      <p:sp>
-        <p:nvSpPr>
-          <p:cNvPr id="3" name="Notes Placeholder 2">
-            <a:extLst>
-              <a:ext uri="{FF2B5EF4-FFF2-40B4-BE49-F238E27FC236}">
-                <a16:creationId xmlns:a16="http://schemas.microsoft.com/office/drawing/2014/main" id="{A2CD631D-D45C-EE14-4945-5E4DBC7F1C92}"/>
-              </a:ext>
-            </a:extLst>
-          </p:cNvPr>
-          <p:cNvSpPr>
-            <a:spLocks noGrp="1"/>
-          </p:cNvSpPr>
-          <p:nvPr>
-            <p:ph type="body" idx="1"/>
-          </p:nvPr>
-        </p:nvSpPr>
-        <p:spPr/>
-        <p:txBody>
-          <a:bodyPr/>
-          <a:lstStyle/>
-          <a:p>
-            <a:endParaRPr lang="en-US" dirty="0"/>
-          </a:p>
-        </p:txBody>
-      </p:sp>
-      <p:sp>
-        <p:nvSpPr>
-          <p:cNvPr id="4" name="Header Placeholder 3">
-            <a:extLst>
-              <a:ext uri="{FF2B5EF4-FFF2-40B4-BE49-F238E27FC236}">
-                <a16:creationId xmlns:a16="http://schemas.microsoft.com/office/drawing/2014/main" id="{880C9714-390E-3673-5DF9-E358208C5346}"/>
-              </a:ext>
-            </a:extLst>
-          </p:cNvPr>
-          <p:cNvSpPr>
-            <a:spLocks noGrp="1"/>
-          </p:cNvSpPr>
-          <p:nvPr>
-            <p:ph type="hdr" sz="quarter" idx="10"/>
-          </p:nvPr>
-        </p:nvSpPr>
-        <p:spPr/>
-        <p:txBody>
-          <a:bodyPr/>
-          <a:lstStyle/>
-          <a:p>
-            <a:r>
-              <a:rPr lang="en-US" dirty="0"/>
-              <a:t>Introduction to Programming using Python</a:t>
-            </a:r>
-          </a:p>
-        </p:txBody>
-      </p:sp>
-      <p:sp>
-        <p:nvSpPr>
-          <p:cNvPr id="5" name="Date Placeholder 4">
-            <a:extLst>
-              <a:ext uri="{FF2B5EF4-FFF2-40B4-BE49-F238E27FC236}">
-                <a16:creationId xmlns:a16="http://schemas.microsoft.com/office/drawing/2014/main" id="{C464B549-604F-0CFC-F8FB-E8FD718BBC8A}"/>
-              </a:ext>
-            </a:extLst>
-          </p:cNvPr>
-          <p:cNvSpPr>
-            <a:spLocks noGrp="1"/>
-          </p:cNvSpPr>
-          <p:nvPr>
-            <p:ph type="dt" idx="11"/>
-          </p:nvPr>
-        </p:nvSpPr>
-        <p:spPr/>
-        <p:txBody>
-          <a:bodyPr/>
-          <a:lstStyle/>
-          <a:p>
-            <a:fld id="{E734D050-5128-424E-B0C7-5BFB4917C3AB}" type="datetime1">
-              <a:rPr lang="en-US" smtClean="0"/>
-              <a:t>7/24/2026</a:t>
-            </a:fld>
-            <a:endParaRPr lang="en-US" dirty="0"/>
-          </a:p>
-        </p:txBody>
-      </p:sp>
-      <p:sp>
-        <p:nvSpPr>
-          <p:cNvPr id="6" name="Footer Placeholder 5">
-            <a:extLst>
-              <a:ext uri="{FF2B5EF4-FFF2-40B4-BE49-F238E27FC236}">
-                <a16:creationId xmlns:a16="http://schemas.microsoft.com/office/drawing/2014/main" id="{7A05C178-319C-915C-97BF-85E4BCF314B0}"/>
-              </a:ext>
-            </a:extLst>
-          </p:cNvPr>
-          <p:cNvSpPr>
-            <a:spLocks noGrp="1"/>
-          </p:cNvSpPr>
-          <p:nvPr>
-            <p:ph type="ftr" sz="quarter" idx="12"/>
-          </p:nvPr>
-        </p:nvSpPr>
-        <p:spPr/>
-        <p:txBody>
-          <a:bodyPr/>
-          <a:lstStyle/>
-          <a:p>
-            <a:r>
-              <a:rPr lang="en-US" dirty="0"/>
-              <a:t>raysmith@alum.mit.edu</a:t>
-            </a:r>
-          </a:p>
-        </p:txBody>
-      </p:sp>
-      <p:sp>
-        <p:nvSpPr>
-          <p:cNvPr id="7" name="Slide Number Placeholder 6">
-            <a:extLst>
-              <a:ext uri="{FF2B5EF4-FFF2-40B4-BE49-F238E27FC236}">
-                <a16:creationId xmlns:a16="http://schemas.microsoft.com/office/drawing/2014/main" id="{7A468222-0813-7B0C-EDD5-117C7FA26AB1}"/>
-              </a:ext>
-            </a:extLst>
-          </p:cNvPr>
-          <p:cNvSpPr>
-            <a:spLocks noGrp="1"/>
-          </p:cNvSpPr>
-          <p:nvPr>
-            <p:ph type="sldNum" sz="quarter" idx="13"/>
-          </p:nvPr>
-        </p:nvSpPr>
-        <p:spPr/>
-        <p:txBody>
-          <a:bodyPr/>
-          <a:lstStyle/>
-          <a:p>
-            <a:fld id="{BA791329-992B-4F83-8435-C33B0EC26DB3}" type="slidenum">
-              <a:rPr lang="en-US" smtClean="0"/>
-              <a:t>14</a:t>
-            </a:fld>
-            <a:endParaRPr lang="en-US" dirty="0"/>
-          </a:p>
-        </p:txBody>
-      </p:sp>
-    </p:spTree>
-    <p:extLst>
-      <p:ext uri="{BB962C8B-B14F-4D97-AF65-F5344CB8AC3E}">
-        <p14:creationId xmlns:p14="http://schemas.microsoft.com/office/powerpoint/2010/main" val="535673981"/>
-      </p:ext>
-    </p:extLst>
-  </p:cSld>
-  <p:clrMapOvr>
-    <a:masterClrMapping/>
-  </p:clrMapOvr>
-</p:notes>
-</file>
-
-<file path=ppt/notesSlides/notesSlide11.xml><?xml version="1.0" encoding="utf-8"?>
 <p:notes xmlns:a="http://schemas.openxmlformats.org/drawingml/2006/main" xmlns:r="http://schemas.openxmlformats.org/officeDocument/2006/relationships" xmlns:p="http://schemas.openxmlformats.org/presentationml/2006/main">
   <p:cSld>
     <p:spTree>
@@ -1194,7 +993,7 @@
           <a:p>
             <a:fld id="{E734D050-5128-424E-B0C7-5BFB4917C3AB}" type="datetime1">
               <a:rPr lang="en-US" smtClean="0"/>
-              <a:t>7/24/2026</a:t>
+              <a:t>7/27/2026</a:t>
             </a:fld>
             <a:endParaRPr lang="en-US" dirty="0"/>
           </a:p>
@@ -1251,7 +1050,7 @@
           <a:p>
             <a:fld id="{BA791329-992B-4F83-8435-C33B0EC26DB3}" type="slidenum">
               <a:rPr lang="en-US" smtClean="0"/>
-              <a:t>15</a:t>
+              <a:t>14</a:t>
             </a:fld>
             <a:endParaRPr lang="en-US" dirty="0"/>
           </a:p>
@@ -1270,7 +1069,7 @@
 </p:notes>
 </file>
 
-<file path=ppt/notesSlides/notesSlide12.xml><?xml version="1.0" encoding="utf-8"?>
+<file path=ppt/notesSlides/notesSlide11.xml><?xml version="1.0" encoding="utf-8"?>
 <p:notes xmlns:a="http://schemas.openxmlformats.org/drawingml/2006/main" xmlns:r="http://schemas.openxmlformats.org/officeDocument/2006/relationships" xmlns:p="http://schemas.openxmlformats.org/presentationml/2006/main">
   <p:cSld>
     <p:spTree>
@@ -1394,7 +1193,7 @@
           <a:p>
             <a:fld id="{E734D050-5128-424E-B0C7-5BFB4917C3AB}" type="datetime1">
               <a:rPr lang="en-US" smtClean="0"/>
-              <a:t>7/24/2026</a:t>
+              <a:t>7/27/2026</a:t>
             </a:fld>
             <a:endParaRPr lang="en-US" dirty="0"/>
           </a:p>
@@ -1451,7 +1250,7 @@
           <a:p>
             <a:fld id="{BA791329-992B-4F83-8435-C33B0EC26DB3}" type="slidenum">
               <a:rPr lang="en-US" smtClean="0"/>
-              <a:t>16</a:t>
+              <a:t>15</a:t>
             </a:fld>
             <a:endParaRPr lang="en-US" dirty="0"/>
           </a:p>
@@ -1461,6 +1260,169 @@
     <p:extLst>
       <p:ext uri="{BB962C8B-B14F-4D97-AF65-F5344CB8AC3E}">
         <p14:creationId xmlns:p14="http://schemas.microsoft.com/office/powerpoint/2010/main" val="222032709"/>
+      </p:ext>
+    </p:extLst>
+  </p:cSld>
+  <p:clrMapOvr>
+    <a:masterClrMapping/>
+  </p:clrMapOvr>
+</p:notes>
+</file>
+
+<file path=ppt/notesSlides/notesSlide12.xml><?xml version="1.0" encoding="utf-8"?>
+<p:notes xmlns:a="http://schemas.openxmlformats.org/drawingml/2006/main" xmlns:r="http://schemas.openxmlformats.org/officeDocument/2006/relationships" xmlns:p="http://schemas.openxmlformats.org/presentationml/2006/main">
+  <p:cSld>
+    <p:spTree>
+      <p:nvGrpSpPr>
+        <p:cNvPr id="1" name=""/>
+        <p:cNvGrpSpPr/>
+        <p:nvPr/>
+      </p:nvGrpSpPr>
+      <p:grpSpPr>
+        <a:xfrm>
+          <a:off x="0" y="0"/>
+          <a:ext cx="0" cy="0"/>
+          <a:chOff x="0" y="0"/>
+          <a:chExt cx="0" cy="0"/>
+        </a:xfrm>
+      </p:grpSpPr>
+      <p:sp>
+        <p:nvSpPr>
+          <p:cNvPr id="2" name="Slide Image Placeholder 1"/>
+          <p:cNvSpPr>
+            <a:spLocks noGrp="1" noRot="1" noChangeAspect="1"/>
+          </p:cNvSpPr>
+          <p:nvPr>
+            <p:ph type="sldImg"/>
+          </p:nvPr>
+        </p:nvSpPr>
+        <p:spPr/>
+        <p:txBody>
+          <a:bodyPr/>
+          <a:lstStyle/>
+          <a:p>
+            <a:endParaRPr lang="en-US"/>
+          </a:p>
+        </p:txBody>
+      </p:sp>
+      <p:sp>
+        <p:nvSpPr>
+          <p:cNvPr id="3" name="Notes Placeholder 2"/>
+          <p:cNvSpPr>
+            <a:spLocks noGrp="1"/>
+          </p:cNvSpPr>
+          <p:nvPr>
+            <p:ph type="body" idx="1"/>
+          </p:nvPr>
+        </p:nvSpPr>
+        <p:spPr/>
+        <p:txBody>
+          <a:bodyPr/>
+          <a:lstStyle/>
+          <a:p>
+            <a:r>
+              <a:rPr lang="en-US" dirty="0"/>
+              <a:t>Table reverses up(1) with down(-1) for black</a:t>
+            </a:r>
+          </a:p>
+        </p:txBody>
+      </p:sp>
+      <p:sp>
+        <p:nvSpPr>
+          <p:cNvPr id="4" name="Header Placeholder 3"/>
+          <p:cNvSpPr>
+            <a:spLocks noGrp="1"/>
+          </p:cNvSpPr>
+          <p:nvPr>
+            <p:ph type="hdr" sz="quarter"/>
+          </p:nvPr>
+        </p:nvSpPr>
+        <p:spPr/>
+        <p:txBody>
+          <a:bodyPr/>
+          <a:lstStyle/>
+          <a:p>
+            <a:r>
+              <a:rPr lang="en-US"/>
+              <a:t>Introduction to Programming using Python</a:t>
+            </a:r>
+            <a:endParaRPr lang="en-US" dirty="0"/>
+          </a:p>
+        </p:txBody>
+      </p:sp>
+      <p:sp>
+        <p:nvSpPr>
+          <p:cNvPr id="5" name="Date Placeholder 4"/>
+          <p:cNvSpPr>
+            <a:spLocks noGrp="1"/>
+          </p:cNvSpPr>
+          <p:nvPr>
+            <p:ph type="dt" idx="1"/>
+          </p:nvPr>
+        </p:nvSpPr>
+        <p:spPr/>
+        <p:txBody>
+          <a:bodyPr/>
+          <a:lstStyle/>
+          <a:p>
+            <a:fld id="{5397933D-7A1B-4403-8C00-DE52D8FE2162}" type="datetime1">
+              <a:rPr lang="en-US" smtClean="0"/>
+              <a:t>7/27/2026</a:t>
+            </a:fld>
+            <a:endParaRPr lang="en-US" dirty="0"/>
+          </a:p>
+        </p:txBody>
+      </p:sp>
+      <p:sp>
+        <p:nvSpPr>
+          <p:cNvPr id="6" name="Footer Placeholder 5"/>
+          <p:cNvSpPr>
+            <a:spLocks noGrp="1"/>
+          </p:cNvSpPr>
+          <p:nvPr>
+            <p:ph type="ftr" sz="quarter" idx="4"/>
+          </p:nvPr>
+        </p:nvSpPr>
+        <p:spPr/>
+        <p:txBody>
+          <a:bodyPr/>
+          <a:lstStyle/>
+          <a:p>
+            <a:r>
+              <a:rPr lang="en-US"/>
+              <a:t>raysmith@alum.mit.edu</a:t>
+            </a:r>
+            <a:endParaRPr lang="en-US" dirty="0"/>
+          </a:p>
+        </p:txBody>
+      </p:sp>
+      <p:sp>
+        <p:nvSpPr>
+          <p:cNvPr id="7" name="Slide Number Placeholder 6"/>
+          <p:cNvSpPr>
+            <a:spLocks noGrp="1"/>
+          </p:cNvSpPr>
+          <p:nvPr>
+            <p:ph type="sldNum" sz="quarter" idx="5"/>
+          </p:nvPr>
+        </p:nvSpPr>
+        <p:spPr/>
+        <p:txBody>
+          <a:bodyPr/>
+          <a:lstStyle/>
+          <a:p>
+            <a:fld id="{BA791329-992B-4F83-8435-C33B0EC26DB3}" type="slidenum">
+              <a:rPr lang="en-US" smtClean="0"/>
+              <a:t>19</a:t>
+            </a:fld>
+            <a:endParaRPr lang="en-US" dirty="0"/>
+          </a:p>
+        </p:txBody>
+      </p:sp>
+    </p:spTree>
+    <p:extLst>
+      <p:ext uri="{BB962C8B-B14F-4D97-AF65-F5344CB8AC3E}">
+        <p14:creationId xmlns:p14="http://schemas.microsoft.com/office/powerpoint/2010/main" val="1724100328"/>
       </p:ext>
     </p:extLst>
   </p:cSld>
@@ -1521,10 +1483,7 @@
           <a:bodyPr/>
           <a:lstStyle/>
           <a:p>
-            <a:r>
-              <a:rPr lang="en-US" dirty="0"/>
-              <a:t>Table reverses up(1) with down(-1) for black</a:t>
-            </a:r>
+            <a:endParaRPr lang="en-US" dirty="0"/>
           </a:p>
         </p:txBody>
       </p:sp>
@@ -1568,7 +1527,7 @@
           <a:p>
             <a:fld id="{5397933D-7A1B-4403-8C00-DE52D8FE2162}" type="datetime1">
               <a:rPr lang="en-US" smtClean="0"/>
-              <a:t>7/24/2026</a:t>
+              <a:t>7/27/2026</a:t>
             </a:fld>
             <a:endParaRPr lang="en-US" dirty="0"/>
           </a:p>
@@ -1614,7 +1573,7 @@
           <a:p>
             <a:fld id="{BA791329-992B-4F83-8435-C33B0EC26DB3}" type="slidenum">
               <a:rPr lang="en-US" smtClean="0"/>
-              <a:t>20</a:t>
+              <a:t>21</a:t>
             </a:fld>
             <a:endParaRPr lang="en-US" dirty="0"/>
           </a:p>
@@ -1623,7 +1582,7 @@
     </p:spTree>
     <p:extLst>
       <p:ext uri="{BB962C8B-B14F-4D97-AF65-F5344CB8AC3E}">
-        <p14:creationId xmlns:p14="http://schemas.microsoft.com/office/powerpoint/2010/main" val="1724100328"/>
+        <p14:creationId xmlns:p14="http://schemas.microsoft.com/office/powerpoint/2010/main" val="3083072296"/>
       </p:ext>
     </p:extLst>
   </p:cSld>
@@ -1695,19 +1654,18 @@
             <a:spLocks noGrp="1"/>
           </p:cNvSpPr>
           <p:nvPr>
-            <p:ph type="hdr" sz="quarter"/>
-          </p:nvPr>
-        </p:nvSpPr>
-        <p:spPr/>
-        <p:txBody>
-          <a:bodyPr/>
-          <a:lstStyle/>
-          <a:p>
-            <a:r>
-              <a:rPr lang="en-US"/>
+            <p:ph type="hdr" sz="quarter" idx="10"/>
+          </p:nvPr>
+        </p:nvSpPr>
+        <p:spPr/>
+        <p:txBody>
+          <a:bodyPr/>
+          <a:lstStyle/>
+          <a:p>
+            <a:r>
+              <a:rPr lang="en-US" dirty="0"/>
               <a:t>Introduction to Programming using Python</a:t>
             </a:r>
-            <a:endParaRPr lang="en-US" dirty="0"/>
           </a:p>
         </p:txBody>
       </p:sp>
@@ -1718,17 +1676,17 @@
             <a:spLocks noGrp="1"/>
           </p:cNvSpPr>
           <p:nvPr>
-            <p:ph type="dt" idx="1"/>
-          </p:nvPr>
-        </p:nvSpPr>
-        <p:spPr/>
-        <p:txBody>
-          <a:bodyPr/>
-          <a:lstStyle/>
-          <a:p>
-            <a:fld id="{5397933D-7A1B-4403-8C00-DE52D8FE2162}" type="datetime1">
+            <p:ph type="dt" idx="11"/>
+          </p:nvPr>
+        </p:nvSpPr>
+        <p:spPr/>
+        <p:txBody>
+          <a:bodyPr/>
+          <a:lstStyle/>
+          <a:p>
+            <a:fld id="{81E0ADA2-1B64-45DB-B2E6-F6A11AB7EB98}" type="datetime1">
               <a:rPr lang="en-US" smtClean="0"/>
-              <a:t>7/24/2026</a:t>
+              <a:t>7/27/2026</a:t>
             </a:fld>
             <a:endParaRPr lang="en-US" dirty="0"/>
           </a:p>
@@ -1741,19 +1699,18 @@
             <a:spLocks noGrp="1"/>
           </p:cNvSpPr>
           <p:nvPr>
-            <p:ph type="ftr" sz="quarter" idx="4"/>
-          </p:nvPr>
-        </p:nvSpPr>
-        <p:spPr/>
-        <p:txBody>
-          <a:bodyPr/>
-          <a:lstStyle/>
-          <a:p>
-            <a:r>
-              <a:rPr lang="en-US"/>
+            <p:ph type="ftr" sz="quarter" idx="12"/>
+          </p:nvPr>
+        </p:nvSpPr>
+        <p:spPr/>
+        <p:txBody>
+          <a:bodyPr/>
+          <a:lstStyle/>
+          <a:p>
+            <a:r>
+              <a:rPr lang="en-US" dirty="0"/>
               <a:t>raysmith@alum.mit.edu</a:t>
             </a:r>
-            <a:endParaRPr lang="en-US" dirty="0"/>
           </a:p>
         </p:txBody>
       </p:sp>
@@ -1764,7 +1721,7 @@
             <a:spLocks noGrp="1"/>
           </p:cNvSpPr>
           <p:nvPr>
-            <p:ph type="sldNum" sz="quarter" idx="5"/>
+            <p:ph type="sldNum" sz="quarter" idx="13"/>
           </p:nvPr>
         </p:nvSpPr>
         <p:spPr/>
@@ -1774,165 +1731,7 @@
           <a:p>
             <a:fld id="{BA791329-992B-4F83-8435-C33B0EC26DB3}" type="slidenum">
               <a:rPr lang="en-US" smtClean="0"/>
-              <a:t>22</a:t>
-            </a:fld>
-            <a:endParaRPr lang="en-US" dirty="0"/>
-          </a:p>
-        </p:txBody>
-      </p:sp>
-    </p:spTree>
-    <p:extLst>
-      <p:ext uri="{BB962C8B-B14F-4D97-AF65-F5344CB8AC3E}">
-        <p14:creationId xmlns:p14="http://schemas.microsoft.com/office/powerpoint/2010/main" val="3083072296"/>
-      </p:ext>
-    </p:extLst>
-  </p:cSld>
-  <p:clrMapOvr>
-    <a:masterClrMapping/>
-  </p:clrMapOvr>
-</p:notes>
-</file>
-
-<file path=ppt/notesSlides/notesSlide15.xml><?xml version="1.0" encoding="utf-8"?>
-<p:notes xmlns:a="http://schemas.openxmlformats.org/drawingml/2006/main" xmlns:r="http://schemas.openxmlformats.org/officeDocument/2006/relationships" xmlns:p="http://schemas.openxmlformats.org/presentationml/2006/main">
-  <p:cSld>
-    <p:spTree>
-      <p:nvGrpSpPr>
-        <p:cNvPr id="1" name=""/>
-        <p:cNvGrpSpPr/>
-        <p:nvPr/>
-      </p:nvGrpSpPr>
-      <p:grpSpPr>
-        <a:xfrm>
-          <a:off x="0" y="0"/>
-          <a:ext cx="0" cy="0"/>
-          <a:chOff x="0" y="0"/>
-          <a:chExt cx="0" cy="0"/>
-        </a:xfrm>
-      </p:grpSpPr>
-      <p:sp>
-        <p:nvSpPr>
-          <p:cNvPr id="2" name="Slide Image Placeholder 1"/>
-          <p:cNvSpPr>
-            <a:spLocks noGrp="1" noRot="1" noChangeAspect="1"/>
-          </p:cNvSpPr>
-          <p:nvPr>
-            <p:ph type="sldImg"/>
-          </p:nvPr>
-        </p:nvSpPr>
-        <p:spPr/>
-        <p:txBody>
-          <a:bodyPr/>
-          <a:lstStyle/>
-          <a:p>
-            <a:endParaRPr lang="en-US"/>
-          </a:p>
-        </p:txBody>
-      </p:sp>
-      <p:sp>
-        <p:nvSpPr>
-          <p:cNvPr id="3" name="Notes Placeholder 2"/>
-          <p:cNvSpPr>
-            <a:spLocks noGrp="1"/>
-          </p:cNvSpPr>
-          <p:nvPr>
-            <p:ph type="body" idx="1"/>
-          </p:nvPr>
-        </p:nvSpPr>
-        <p:spPr/>
-        <p:txBody>
-          <a:bodyPr/>
-          <a:lstStyle/>
-          <a:p>
-            <a:endParaRPr lang="en-US" dirty="0"/>
-          </a:p>
-        </p:txBody>
-      </p:sp>
-      <p:sp>
-        <p:nvSpPr>
-          <p:cNvPr id="4" name="Header Placeholder 3"/>
-          <p:cNvSpPr>
-            <a:spLocks noGrp="1"/>
-          </p:cNvSpPr>
-          <p:nvPr>
-            <p:ph type="hdr" sz="quarter" idx="10"/>
-          </p:nvPr>
-        </p:nvSpPr>
-        <p:spPr/>
-        <p:txBody>
-          <a:bodyPr/>
-          <a:lstStyle/>
-          <a:p>
-            <a:r>
-              <a:rPr lang="en-US" dirty="0"/>
-              <a:t>Introduction to Programming using Python</a:t>
-            </a:r>
-          </a:p>
-        </p:txBody>
-      </p:sp>
-      <p:sp>
-        <p:nvSpPr>
-          <p:cNvPr id="5" name="Date Placeholder 4"/>
-          <p:cNvSpPr>
-            <a:spLocks noGrp="1"/>
-          </p:cNvSpPr>
-          <p:nvPr>
-            <p:ph type="dt" idx="11"/>
-          </p:nvPr>
-        </p:nvSpPr>
-        <p:spPr/>
-        <p:txBody>
-          <a:bodyPr/>
-          <a:lstStyle/>
-          <a:p>
-            <a:fld id="{81E0ADA2-1B64-45DB-B2E6-F6A11AB7EB98}" type="datetime1">
-              <a:rPr lang="en-US" smtClean="0"/>
-              <a:t>7/24/2026</a:t>
-            </a:fld>
-            <a:endParaRPr lang="en-US" dirty="0"/>
-          </a:p>
-        </p:txBody>
-      </p:sp>
-      <p:sp>
-        <p:nvSpPr>
-          <p:cNvPr id="6" name="Footer Placeholder 5"/>
-          <p:cNvSpPr>
-            <a:spLocks noGrp="1"/>
-          </p:cNvSpPr>
-          <p:nvPr>
-            <p:ph type="ftr" sz="quarter" idx="12"/>
-          </p:nvPr>
-        </p:nvSpPr>
-        <p:spPr/>
-        <p:txBody>
-          <a:bodyPr/>
-          <a:lstStyle/>
-          <a:p>
-            <a:r>
-              <a:rPr lang="en-US" dirty="0"/>
-              <a:t>raysmith@alum.mit.edu</a:t>
-            </a:r>
-          </a:p>
-        </p:txBody>
-      </p:sp>
-      <p:sp>
-        <p:nvSpPr>
-          <p:cNvPr id="7" name="Slide Number Placeholder 6"/>
-          <p:cNvSpPr>
-            <a:spLocks noGrp="1"/>
-          </p:cNvSpPr>
-          <p:nvPr>
-            <p:ph type="sldNum" sz="quarter" idx="13"/>
-          </p:nvPr>
-        </p:nvSpPr>
-        <p:spPr/>
-        <p:txBody>
-          <a:bodyPr/>
-          <a:lstStyle/>
-          <a:p>
-            <a:fld id="{BA791329-992B-4F83-8435-C33B0EC26DB3}" type="slidenum">
-              <a:rPr lang="en-US" smtClean="0"/>
-              <a:t>27</a:t>
+              <a:t>26</a:t>
             </a:fld>
             <a:endParaRPr lang="en-US" dirty="0"/>
           </a:p>
@@ -2045,7 +1844,7 @@
           <a:p>
             <a:fld id="{E734D050-5128-424E-B0C7-5BFB4917C3AB}" type="datetime1">
               <a:rPr lang="en-US" smtClean="0"/>
-              <a:t>7/24/2026</a:t>
+              <a:t>7/27/2026</a:t>
             </a:fld>
             <a:endParaRPr lang="en-US" dirty="0"/>
           </a:p>
@@ -2233,7 +2032,7 @@
           <a:p>
             <a:fld id="{E734D050-5128-424E-B0C7-5BFB4917C3AB}" type="datetime1">
               <a:rPr lang="en-US" smtClean="0"/>
-              <a:t>7/24/2026</a:t>
+              <a:t>7/27/2026</a:t>
             </a:fld>
             <a:endParaRPr lang="en-US" dirty="0"/>
           </a:p>
@@ -2436,7 +2235,7 @@
           <a:p>
             <a:fld id="{E734D050-5128-424E-B0C7-5BFB4917C3AB}" type="datetime1">
               <a:rPr lang="en-US" smtClean="0"/>
-              <a:t>7/24/2026</a:t>
+              <a:t>7/27/2026</a:t>
             </a:fld>
             <a:endParaRPr lang="en-US" dirty="0"/>
           </a:p>
@@ -2639,7 +2438,7 @@
           <a:p>
             <a:fld id="{E734D050-5128-424E-B0C7-5BFB4917C3AB}" type="datetime1">
               <a:rPr lang="en-US" smtClean="0"/>
-              <a:t>7/24/2026</a:t>
+              <a:t>7/27/2026</a:t>
             </a:fld>
             <a:endParaRPr lang="en-US" dirty="0"/>
           </a:p>
@@ -2839,7 +2638,7 @@
           <a:p>
             <a:fld id="{E734D050-5128-424E-B0C7-5BFB4917C3AB}" type="datetime1">
               <a:rPr lang="en-US" smtClean="0"/>
-              <a:t>7/24/2026</a:t>
+              <a:t>7/27/2026</a:t>
             </a:fld>
             <a:endParaRPr lang="en-US" dirty="0"/>
           </a:p>
@@ -3039,7 +2838,7 @@
           <a:p>
             <a:fld id="{E734D050-5128-424E-B0C7-5BFB4917C3AB}" type="datetime1">
               <a:rPr lang="en-US" smtClean="0"/>
-              <a:t>7/24/2026</a:t>
+              <a:t>7/27/2026</a:t>
             </a:fld>
             <a:endParaRPr lang="en-US" dirty="0"/>
           </a:p>
@@ -3239,7 +3038,7 @@
           <a:p>
             <a:fld id="{E734D050-5128-424E-B0C7-5BFB4917C3AB}" type="datetime1">
               <a:rPr lang="en-US" smtClean="0"/>
-              <a:t>7/24/2026</a:t>
+              <a:t>7/27/2026</a:t>
             </a:fld>
             <a:endParaRPr lang="en-US" dirty="0"/>
           </a:p>
@@ -3323,7 +3122,7 @@
         <p:cNvPr id="1" name="">
           <a:extLst>
             <a:ext uri="{FF2B5EF4-FFF2-40B4-BE49-F238E27FC236}">
-              <a16:creationId xmlns:a16="http://schemas.microsoft.com/office/drawing/2014/main" id="{6B5B35C7-6873-B3ED-14FF-A811251539A3}"/>
+              <a16:creationId xmlns:a16="http://schemas.microsoft.com/office/drawing/2014/main" id="{A3B580B5-1130-1A94-C82A-CF4D68A02B51}"/>
             </a:ext>
           </a:extLst>
         </p:cNvPr>
@@ -3343,7 +3142,7 @@
           <p:cNvPr id="2" name="Slide Image Placeholder 1">
             <a:extLst>
               <a:ext uri="{FF2B5EF4-FFF2-40B4-BE49-F238E27FC236}">
-                <a16:creationId xmlns:a16="http://schemas.microsoft.com/office/drawing/2014/main" id="{829B5CA5-5956-A867-ED5B-C7F8834FD5FD}"/>
+                <a16:creationId xmlns:a16="http://schemas.microsoft.com/office/drawing/2014/main" id="{12CFE8CC-EC09-7070-44E6-14742E1E3A35}"/>
               </a:ext>
             </a:extLst>
           </p:cNvPr>
@@ -3368,7 +3167,7 @@
           <p:cNvPr id="3" name="Notes Placeholder 2">
             <a:extLst>
               <a:ext uri="{FF2B5EF4-FFF2-40B4-BE49-F238E27FC236}">
-                <a16:creationId xmlns:a16="http://schemas.microsoft.com/office/drawing/2014/main" id="{B0D029C1-6A53-AE6C-3E59-CB7F71EBED01}"/>
+                <a16:creationId xmlns:a16="http://schemas.microsoft.com/office/drawing/2014/main" id="{A2CD631D-D45C-EE14-4945-5E4DBC7F1C92}"/>
               </a:ext>
             </a:extLst>
           </p:cNvPr>
@@ -3393,7 +3192,7 @@
           <p:cNvPr id="4" name="Header Placeholder 3">
             <a:extLst>
               <a:ext uri="{FF2B5EF4-FFF2-40B4-BE49-F238E27FC236}">
-                <a16:creationId xmlns:a16="http://schemas.microsoft.com/office/drawing/2014/main" id="{790A9648-D9C8-D0CB-9AFD-4DDBFD492C6F}"/>
+                <a16:creationId xmlns:a16="http://schemas.microsoft.com/office/drawing/2014/main" id="{880C9714-390E-3673-5DF9-E358208C5346}"/>
               </a:ext>
             </a:extLst>
           </p:cNvPr>
@@ -3421,7 +3220,7 @@
           <p:cNvPr id="5" name="Date Placeholder 4">
             <a:extLst>
               <a:ext uri="{FF2B5EF4-FFF2-40B4-BE49-F238E27FC236}">
-                <a16:creationId xmlns:a16="http://schemas.microsoft.com/office/drawing/2014/main" id="{7EBD5CC2-95FE-92FD-2DEF-B184AE7E58EE}"/>
+                <a16:creationId xmlns:a16="http://schemas.microsoft.com/office/drawing/2014/main" id="{C464B549-604F-0CFC-F8FB-E8FD718BBC8A}"/>
               </a:ext>
             </a:extLst>
           </p:cNvPr>
@@ -3439,7 +3238,7 @@
           <a:p>
             <a:fld id="{E734D050-5128-424E-B0C7-5BFB4917C3AB}" type="datetime1">
               <a:rPr lang="en-US" smtClean="0"/>
-              <a:t>7/24/2026</a:t>
+              <a:t>7/27/2026</a:t>
             </a:fld>
             <a:endParaRPr lang="en-US" dirty="0"/>
           </a:p>
@@ -3450,7 +3249,7 @@
           <p:cNvPr id="6" name="Footer Placeholder 5">
             <a:extLst>
               <a:ext uri="{FF2B5EF4-FFF2-40B4-BE49-F238E27FC236}">
-                <a16:creationId xmlns:a16="http://schemas.microsoft.com/office/drawing/2014/main" id="{CA6D6290-089D-0C17-6D11-522848E8A639}"/>
+                <a16:creationId xmlns:a16="http://schemas.microsoft.com/office/drawing/2014/main" id="{7A05C178-319C-915C-97BF-85E4BCF314B0}"/>
               </a:ext>
             </a:extLst>
           </p:cNvPr>
@@ -3478,7 +3277,7 @@
           <p:cNvPr id="7" name="Slide Number Placeholder 6">
             <a:extLst>
               <a:ext uri="{FF2B5EF4-FFF2-40B4-BE49-F238E27FC236}">
-                <a16:creationId xmlns:a16="http://schemas.microsoft.com/office/drawing/2014/main" id="{88020CAC-391F-29CE-BCB4-1F9FB80BA123}"/>
+                <a16:creationId xmlns:a16="http://schemas.microsoft.com/office/drawing/2014/main" id="{7A468222-0813-7B0C-EDD5-117C7FA26AB1}"/>
               </a:ext>
             </a:extLst>
           </p:cNvPr>
@@ -3505,7 +3304,7 @@
     </p:spTree>
     <p:extLst>
       <p:ext uri="{BB962C8B-B14F-4D97-AF65-F5344CB8AC3E}">
-        <p14:creationId xmlns:p14="http://schemas.microsoft.com/office/powerpoint/2010/main" val="1083284795"/>
+        <p14:creationId xmlns:p14="http://schemas.microsoft.com/office/powerpoint/2010/main" val="535673981"/>
       </p:ext>
     </p:extLst>
   </p:cSld>
@@ -4293,7 +4092,7 @@
           <a:p>
             <a:fld id="{5110D8A6-D61F-4DCA-82DB-6A888A9B2487}" type="datetime1">
               <a:rPr lang="en-US" smtClean="0"/>
-              <a:t>7/24/2026</a:t>
+              <a:t>7/27/2026</a:t>
             </a:fld>
             <a:endParaRPr lang="en-US" dirty="0"/>
           </a:p>
@@ -4560,7 +4359,7 @@
           <a:p>
             <a:fld id="{62C5B04C-660C-4601-8C32-DAC504F51286}" type="datetime1">
               <a:rPr lang="en-US" smtClean="0"/>
-              <a:t>7/24/2026</a:t>
+              <a:t>7/27/2026</a:t>
             </a:fld>
             <a:endParaRPr lang="en-US" dirty="0"/>
           </a:p>
@@ -4879,7 +4678,7 @@
           <a:p>
             <a:fld id="{28495457-F83B-45BB-B822-2DF2A1FD0C27}" type="datetime1">
               <a:rPr lang="en-US" smtClean="0"/>
-              <a:t>7/24/2026</a:t>
+              <a:t>7/27/2026</a:t>
             </a:fld>
             <a:endParaRPr lang="en-US" dirty="0"/>
           </a:p>
@@ -5225,7 +5024,7 @@
           <a:p>
             <a:fld id="{AF75F462-1497-413B-A43E-E69E6D8E4BEF}" type="datetime1">
               <a:rPr lang="en-US" smtClean="0"/>
-              <a:t>7/24/2026</a:t>
+              <a:t>7/27/2026</a:t>
             </a:fld>
             <a:endParaRPr lang="en-US" dirty="0"/>
           </a:p>
@@ -5544,7 +5343,7 @@
           <a:p>
             <a:fld id="{F552C08A-409D-4E56-98A3-A36D8B5C9F4C}" type="datetime1">
               <a:rPr lang="en-US" smtClean="0"/>
-              <a:t>7/24/2026</a:t>
+              <a:t>7/27/2026</a:t>
             </a:fld>
             <a:endParaRPr lang="en-US" dirty="0"/>
           </a:p>
@@ -5942,7 +5741,7 @@
           <a:p>
             <a:fld id="{8469E2CF-C14A-49FB-8201-FEEF3BF16570}" type="datetime1">
               <a:rPr lang="en-US" smtClean="0"/>
-              <a:t>7/24/2026</a:t>
+              <a:t>7/27/2026</a:t>
             </a:fld>
             <a:endParaRPr lang="en-US" dirty="0"/>
           </a:p>
@@ -6117,7 +5916,7 @@
           <a:p>
             <a:fld id="{B4FD04B1-0384-44B0-8537-B8F12FD50EF8}" type="datetime1">
               <a:rPr lang="en-US" smtClean="0"/>
-              <a:t>7/24/2026</a:t>
+              <a:t>7/27/2026</a:t>
             </a:fld>
             <a:endParaRPr lang="en-US" dirty="0"/>
           </a:p>
@@ -6301,7 +6100,7 @@
           <a:p>
             <a:fld id="{DC5F4745-C362-4373-8D92-8EF41093E018}" type="datetime1">
               <a:rPr lang="en-US" smtClean="0"/>
-              <a:t>7/24/2026</a:t>
+              <a:t>7/27/2026</a:t>
             </a:fld>
             <a:endParaRPr lang="en-US" dirty="0"/>
           </a:p>
@@ -6481,7 +6280,7 @@
           <a:p>
             <a:fld id="{6F8407F0-4949-4EDC-A592-6ECEEFF5A038}" type="datetime1">
               <a:rPr lang="en-US" smtClean="0"/>
-              <a:t>7/24/2026</a:t>
+              <a:t>7/27/2026</a:t>
             </a:fld>
             <a:endParaRPr lang="en-US" dirty="0"/>
           </a:p>
@@ -6732,7 +6531,7 @@
           <a:p>
             <a:fld id="{298A7F69-C248-41A3-8602-E8D54188EDB0}" type="datetime1">
               <a:rPr lang="en-US" smtClean="0"/>
-              <a:t>7/24/2026</a:t>
+              <a:t>7/27/2026</a:t>
             </a:fld>
             <a:endParaRPr lang="en-US" dirty="0"/>
           </a:p>
@@ -6968,7 +6767,7 @@
           <a:p>
             <a:fld id="{1F20B086-39C4-4128-985B-FB07F33D3CF3}" type="datetime1">
               <a:rPr lang="en-US" smtClean="0"/>
-              <a:t>7/24/2026</a:t>
+              <a:t>7/27/2026</a:t>
             </a:fld>
             <a:endParaRPr lang="en-US" dirty="0"/>
           </a:p>
@@ -7346,7 +7145,7 @@
           <a:p>
             <a:fld id="{2A2ADCF5-0A36-4D40-B549-3F06F2B68F47}" type="datetime1">
               <a:rPr lang="en-US" smtClean="0"/>
-              <a:t>7/24/2026</a:t>
+              <a:t>7/27/2026</a:t>
             </a:fld>
             <a:endParaRPr lang="en-US" dirty="0"/>
           </a:p>
@@ -7473,7 +7272,7 @@
           <a:p>
             <a:fld id="{7D89728E-A64F-4CB2-A929-EC8F77743E5A}" type="datetime1">
               <a:rPr lang="en-US" smtClean="0"/>
-              <a:t>7/24/2026</a:t>
+              <a:t>7/27/2026</a:t>
             </a:fld>
             <a:endParaRPr lang="en-US" dirty="0"/>
           </a:p>
@@ -7572,7 +7371,7 @@
           <a:p>
             <a:fld id="{F1811B85-6381-4843-915E-A80D8CF566B9}" type="datetime1">
               <a:rPr lang="en-US" smtClean="0"/>
-              <a:t>7/24/2026</a:t>
+              <a:t>7/27/2026</a:t>
             </a:fld>
             <a:endParaRPr lang="en-US" dirty="0"/>
           </a:p>
@@ -7831,7 +7630,7 @@
           <a:p>
             <a:fld id="{038FA659-E42E-4DAC-9069-4C6BD9C68659}" type="datetime1">
               <a:rPr lang="en-US" smtClean="0"/>
-              <a:t>7/24/2026</a:t>
+              <a:t>7/27/2026</a:t>
             </a:fld>
             <a:endParaRPr lang="en-US" dirty="0"/>
           </a:p>
@@ -8097,7 +7896,7 @@
           <a:p>
             <a:fld id="{E08F6933-E9E6-4227-B3A4-00207D316420}" type="datetime1">
               <a:rPr lang="en-US" smtClean="0"/>
-              <a:t>7/24/2026</a:t>
+              <a:t>7/27/2026</a:t>
             </a:fld>
             <a:endParaRPr lang="en-US" dirty="0"/>
           </a:p>
@@ -8900,7 +8699,7 @@
           <a:p>
             <a:fld id="{A0393A93-C82D-47F0-A099-2DE871639089}" type="datetime1">
               <a:rPr lang="en-US" smtClean="0"/>
-              <a:t>7/24/2026</a:t>
+              <a:t>7/27/2026</a:t>
             </a:fld>
             <a:endParaRPr lang="en-US" dirty="0"/>
           </a:p>
@@ -9490,7 +9289,7 @@
           <a:p>
             <a:fld id="{AC2EE02F-DFA0-4A0E-B523-2B95372C2781}" type="datetime1">
               <a:rPr lang="en-US" smtClean="0"/>
-              <a:t>7/24/2026</a:t>
+              <a:t>7/27/2026</a:t>
             </a:fld>
             <a:endParaRPr lang="en-US" dirty="0"/>
           </a:p>
@@ -9665,7 +9464,7 @@
           <a:p>
             <a:r>
               <a:rPr lang="en-US" sz="4000" dirty="0"/>
-              <a:t>Game display – move, unmove</a:t>
+              <a:t>Game display – move, unmove, Go To Move</a:t>
             </a:r>
           </a:p>
           <a:p>
@@ -9717,7 +9516,7 @@
           <a:p>
             <a:fld id="{771FCE44-14AA-407B-9781-80C2DD8F374A}" type="datetime1">
               <a:rPr lang="en-US" smtClean="0"/>
-              <a:t>7/24/2026</a:t>
+              <a:t>7/27/2026</a:t>
             </a:fld>
             <a:endParaRPr lang="en-US" dirty="0"/>
           </a:p>
@@ -9927,7 +9726,7 @@
           <a:p>
             <a:fld id="{771FCE44-14AA-407B-9781-80C2DD8F374A}" type="datetime1">
               <a:rPr lang="en-US" smtClean="0"/>
-              <a:t>7/24/2026</a:t>
+              <a:t>7/27/2026</a:t>
             </a:fld>
             <a:endParaRPr lang="en-US" dirty="0"/>
           </a:p>
@@ -10223,7 +10022,7 @@
           <a:p>
             <a:fld id="{771FCE44-14AA-407B-9781-80C2DD8F374A}" type="datetime1">
               <a:rPr lang="en-US" smtClean="0"/>
-              <a:t>7/24/2026</a:t>
+              <a:t>7/27/2026</a:t>
             </a:fld>
             <a:endParaRPr lang="en-US" dirty="0"/>
           </a:p>
@@ -10320,7 +10119,7 @@
         <p:cNvPr id="1" name="">
           <a:extLst>
             <a:ext uri="{FF2B5EF4-FFF2-40B4-BE49-F238E27FC236}">
-              <a16:creationId xmlns:a16="http://schemas.microsoft.com/office/drawing/2014/main" id="{EAD97715-6AF9-EB12-7F23-D78B7E90C7A6}"/>
+              <a16:creationId xmlns:a16="http://schemas.microsoft.com/office/drawing/2014/main" id="{89F714EA-492F-C973-D890-69F069F79AC4}"/>
             </a:ext>
           </a:extLst>
         </p:cNvPr>
@@ -10340,7 +10139,7 @@
           <p:cNvPr id="2" name="Title 1">
             <a:extLst>
               <a:ext uri="{FF2B5EF4-FFF2-40B4-BE49-F238E27FC236}">
-                <a16:creationId xmlns:a16="http://schemas.microsoft.com/office/drawing/2014/main" id="{C5389F50-8F9C-1391-D64F-E4A2F50D5CEF}"/>
+                <a16:creationId xmlns:a16="http://schemas.microsoft.com/office/drawing/2014/main" id="{3C060E87-8A23-017C-86BC-91DD44813D18}"/>
               </a:ext>
             </a:extLst>
           </p:cNvPr>
@@ -10353,16 +10152,14 @@
         </p:nvSpPr>
         <p:spPr/>
         <p:txBody>
-          <a:bodyPr/>
-          <a:lstStyle/>
-          <a:p>
-            <a:r>
-              <a:rPr lang="en-US" dirty="0"/>
-              <a:t>Chess Move Notation </a:t>
-            </a:r>
-            <a:r>
-              <a:rPr lang="en-US" sz="2400" dirty="0"/>
-              <a:t>- continued</a:t>
+          <a:bodyPr>
+            <a:normAutofit/>
+          </a:bodyPr>
+          <a:lstStyle/>
+          <a:p>
+            <a:r>
+              <a:rPr lang="en-US" sz="4000" dirty="0"/>
+              <a:t>Chess Interpretation Challenges</a:t>
             </a:r>
           </a:p>
         </p:txBody>
@@ -10372,7 +10169,7 @@
           <p:cNvPr id="3" name="Content Placeholder 2">
             <a:extLst>
               <a:ext uri="{FF2B5EF4-FFF2-40B4-BE49-F238E27FC236}">
-                <a16:creationId xmlns:a16="http://schemas.microsoft.com/office/drawing/2014/main" id="{0B9D5F06-BC8E-C1FD-0B5A-211032AB9A70}"/>
+                <a16:creationId xmlns:a16="http://schemas.microsoft.com/office/drawing/2014/main" id="{8D8F0356-FE6A-C114-7379-E40A723B88F5}"/>
               </a:ext>
             </a:extLst>
           </p:cNvPr>
@@ -10396,24 +10193,40 @@
           <a:lstStyle/>
           <a:p>
             <a:r>
-              <a:rPr lang="en-US" sz="4000" dirty="0"/>
-              <a:t>Piece must be unambiguous</a:t>
-            </a:r>
-          </a:p>
-          <a:p>
-            <a:r>
-              <a:rPr lang="en-US" sz="4000" dirty="0"/>
-              <a:t>Ambiguity solved by modifiers</a:t>
-            </a:r>
-          </a:p>
-          <a:p>
-            <a:pPr marL="457200" lvl="1" indent="0">
+              <a:rPr lang="en-US" sz="3800" dirty="0"/>
+              <a:t>Notation Parsing </a:t>
+            </a:r>
+          </a:p>
+          <a:p>
+            <a:pPr lvl="1"/>
+            <a:r>
+              <a:rPr lang="en-US" sz="3600" dirty="0"/>
+              <a:t>Movement spec -&gt; piece + destination</a:t>
+            </a:r>
+          </a:p>
+          <a:p>
+            <a:r>
+              <a:rPr lang="en-US" sz="3800" dirty="0"/>
+              <a:t>	Locate piece(s)</a:t>
+            </a:r>
+          </a:p>
+          <a:p>
+            <a:r>
+              <a:rPr lang="en-US" sz="3800" dirty="0"/>
+              <a:t>Resolve ambiguities</a:t>
+            </a:r>
+          </a:p>
+          <a:p>
+            <a:r>
+              <a:rPr lang="en-US" sz="3800" dirty="0"/>
+              <a:t>Recognize invalid moves</a:t>
+            </a:r>
+          </a:p>
+          <a:p>
+            <a:pPr marL="0" indent="0">
               <a:buNone/>
             </a:pPr>
-            <a:r>
-              <a:rPr lang="en-US" sz="3800" dirty="0"/>
-              <a:t>16… Rfe8+  Black’s 16 move - Rook on the f-file to square e8 with check (Not the black rook on the a-file) </a:t>
-            </a:r>
+            <a:endParaRPr lang="en-US" sz="3800" dirty="0"/>
           </a:p>
         </p:txBody>
       </p:sp>
@@ -10422,7 +10235,7 @@
           <p:cNvPr id="4" name="Date Placeholder 3">
             <a:extLst>
               <a:ext uri="{FF2B5EF4-FFF2-40B4-BE49-F238E27FC236}">
-                <a16:creationId xmlns:a16="http://schemas.microsoft.com/office/drawing/2014/main" id="{86434649-10D2-3A1B-A53E-0231768AE498}"/>
+                <a16:creationId xmlns:a16="http://schemas.microsoft.com/office/drawing/2014/main" id="{F0287082-D6DF-BC74-215C-536A19BB74EE}"/>
               </a:ext>
             </a:extLst>
           </p:cNvPr>
@@ -10440,7 +10253,7 @@
           <a:p>
             <a:fld id="{771FCE44-14AA-407B-9781-80C2DD8F374A}" type="datetime1">
               <a:rPr lang="en-US" smtClean="0"/>
-              <a:t>7/24/2026</a:t>
+              <a:t>7/27/2026</a:t>
             </a:fld>
             <a:endParaRPr lang="en-US" dirty="0"/>
           </a:p>
@@ -10451,7 +10264,7 @@
           <p:cNvPr id="6" name="Slide Number Placeholder 5">
             <a:extLst>
               <a:ext uri="{FF2B5EF4-FFF2-40B4-BE49-F238E27FC236}">
-                <a16:creationId xmlns:a16="http://schemas.microsoft.com/office/drawing/2014/main" id="{11B8E895-DF8D-9DF3-7D3F-027551577964}"/>
+                <a16:creationId xmlns:a16="http://schemas.microsoft.com/office/drawing/2014/main" id="{195EC657-53F4-40C8-94D3-9C11C4018D1C}"/>
               </a:ext>
             </a:extLst>
           </p:cNvPr>
@@ -10480,7 +10293,7 @@
           <p:cNvPr id="7" name="Footer Placeholder 6">
             <a:extLst>
               <a:ext uri="{FF2B5EF4-FFF2-40B4-BE49-F238E27FC236}">
-                <a16:creationId xmlns:a16="http://schemas.microsoft.com/office/drawing/2014/main" id="{7AC443B9-3947-4B87-6ABC-18C425AB52D3}"/>
+                <a16:creationId xmlns:a16="http://schemas.microsoft.com/office/drawing/2014/main" id="{84EB9F04-AFA4-B663-F5B3-B79DD3A24891}"/>
               </a:ext>
             </a:extLst>
           </p:cNvPr>
@@ -10507,7 +10320,7 @@
     </p:spTree>
     <p:extLst>
       <p:ext uri="{BB962C8B-B14F-4D97-AF65-F5344CB8AC3E}">
-        <p14:creationId xmlns:p14="http://schemas.microsoft.com/office/powerpoint/2010/main" val="157590700"/>
+        <p14:creationId xmlns:p14="http://schemas.microsoft.com/office/powerpoint/2010/main" val="3393000821"/>
       </p:ext>
     </p:extLst>
   </p:cSld>
@@ -10537,7 +10350,7 @@
         <p:cNvPr id="1" name="">
           <a:extLst>
             <a:ext uri="{FF2B5EF4-FFF2-40B4-BE49-F238E27FC236}">
-              <a16:creationId xmlns:a16="http://schemas.microsoft.com/office/drawing/2014/main" id="{89F714EA-492F-C973-D890-69F069F79AC4}"/>
+              <a16:creationId xmlns:a16="http://schemas.microsoft.com/office/drawing/2014/main" id="{2296FA7B-6556-9641-CE0C-8FB041997617}"/>
             </a:ext>
           </a:extLst>
         </p:cNvPr>
@@ -10557,7 +10370,7 @@
           <p:cNvPr id="2" name="Title 1">
             <a:extLst>
               <a:ext uri="{FF2B5EF4-FFF2-40B4-BE49-F238E27FC236}">
-                <a16:creationId xmlns:a16="http://schemas.microsoft.com/office/drawing/2014/main" id="{3C060E87-8A23-017C-86BC-91DD44813D18}"/>
+                <a16:creationId xmlns:a16="http://schemas.microsoft.com/office/drawing/2014/main" id="{149F6FB5-22F3-02AC-F03F-7D113C8D5C2B}"/>
               </a:ext>
             </a:extLst>
           </p:cNvPr>
@@ -10568,7 +10381,12 @@
             <p:ph type="title"/>
           </p:nvPr>
         </p:nvSpPr>
-        <p:spPr/>
+        <p:spPr>
+          <a:xfrm>
+            <a:off x="677333" y="609600"/>
+            <a:ext cx="9049991" cy="1320800"/>
+          </a:xfrm>
+        </p:spPr>
         <p:txBody>
           <a:bodyPr>
             <a:normAutofit/>
@@ -10577,7 +10395,7 @@
           <a:p>
             <a:r>
               <a:rPr lang="en-US" sz="4000" dirty="0"/>
-              <a:t>Chess Interpretation Challenges</a:t>
+              <a:t>Chess Move Notation – Example: 1. Nf3</a:t>
             </a:r>
           </a:p>
         </p:txBody>
@@ -10587,7 +10405,7 @@
           <p:cNvPr id="3" name="Content Placeholder 2">
             <a:extLst>
               <a:ext uri="{FF2B5EF4-FFF2-40B4-BE49-F238E27FC236}">
-                <a16:creationId xmlns:a16="http://schemas.microsoft.com/office/drawing/2014/main" id="{8D8F0356-FE6A-C114-7379-E40A723B88F5}"/>
+                <a16:creationId xmlns:a16="http://schemas.microsoft.com/office/drawing/2014/main" id="{16DF6F65-5BA1-8BD8-C2C8-009B545DC94F}"/>
               </a:ext>
             </a:extLst>
           </p:cNvPr>
@@ -10612,32 +10430,13 @@
           <a:p>
             <a:r>
               <a:rPr lang="en-US" sz="3800" dirty="0"/>
-              <a:t>Notation Parsing </a:t>
-            </a:r>
-          </a:p>
-          <a:p>
-            <a:pPr lvl="1"/>
-            <a:r>
-              <a:rPr lang="en-US" sz="3600" dirty="0"/>
-              <a:t>Movement spec -&gt; piece + destination</a:t>
+              <a:t>Parse 1. Nf3 into white knight moving to square f3</a:t>
             </a:r>
           </a:p>
           <a:p>
             <a:r>
               <a:rPr lang="en-US" sz="3800" dirty="0"/>
-              <a:t>	Locate piece(s)</a:t>
-            </a:r>
-          </a:p>
-          <a:p>
-            <a:r>
-              <a:rPr lang="en-US" sz="3800" dirty="0"/>
-              <a:t>Resolve ambiguities</a:t>
-            </a:r>
-          </a:p>
-          <a:p>
-            <a:r>
-              <a:rPr lang="en-US" sz="3800" dirty="0"/>
-              <a:t>Recognize invalid moves</a:t>
+              <a:t>Determine white knight (at g1) is the one and  only white knight that can move to f3</a:t>
             </a:r>
           </a:p>
           <a:p>
@@ -10653,7 +10452,7 @@
           <p:cNvPr id="4" name="Date Placeholder 3">
             <a:extLst>
               <a:ext uri="{FF2B5EF4-FFF2-40B4-BE49-F238E27FC236}">
-                <a16:creationId xmlns:a16="http://schemas.microsoft.com/office/drawing/2014/main" id="{F0287082-D6DF-BC74-215C-536A19BB74EE}"/>
+                <a16:creationId xmlns:a16="http://schemas.microsoft.com/office/drawing/2014/main" id="{478BA7F9-F106-D735-3A09-8D9CB6A98F6D}"/>
               </a:ext>
             </a:extLst>
           </p:cNvPr>
@@ -10671,7 +10470,7 @@
           <a:p>
             <a:fld id="{771FCE44-14AA-407B-9781-80C2DD8F374A}" type="datetime1">
               <a:rPr lang="en-US" smtClean="0"/>
-              <a:t>7/24/2026</a:t>
+              <a:t>7/27/2026</a:t>
             </a:fld>
             <a:endParaRPr lang="en-US" dirty="0"/>
           </a:p>
@@ -10682,7 +10481,7 @@
           <p:cNvPr id="6" name="Slide Number Placeholder 5">
             <a:extLst>
               <a:ext uri="{FF2B5EF4-FFF2-40B4-BE49-F238E27FC236}">
-                <a16:creationId xmlns:a16="http://schemas.microsoft.com/office/drawing/2014/main" id="{195EC657-53F4-40C8-94D3-9C11C4018D1C}"/>
+                <a16:creationId xmlns:a16="http://schemas.microsoft.com/office/drawing/2014/main" id="{D01AFB29-A179-E1C8-A86F-BFC0B540F8F5}"/>
               </a:ext>
             </a:extLst>
           </p:cNvPr>
@@ -10711,7 +10510,7 @@
           <p:cNvPr id="7" name="Footer Placeholder 6">
             <a:extLst>
               <a:ext uri="{FF2B5EF4-FFF2-40B4-BE49-F238E27FC236}">
-                <a16:creationId xmlns:a16="http://schemas.microsoft.com/office/drawing/2014/main" id="{84EB9F04-AFA4-B663-F5B3-B79DD3A24891}"/>
+                <a16:creationId xmlns:a16="http://schemas.microsoft.com/office/drawing/2014/main" id="{C00D770E-4F7D-21C8-8862-1F39E2287DEE}"/>
               </a:ext>
             </a:extLst>
           </p:cNvPr>
@@ -10738,7 +10537,7 @@
     </p:spTree>
     <p:extLst>
       <p:ext uri="{BB962C8B-B14F-4D97-AF65-F5344CB8AC3E}">
-        <p14:creationId xmlns:p14="http://schemas.microsoft.com/office/powerpoint/2010/main" val="3393000821"/>
+        <p14:creationId xmlns:p14="http://schemas.microsoft.com/office/powerpoint/2010/main" val="1929452315"/>
       </p:ext>
     </p:extLst>
   </p:cSld>
@@ -10768,7 +10567,7 @@
         <p:cNvPr id="1" name="">
           <a:extLst>
             <a:ext uri="{FF2B5EF4-FFF2-40B4-BE49-F238E27FC236}">
-              <a16:creationId xmlns:a16="http://schemas.microsoft.com/office/drawing/2014/main" id="{2296FA7B-6556-9641-CE0C-8FB041997617}"/>
+              <a16:creationId xmlns:a16="http://schemas.microsoft.com/office/drawing/2014/main" id="{C3DB5E45-A2BB-24B6-7ADE-021D5E73D9B3}"/>
             </a:ext>
           </a:extLst>
         </p:cNvPr>
@@ -10788,7 +10587,7 @@
           <p:cNvPr id="2" name="Title 1">
             <a:extLst>
               <a:ext uri="{FF2B5EF4-FFF2-40B4-BE49-F238E27FC236}">
-                <a16:creationId xmlns:a16="http://schemas.microsoft.com/office/drawing/2014/main" id="{149F6FB5-22F3-02AC-F03F-7D113C8D5C2B}"/>
+                <a16:creationId xmlns:a16="http://schemas.microsoft.com/office/drawing/2014/main" id="{B4BC1556-5BF1-ECB6-830B-3C9B314C10C3}"/>
               </a:ext>
             </a:extLst>
           </p:cNvPr>
@@ -10813,7 +10612,14 @@
           <a:p>
             <a:r>
               <a:rPr lang="en-US" sz="4000" dirty="0"/>
-              <a:t>Chess Move Notation – Example: 1. Nf3</a:t>
+              <a:t>Chess Move Notation - Disambiguation </a:t>
+            </a:r>
+            <a:br>
+              <a:rPr lang="en-US" sz="4000" dirty="0"/>
+            </a:br>
+            <a:r>
+              <a:rPr lang="en-US" sz="4000" dirty="0"/>
+              <a:t>– Example: 16… Rfe8+</a:t>
             </a:r>
           </a:p>
         </p:txBody>
@@ -10823,7 +10629,7 @@
           <p:cNvPr id="3" name="Content Placeholder 2">
             <a:extLst>
               <a:ext uri="{FF2B5EF4-FFF2-40B4-BE49-F238E27FC236}">
-                <a16:creationId xmlns:a16="http://schemas.microsoft.com/office/drawing/2014/main" id="{16DF6F65-5BA1-8BD8-C2C8-009B545DC94F}"/>
+                <a16:creationId xmlns:a16="http://schemas.microsoft.com/office/drawing/2014/main" id="{7C6D9E91-98B7-3FD2-3300-993AC2011E19}"/>
               </a:ext>
             </a:extLst>
           </p:cNvPr>
@@ -10836,8 +10642,8 @@
         </p:nvSpPr>
         <p:spPr>
           <a:xfrm>
-            <a:off x="677333" y="1593477"/>
-            <a:ext cx="9396833" cy="4447886"/>
+            <a:off x="677333" y="1930399"/>
+            <a:ext cx="9396833" cy="4110963"/>
           </a:xfrm>
         </p:spPr>
         <p:txBody>
@@ -10848,13 +10654,21 @@
           <a:p>
             <a:r>
               <a:rPr lang="en-US" sz="3800" dirty="0"/>
-              <a:t>Parse 1. Nf3 into white knight moving to square f3</a:t>
+              <a:t>Parse 16… Rfe8+ into black rook in file-f to square e8 with check</a:t>
             </a:r>
           </a:p>
           <a:p>
             <a:r>
               <a:rPr lang="en-US" sz="3800" dirty="0"/>
-              <a:t>Determine white knight (at g1) is the one and  only white knight that can move to f3</a:t>
+              <a:t>Determine that the only black rook in the file-f that can move to e8 is </a:t>
+            </a:r>
+            <a:r>
+              <a:rPr lang="en-US" sz="3800"/>
+              <a:t>the rook </a:t>
+            </a:r>
+            <a:r>
+              <a:rPr lang="en-US" sz="3800" dirty="0"/>
+              <a:t>starting in c8</a:t>
             </a:r>
           </a:p>
           <a:p>
@@ -10870,7 +10684,7 @@
           <p:cNvPr id="4" name="Date Placeholder 3">
             <a:extLst>
               <a:ext uri="{FF2B5EF4-FFF2-40B4-BE49-F238E27FC236}">
-                <a16:creationId xmlns:a16="http://schemas.microsoft.com/office/drawing/2014/main" id="{478BA7F9-F106-D735-3A09-8D9CB6A98F6D}"/>
+                <a16:creationId xmlns:a16="http://schemas.microsoft.com/office/drawing/2014/main" id="{B7D72999-BCC9-38B5-856F-182A07F22849}"/>
               </a:ext>
             </a:extLst>
           </p:cNvPr>
@@ -10888,7 +10702,7 @@
           <a:p>
             <a:fld id="{771FCE44-14AA-407B-9781-80C2DD8F374A}" type="datetime1">
               <a:rPr lang="en-US" smtClean="0"/>
-              <a:t>7/24/2026</a:t>
+              <a:t>7/27/2026</a:t>
             </a:fld>
             <a:endParaRPr lang="en-US" dirty="0"/>
           </a:p>
@@ -10899,7 +10713,7 @@
           <p:cNvPr id="6" name="Slide Number Placeholder 5">
             <a:extLst>
               <a:ext uri="{FF2B5EF4-FFF2-40B4-BE49-F238E27FC236}">
-                <a16:creationId xmlns:a16="http://schemas.microsoft.com/office/drawing/2014/main" id="{D01AFB29-A179-E1C8-A86F-BFC0B540F8F5}"/>
+                <a16:creationId xmlns:a16="http://schemas.microsoft.com/office/drawing/2014/main" id="{6D4B26D8-3C90-06E0-BCD7-73BE78C66745}"/>
               </a:ext>
             </a:extLst>
           </p:cNvPr>
@@ -10928,7 +10742,7 @@
           <p:cNvPr id="7" name="Footer Placeholder 6">
             <a:extLst>
               <a:ext uri="{FF2B5EF4-FFF2-40B4-BE49-F238E27FC236}">
-                <a16:creationId xmlns:a16="http://schemas.microsoft.com/office/drawing/2014/main" id="{C00D770E-4F7D-21C8-8862-1F39E2287DEE}"/>
+                <a16:creationId xmlns:a16="http://schemas.microsoft.com/office/drawing/2014/main" id="{702581CD-A02E-912F-9B79-6A32599D72B8}"/>
               </a:ext>
             </a:extLst>
           </p:cNvPr>
@@ -10955,7 +10769,7 @@
     </p:spTree>
     <p:extLst>
       <p:ext uri="{BB962C8B-B14F-4D97-AF65-F5344CB8AC3E}">
-        <p14:creationId xmlns:p14="http://schemas.microsoft.com/office/powerpoint/2010/main" val="1929452315"/>
+        <p14:creationId xmlns:p14="http://schemas.microsoft.com/office/powerpoint/2010/main" val="3026986454"/>
       </p:ext>
     </p:extLst>
   </p:cSld>
@@ -10985,238 +10799,6 @@
         <p:cNvPr id="1" name="">
           <a:extLst>
             <a:ext uri="{FF2B5EF4-FFF2-40B4-BE49-F238E27FC236}">
-              <a16:creationId xmlns:a16="http://schemas.microsoft.com/office/drawing/2014/main" id="{C3DB5E45-A2BB-24B6-7ADE-021D5E73D9B3}"/>
-            </a:ext>
-          </a:extLst>
-        </p:cNvPr>
-        <p:cNvGrpSpPr/>
-        <p:nvPr/>
-      </p:nvGrpSpPr>
-      <p:grpSpPr>
-        <a:xfrm>
-          <a:off x="0" y="0"/>
-          <a:ext cx="0" cy="0"/>
-          <a:chOff x="0" y="0"/>
-          <a:chExt cx="0" cy="0"/>
-        </a:xfrm>
-      </p:grpSpPr>
-      <p:sp>
-        <p:nvSpPr>
-          <p:cNvPr id="2" name="Title 1">
-            <a:extLst>
-              <a:ext uri="{FF2B5EF4-FFF2-40B4-BE49-F238E27FC236}">
-                <a16:creationId xmlns:a16="http://schemas.microsoft.com/office/drawing/2014/main" id="{B4BC1556-5BF1-ECB6-830B-3C9B314C10C3}"/>
-              </a:ext>
-            </a:extLst>
-          </p:cNvPr>
-          <p:cNvSpPr>
-            <a:spLocks noGrp="1"/>
-          </p:cNvSpPr>
-          <p:nvPr>
-            <p:ph type="title"/>
-          </p:nvPr>
-        </p:nvSpPr>
-        <p:spPr>
-          <a:xfrm>
-            <a:off x="677333" y="609600"/>
-            <a:ext cx="9049991" cy="1320800"/>
-          </a:xfrm>
-        </p:spPr>
-        <p:txBody>
-          <a:bodyPr>
-            <a:normAutofit/>
-          </a:bodyPr>
-          <a:lstStyle/>
-          <a:p>
-            <a:r>
-              <a:rPr lang="en-US" sz="4000" dirty="0"/>
-              <a:t>Chess Move Notation - Disambiguation </a:t>
-            </a:r>
-            <a:br>
-              <a:rPr lang="en-US" sz="4000" dirty="0"/>
-            </a:br>
-            <a:r>
-              <a:rPr lang="en-US" sz="4000" dirty="0"/>
-              <a:t>– Example: 16… Rfe8+</a:t>
-            </a:r>
-          </a:p>
-        </p:txBody>
-      </p:sp>
-      <p:sp>
-        <p:nvSpPr>
-          <p:cNvPr id="3" name="Content Placeholder 2">
-            <a:extLst>
-              <a:ext uri="{FF2B5EF4-FFF2-40B4-BE49-F238E27FC236}">
-                <a16:creationId xmlns:a16="http://schemas.microsoft.com/office/drawing/2014/main" id="{7C6D9E91-98B7-3FD2-3300-993AC2011E19}"/>
-              </a:ext>
-            </a:extLst>
-          </p:cNvPr>
-          <p:cNvSpPr>
-            <a:spLocks noGrp="1"/>
-          </p:cNvSpPr>
-          <p:nvPr>
-            <p:ph idx="1"/>
-          </p:nvPr>
-        </p:nvSpPr>
-        <p:spPr>
-          <a:xfrm>
-            <a:off x="677333" y="1930399"/>
-            <a:ext cx="9396833" cy="4110963"/>
-          </a:xfrm>
-        </p:spPr>
-        <p:txBody>
-          <a:bodyPr>
-            <a:normAutofit/>
-          </a:bodyPr>
-          <a:lstStyle/>
-          <a:p>
-            <a:r>
-              <a:rPr lang="en-US" sz="3800" dirty="0"/>
-              <a:t>Parse 16… Rfe8+ into black rook in file-f to square e8 with check</a:t>
-            </a:r>
-          </a:p>
-          <a:p>
-            <a:r>
-              <a:rPr lang="en-US" sz="3800" dirty="0"/>
-              <a:t>Determine that the only black rook in the file-f that can move to e8 is </a:t>
-            </a:r>
-            <a:r>
-              <a:rPr lang="en-US" sz="3800"/>
-              <a:t>the rook </a:t>
-            </a:r>
-            <a:r>
-              <a:rPr lang="en-US" sz="3800" dirty="0"/>
-              <a:t>starting in c8</a:t>
-            </a:r>
-          </a:p>
-          <a:p>
-            <a:pPr marL="0" indent="0">
-              <a:buNone/>
-            </a:pPr>
-            <a:endParaRPr lang="en-US" sz="3800" dirty="0"/>
-          </a:p>
-        </p:txBody>
-      </p:sp>
-      <p:sp>
-        <p:nvSpPr>
-          <p:cNvPr id="4" name="Date Placeholder 3">
-            <a:extLst>
-              <a:ext uri="{FF2B5EF4-FFF2-40B4-BE49-F238E27FC236}">
-                <a16:creationId xmlns:a16="http://schemas.microsoft.com/office/drawing/2014/main" id="{B7D72999-BCC9-38B5-856F-182A07F22849}"/>
-              </a:ext>
-            </a:extLst>
-          </p:cNvPr>
-          <p:cNvSpPr>
-            <a:spLocks noGrp="1"/>
-          </p:cNvSpPr>
-          <p:nvPr>
-            <p:ph type="dt" sz="half" idx="10"/>
-          </p:nvPr>
-        </p:nvSpPr>
-        <p:spPr/>
-        <p:txBody>
-          <a:bodyPr/>
-          <a:lstStyle/>
-          <a:p>
-            <a:fld id="{771FCE44-14AA-407B-9781-80C2DD8F374A}" type="datetime1">
-              <a:rPr lang="en-US" smtClean="0"/>
-              <a:t>7/24/2026</a:t>
-            </a:fld>
-            <a:endParaRPr lang="en-US" dirty="0"/>
-          </a:p>
-        </p:txBody>
-      </p:sp>
-      <p:sp>
-        <p:nvSpPr>
-          <p:cNvPr id="6" name="Slide Number Placeholder 5">
-            <a:extLst>
-              <a:ext uri="{FF2B5EF4-FFF2-40B4-BE49-F238E27FC236}">
-                <a16:creationId xmlns:a16="http://schemas.microsoft.com/office/drawing/2014/main" id="{6D4B26D8-3C90-06E0-BCD7-73BE78C66745}"/>
-              </a:ext>
-            </a:extLst>
-          </p:cNvPr>
-          <p:cNvSpPr>
-            <a:spLocks noGrp="1"/>
-          </p:cNvSpPr>
-          <p:nvPr>
-            <p:ph type="sldNum" sz="quarter" idx="12"/>
-          </p:nvPr>
-        </p:nvSpPr>
-        <p:spPr/>
-        <p:txBody>
-          <a:bodyPr/>
-          <a:lstStyle/>
-          <a:p>
-            <a:fld id="{6D22F896-40B5-4ADD-8801-0D06FADFA095}" type="slidenum">
-              <a:rPr lang="en-US" smtClean="0"/>
-              <a:t>16</a:t>
-            </a:fld>
-            <a:endParaRPr lang="en-US" dirty="0"/>
-          </a:p>
-        </p:txBody>
-      </p:sp>
-      <p:sp>
-        <p:nvSpPr>
-          <p:cNvPr id="7" name="Footer Placeholder 6">
-            <a:extLst>
-              <a:ext uri="{FF2B5EF4-FFF2-40B4-BE49-F238E27FC236}">
-                <a16:creationId xmlns:a16="http://schemas.microsoft.com/office/drawing/2014/main" id="{702581CD-A02E-912F-9B79-6A32599D72B8}"/>
-              </a:ext>
-            </a:extLst>
-          </p:cNvPr>
-          <p:cNvSpPr>
-            <a:spLocks noGrp="1"/>
-          </p:cNvSpPr>
-          <p:nvPr>
-            <p:ph type="ftr" sz="quarter" idx="11"/>
-          </p:nvPr>
-        </p:nvSpPr>
-        <p:spPr/>
-        <p:txBody>
-          <a:bodyPr/>
-          <a:lstStyle/>
-          <a:p>
-            <a:r>
-              <a:rPr lang="en-US"/>
-              <a:t>raysmith@alum.mit.edu                     Session 2 – Building Blocks</a:t>
-            </a:r>
-            <a:endParaRPr lang="en-US" dirty="0"/>
-          </a:p>
-        </p:txBody>
-      </p:sp>
-    </p:spTree>
-    <p:extLst>
-      <p:ext uri="{BB962C8B-B14F-4D97-AF65-F5344CB8AC3E}">
-        <p14:creationId xmlns:p14="http://schemas.microsoft.com/office/powerpoint/2010/main" val="3026986454"/>
-      </p:ext>
-    </p:extLst>
-  </p:cSld>
-  <p:clrMapOvr>
-    <a:masterClrMapping/>
-  </p:clrMapOvr>
-  <mc:AlternateContent xmlns:mc="http://schemas.openxmlformats.org/markup-compatibility/2006" xmlns:p14="http://schemas.microsoft.com/office/powerpoint/2010/main">
-    <mc:Choice Requires="p14">
-      <p:transition spd="med" p14:dur="700">
-        <p:fade/>
-      </p:transition>
-    </mc:Choice>
-    <mc:Fallback xmlns="">
-      <p:transition spd="med">
-        <p:fade/>
-      </p:transition>
-    </mc:Fallback>
-  </mc:AlternateContent>
-</p:sld>
-</file>
-
-<file path=ppt/slides/slide17.xml><?xml version="1.0" encoding="utf-8"?>
-<p:sld xmlns:a="http://schemas.openxmlformats.org/drawingml/2006/main" xmlns:r="http://schemas.openxmlformats.org/officeDocument/2006/relationships" xmlns:p="http://schemas.openxmlformats.org/presentationml/2006/main">
-  <p:cSld>
-    <p:spTree>
-      <p:nvGrpSpPr>
-        <p:cNvPr id="1" name="">
-          <a:extLst>
-            <a:ext uri="{FF2B5EF4-FFF2-40B4-BE49-F238E27FC236}">
               <a16:creationId xmlns:a16="http://schemas.microsoft.com/office/drawing/2014/main" id="{1A800116-AD8E-DD7A-25E9-EE712F072FD8}"/>
             </a:ext>
           </a:extLst>
@@ -11331,7 +10913,7 @@
           <a:p>
             <a:fld id="{6F8407F0-4949-4EDC-A592-6ECEEFF5A038}" type="datetime1">
               <a:rPr lang="en-US" smtClean="0"/>
-              <a:t>7/24/2026</a:t>
+              <a:t>7/27/2026</a:t>
             </a:fld>
             <a:endParaRPr lang="en-US" dirty="0"/>
           </a:p>
@@ -11389,7 +10971,7 @@
           <a:p>
             <a:fld id="{6D22F896-40B5-4ADD-8801-0D06FADFA095}" type="slidenum">
               <a:rPr lang="en-US" smtClean="0"/>
-              <a:t>17</a:t>
+              <a:t>16</a:t>
             </a:fld>
             <a:endParaRPr lang="en-US" dirty="0"/>
           </a:p>
@@ -11408,7 +10990,7 @@
 </p:sld>
 </file>
 
-<file path=ppt/slides/slide18.xml><?xml version="1.0" encoding="utf-8"?>
+<file path=ppt/slides/slide17.xml><?xml version="1.0" encoding="utf-8"?>
 <p:sld xmlns:a="http://schemas.openxmlformats.org/drawingml/2006/main" xmlns:r="http://schemas.openxmlformats.org/officeDocument/2006/relationships" xmlns:p="http://schemas.openxmlformats.org/presentationml/2006/main">
   <p:cSld>
     <p:spTree>
@@ -11486,7 +11068,7 @@
         <p:spPr/>
         <p:txBody>
           <a:bodyPr>
-            <a:normAutofit fontScale="92500" lnSpcReduction="20000"/>
+            <a:normAutofit fontScale="85000" lnSpcReduction="20000"/>
           </a:bodyPr>
           <a:lstStyle/>
           <a:p>
@@ -11496,6 +11078,12 @@
             </a:r>
           </a:p>
           <a:p>
+            <a:r>
+              <a:rPr lang="en-US" sz="3600" dirty="0"/>
+              <a:t>Hopefully one plan for all pieces</a:t>
+            </a:r>
+          </a:p>
+          <a:p>
             <a:endParaRPr lang="en-US" sz="3600" dirty="0"/>
           </a:p>
           <a:p>
@@ -11547,7 +11135,7 @@
           <a:p>
             <a:fld id="{6F8407F0-4949-4EDC-A592-6ECEEFF5A038}" type="datetime1">
               <a:rPr lang="en-US" smtClean="0"/>
-              <a:t>7/24/2026</a:t>
+              <a:t>7/27/2026</a:t>
             </a:fld>
             <a:endParaRPr lang="en-US" dirty="0"/>
           </a:p>
@@ -11605,7 +11193,7 @@
           <a:p>
             <a:fld id="{6D22F896-40B5-4ADD-8801-0D06FADFA095}" type="slidenum">
               <a:rPr lang="en-US" smtClean="0"/>
-              <a:t>18</a:t>
+              <a:t>17</a:t>
             </a:fld>
             <a:endParaRPr lang="en-US" dirty="0"/>
           </a:p>
@@ -11624,7 +11212,7 @@
 </p:sld>
 </file>
 
-<file path=ppt/slides/slide19.xml><?xml version="1.0" encoding="utf-8"?>
+<file path=ppt/slides/slide18.xml><?xml version="1.0" encoding="utf-8"?>
 <p:sld xmlns:a="http://schemas.openxmlformats.org/drawingml/2006/main" xmlns:r="http://schemas.openxmlformats.org/officeDocument/2006/relationships" xmlns:p="http://schemas.openxmlformats.org/presentationml/2006/main">
   <p:cSld>
     <p:spTree>
@@ -11828,7 +11416,7 @@
           <a:p>
             <a:fld id="{6F8407F0-4949-4EDC-A592-6ECEEFF5A038}" type="datetime1">
               <a:rPr lang="en-US" smtClean="0"/>
-              <a:t>7/24/2026</a:t>
+              <a:t>7/27/2026</a:t>
             </a:fld>
             <a:endParaRPr lang="en-US" dirty="0"/>
           </a:p>
@@ -11869,6 +11457,369 @@
             <a:extLst>
               <a:ext uri="{FF2B5EF4-FFF2-40B4-BE49-F238E27FC236}">
                 <a16:creationId xmlns:a16="http://schemas.microsoft.com/office/drawing/2014/main" id="{683B6B92-1060-278C-DB8A-FCC281440B42}"/>
+              </a:ext>
+            </a:extLst>
+          </p:cNvPr>
+          <p:cNvSpPr>
+            <a:spLocks noGrp="1"/>
+          </p:cNvSpPr>
+          <p:nvPr>
+            <p:ph type="sldNum" sz="quarter" idx="12"/>
+          </p:nvPr>
+        </p:nvSpPr>
+        <p:spPr/>
+        <p:txBody>
+          <a:bodyPr/>
+          <a:lstStyle/>
+          <a:p>
+            <a:fld id="{6D22F896-40B5-4ADD-8801-0D06FADFA095}" type="slidenum">
+              <a:rPr lang="en-US" smtClean="0"/>
+              <a:t>18</a:t>
+            </a:fld>
+            <a:endParaRPr lang="en-US" dirty="0"/>
+          </a:p>
+        </p:txBody>
+      </p:sp>
+    </p:spTree>
+    <p:extLst>
+      <p:ext uri="{BB962C8B-B14F-4D97-AF65-F5344CB8AC3E}">
+        <p14:creationId xmlns:p14="http://schemas.microsoft.com/office/powerpoint/2010/main" val="2584085676"/>
+      </p:ext>
+    </p:extLst>
+  </p:cSld>
+  <p:clrMapOvr>
+    <a:masterClrMapping/>
+  </p:clrMapOvr>
+</p:sld>
+</file>
+
+<file path=ppt/slides/slide19.xml><?xml version="1.0" encoding="utf-8"?>
+<p:sld xmlns:a="http://schemas.openxmlformats.org/drawingml/2006/main" xmlns:r="http://schemas.openxmlformats.org/officeDocument/2006/relationships" xmlns:p="http://schemas.openxmlformats.org/presentationml/2006/main">
+  <p:cSld>
+    <p:spTree>
+      <p:nvGrpSpPr>
+        <p:cNvPr id="1" name="">
+          <a:extLst>
+            <a:ext uri="{FF2B5EF4-FFF2-40B4-BE49-F238E27FC236}">
+              <a16:creationId xmlns:a16="http://schemas.microsoft.com/office/drawing/2014/main" id="{96F9300A-91D4-0213-0591-8BCCA96D6202}"/>
+            </a:ext>
+          </a:extLst>
+        </p:cNvPr>
+        <p:cNvGrpSpPr/>
+        <p:nvPr/>
+      </p:nvGrpSpPr>
+      <p:grpSpPr>
+        <a:xfrm>
+          <a:off x="0" y="0"/>
+          <a:ext cx="0" cy="0"/>
+          <a:chOff x="0" y="0"/>
+          <a:chExt cx="0" cy="0"/>
+        </a:xfrm>
+      </p:grpSpPr>
+      <p:sp>
+        <p:nvSpPr>
+          <p:cNvPr id="2" name="Title 1">
+            <a:extLst>
+              <a:ext uri="{FF2B5EF4-FFF2-40B4-BE49-F238E27FC236}">
+                <a16:creationId xmlns:a16="http://schemas.microsoft.com/office/drawing/2014/main" id="{4B2D49CF-42A2-5BFB-1662-DA26C66EFFE4}"/>
+              </a:ext>
+            </a:extLst>
+          </p:cNvPr>
+          <p:cNvSpPr>
+            <a:spLocks noGrp="1"/>
+          </p:cNvSpPr>
+          <p:nvPr>
+            <p:ph type="title"/>
+          </p:nvPr>
+        </p:nvSpPr>
+        <p:spPr>
+          <a:xfrm>
+            <a:off x="677334" y="609600"/>
+            <a:ext cx="8596668" cy="919655"/>
+          </a:xfrm>
+        </p:spPr>
+        <p:txBody>
+          <a:bodyPr/>
+          <a:lstStyle/>
+          <a:p>
+            <a:r>
+              <a:rPr lang="en-US" dirty="0"/>
+              <a:t> Pawn Move Direction Lists</a:t>
+            </a:r>
+          </a:p>
+        </p:txBody>
+      </p:sp>
+      <p:sp>
+        <p:nvSpPr>
+          <p:cNvPr id="3" name="Content Placeholder 2">
+            <a:extLst>
+              <a:ext uri="{FF2B5EF4-FFF2-40B4-BE49-F238E27FC236}">
+                <a16:creationId xmlns:a16="http://schemas.microsoft.com/office/drawing/2014/main" id="{34AEEDB6-69A7-D882-E9BB-9784EDB8F0E9}"/>
+              </a:ext>
+            </a:extLst>
+          </p:cNvPr>
+          <p:cNvSpPr>
+            <a:spLocks noGrp="1"/>
+          </p:cNvSpPr>
+          <p:nvPr>
+            <p:ph idx="1"/>
+          </p:nvPr>
+        </p:nvSpPr>
+        <p:spPr>
+          <a:xfrm>
+            <a:off x="677333" y="2160589"/>
+            <a:ext cx="9081521" cy="3880773"/>
+          </a:xfrm>
+        </p:spPr>
+        <p:txBody>
+          <a:bodyPr>
+            <a:normAutofit fontScale="92500" lnSpcReduction="20000"/>
+          </a:bodyPr>
+          <a:lstStyle/>
+          <a:p>
+            <a:pPr marL="0" indent="0">
+              <a:buNone/>
+            </a:pPr>
+            <a:r>
+              <a:rPr lang="en-US" sz="3600" dirty="0"/>
+              <a:t> </a:t>
+            </a:r>
+            <a:r>
+              <a:rPr lang="en-US" sz="3600" dirty="0">
+                <a:solidFill>
+                  <a:schemeClr val="accent1"/>
+                </a:solidFill>
+              </a:rPr>
+              <a:t>pawn – list of directions:</a:t>
+            </a:r>
+          </a:p>
+          <a:p>
+            <a:pPr marL="0" indent="0">
+              <a:buNone/>
+            </a:pPr>
+            <a:r>
+              <a:rPr lang="en-US" sz="3600" dirty="0">
+                <a:solidFill>
+                  <a:schemeClr val="accent1"/>
+                </a:solidFill>
+              </a:rPr>
+              <a:t> Third entry for </a:t>
+            </a:r>
+            <a:r>
+              <a:rPr lang="en-US" sz="3600" dirty="0">
+                <a:solidFill>
+                  <a:schemeClr val="accent2"/>
+                </a:solidFill>
+              </a:rPr>
+              <a:t>move</a:t>
+            </a:r>
+            <a:r>
+              <a:rPr lang="en-US" sz="3600" dirty="0">
+                <a:solidFill>
+                  <a:schemeClr val="accent1"/>
+                </a:solidFill>
+              </a:rPr>
+              <a:t> /</a:t>
+            </a:r>
+            <a:r>
+              <a:rPr lang="en-US" sz="3600" dirty="0">
+                <a:solidFill>
+                  <a:schemeClr val="accent5"/>
+                </a:solidFill>
+              </a:rPr>
+              <a:t>capture</a:t>
+            </a:r>
+          </a:p>
+          <a:p>
+            <a:pPr marL="0" indent="0">
+              <a:buNone/>
+            </a:pPr>
+            <a:r>
+              <a:rPr lang="en-US" sz="3600" dirty="0">
+                <a:solidFill>
+                  <a:schemeClr val="accent1"/>
+                </a:solidFill>
+              </a:rPr>
+              <a:t>  </a:t>
+            </a:r>
+          </a:p>
+          <a:p>
+            <a:pPr marL="0" indent="0">
+              <a:buNone/>
+            </a:pPr>
+            <a:r>
+              <a:rPr lang="en-US" sz="3600" dirty="0"/>
+              <a:t>  white:  (0,1,"</a:t>
+            </a:r>
+            <a:r>
+              <a:rPr lang="en-US" sz="3600" dirty="0">
+                <a:solidFill>
+                  <a:srgbClr val="00B050"/>
+                </a:solidFill>
+              </a:rPr>
+              <a:t>move</a:t>
+            </a:r>
+            <a:r>
+              <a:rPr lang="en-US" sz="3600" dirty="0"/>
+              <a:t>"), (-1,1, "</a:t>
+            </a:r>
+            <a:r>
+              <a:rPr lang="en-US" sz="3600" dirty="0">
+                <a:solidFill>
+                  <a:schemeClr val="accent5"/>
+                </a:solidFill>
+              </a:rPr>
+              <a:t>capture</a:t>
+            </a:r>
+            <a:r>
+              <a:rPr lang="en-US" sz="3600" dirty="0"/>
+              <a:t>")</a:t>
+            </a:r>
+          </a:p>
+          <a:p>
+            <a:pPr marL="0" indent="0">
+              <a:buNone/>
+            </a:pPr>
+            <a:r>
+              <a:rPr lang="en-US" sz="3600" dirty="0"/>
+              <a:t>             (1,1,"</a:t>
+            </a:r>
+            <a:r>
+              <a:rPr lang="en-US" sz="3600" dirty="0">
+                <a:solidFill>
+                  <a:schemeClr val="accent5"/>
+                </a:solidFill>
+              </a:rPr>
+              <a:t>capture</a:t>
+            </a:r>
+            <a:r>
+              <a:rPr lang="en-US" sz="3600" dirty="0"/>
+              <a:t>")</a:t>
+            </a:r>
+          </a:p>
+          <a:p>
+            <a:pPr marL="0" indent="0">
+              <a:buNone/>
+            </a:pPr>
+            <a:r>
+              <a:rPr lang="en-US" sz="3600" dirty="0"/>
+              <a:t>  black:  (0,-1,"</a:t>
+            </a:r>
+            <a:r>
+              <a:rPr lang="en-US" sz="3600" dirty="0">
+                <a:solidFill>
+                  <a:schemeClr val="accent2"/>
+                </a:solidFill>
+              </a:rPr>
+              <a:t>move</a:t>
+            </a:r>
+            <a:r>
+              <a:rPr lang="en-US" sz="3600" dirty="0"/>
+              <a:t>"), (-1,-1, "</a:t>
+            </a:r>
+            <a:r>
+              <a:rPr lang="en-US" sz="3600" dirty="0">
+                <a:solidFill>
+                  <a:schemeClr val="accent5"/>
+                </a:solidFill>
+              </a:rPr>
+              <a:t>capture</a:t>
+            </a:r>
+            <a:r>
+              <a:rPr lang="en-US" sz="3600" dirty="0"/>
+              <a:t>"),</a:t>
+            </a:r>
+          </a:p>
+          <a:p>
+            <a:pPr marL="0" indent="0">
+              <a:buNone/>
+            </a:pPr>
+            <a:r>
+              <a:rPr lang="en-US" sz="3600" dirty="0"/>
+              <a:t>             (1,-1,"</a:t>
+            </a:r>
+            <a:r>
+              <a:rPr lang="en-US" sz="3600" dirty="0">
+                <a:solidFill>
+                  <a:schemeClr val="accent5"/>
+                </a:solidFill>
+              </a:rPr>
+              <a:t>capture</a:t>
+            </a:r>
+            <a:r>
+              <a:rPr lang="en-US" sz="3600" dirty="0"/>
+              <a:t>")],</a:t>
+            </a:r>
+          </a:p>
+          <a:p>
+            <a:endParaRPr lang="en-US" sz="3600" dirty="0"/>
+          </a:p>
+        </p:txBody>
+      </p:sp>
+      <p:sp>
+        <p:nvSpPr>
+          <p:cNvPr id="4" name="Date Placeholder 3">
+            <a:extLst>
+              <a:ext uri="{FF2B5EF4-FFF2-40B4-BE49-F238E27FC236}">
+                <a16:creationId xmlns:a16="http://schemas.microsoft.com/office/drawing/2014/main" id="{C36264F9-8A8F-908D-231E-B5B2AB5DE42D}"/>
+              </a:ext>
+            </a:extLst>
+          </p:cNvPr>
+          <p:cNvSpPr>
+            <a:spLocks noGrp="1"/>
+          </p:cNvSpPr>
+          <p:nvPr>
+            <p:ph type="dt" sz="half" idx="10"/>
+          </p:nvPr>
+        </p:nvSpPr>
+        <p:spPr/>
+        <p:txBody>
+          <a:bodyPr/>
+          <a:lstStyle/>
+          <a:p>
+            <a:fld id="{6F8407F0-4949-4EDC-A592-6ECEEFF5A038}" type="datetime1">
+              <a:rPr lang="en-US" smtClean="0"/>
+              <a:t>7/27/2026</a:t>
+            </a:fld>
+            <a:endParaRPr lang="en-US" dirty="0"/>
+          </a:p>
+        </p:txBody>
+      </p:sp>
+      <p:sp>
+        <p:nvSpPr>
+          <p:cNvPr id="5" name="Footer Placeholder 4">
+            <a:extLst>
+              <a:ext uri="{FF2B5EF4-FFF2-40B4-BE49-F238E27FC236}">
+                <a16:creationId xmlns:a16="http://schemas.microsoft.com/office/drawing/2014/main" id="{B5E763EC-CF35-80FC-6010-FC4821ABD43A}"/>
+              </a:ext>
+            </a:extLst>
+          </p:cNvPr>
+          <p:cNvSpPr>
+            <a:spLocks noGrp="1"/>
+          </p:cNvSpPr>
+          <p:nvPr>
+            <p:ph type="ftr" sz="quarter" idx="11"/>
+          </p:nvPr>
+        </p:nvSpPr>
+        <p:spPr/>
+        <p:txBody>
+          <a:bodyPr/>
+          <a:lstStyle/>
+          <a:p>
+            <a:r>
+              <a:rPr lang="en-US"/>
+              <a:t>raysmith@alum.mit.edu                     Session 2 – Building Blocks</a:t>
+            </a:r>
+            <a:endParaRPr lang="en-US" dirty="0"/>
+          </a:p>
+        </p:txBody>
+      </p:sp>
+      <p:sp>
+        <p:nvSpPr>
+          <p:cNvPr id="6" name="Slide Number Placeholder 5">
+            <a:extLst>
+              <a:ext uri="{FF2B5EF4-FFF2-40B4-BE49-F238E27FC236}">
+                <a16:creationId xmlns:a16="http://schemas.microsoft.com/office/drawing/2014/main" id="{AABE5C57-4D0C-0A4B-CDA9-59126E65613F}"/>
               </a:ext>
             </a:extLst>
           </p:cNvPr>
@@ -11895,7 +11846,7 @@
     </p:spTree>
     <p:extLst>
       <p:ext uri="{BB962C8B-B14F-4D97-AF65-F5344CB8AC3E}">
-        <p14:creationId xmlns:p14="http://schemas.microsoft.com/office/powerpoint/2010/main" val="2584085676"/>
+        <p14:creationId xmlns:p14="http://schemas.microsoft.com/office/powerpoint/2010/main" val="895188894"/>
       </p:ext>
     </p:extLst>
   </p:cSld>
@@ -12020,7 +11971,7 @@
           <a:p>
             <a:fld id="{771FCE44-14AA-407B-9781-80C2DD8F374A}" type="datetime1">
               <a:rPr lang="en-US" smtClean="0"/>
-              <a:t>7/24/2026</a:t>
+              <a:t>7/27/2026</a:t>
             </a:fld>
             <a:endParaRPr lang="en-US" dirty="0"/>
           </a:p>
@@ -12116,369 +12067,6 @@
         <p:cNvPr id="1" name="">
           <a:extLst>
             <a:ext uri="{FF2B5EF4-FFF2-40B4-BE49-F238E27FC236}">
-              <a16:creationId xmlns:a16="http://schemas.microsoft.com/office/drawing/2014/main" id="{96F9300A-91D4-0213-0591-8BCCA96D6202}"/>
-            </a:ext>
-          </a:extLst>
-        </p:cNvPr>
-        <p:cNvGrpSpPr/>
-        <p:nvPr/>
-      </p:nvGrpSpPr>
-      <p:grpSpPr>
-        <a:xfrm>
-          <a:off x="0" y="0"/>
-          <a:ext cx="0" cy="0"/>
-          <a:chOff x="0" y="0"/>
-          <a:chExt cx="0" cy="0"/>
-        </a:xfrm>
-      </p:grpSpPr>
-      <p:sp>
-        <p:nvSpPr>
-          <p:cNvPr id="2" name="Title 1">
-            <a:extLst>
-              <a:ext uri="{FF2B5EF4-FFF2-40B4-BE49-F238E27FC236}">
-                <a16:creationId xmlns:a16="http://schemas.microsoft.com/office/drawing/2014/main" id="{4B2D49CF-42A2-5BFB-1662-DA26C66EFFE4}"/>
-              </a:ext>
-            </a:extLst>
-          </p:cNvPr>
-          <p:cNvSpPr>
-            <a:spLocks noGrp="1"/>
-          </p:cNvSpPr>
-          <p:nvPr>
-            <p:ph type="title"/>
-          </p:nvPr>
-        </p:nvSpPr>
-        <p:spPr>
-          <a:xfrm>
-            <a:off x="677334" y="609600"/>
-            <a:ext cx="8596668" cy="919655"/>
-          </a:xfrm>
-        </p:spPr>
-        <p:txBody>
-          <a:bodyPr/>
-          <a:lstStyle/>
-          <a:p>
-            <a:r>
-              <a:rPr lang="en-US" dirty="0"/>
-              <a:t> Pawn Move Direction Lists</a:t>
-            </a:r>
-          </a:p>
-        </p:txBody>
-      </p:sp>
-      <p:sp>
-        <p:nvSpPr>
-          <p:cNvPr id="3" name="Content Placeholder 2">
-            <a:extLst>
-              <a:ext uri="{FF2B5EF4-FFF2-40B4-BE49-F238E27FC236}">
-                <a16:creationId xmlns:a16="http://schemas.microsoft.com/office/drawing/2014/main" id="{34AEEDB6-69A7-D882-E9BB-9784EDB8F0E9}"/>
-              </a:ext>
-            </a:extLst>
-          </p:cNvPr>
-          <p:cNvSpPr>
-            <a:spLocks noGrp="1"/>
-          </p:cNvSpPr>
-          <p:nvPr>
-            <p:ph idx="1"/>
-          </p:nvPr>
-        </p:nvSpPr>
-        <p:spPr>
-          <a:xfrm>
-            <a:off x="677333" y="2160589"/>
-            <a:ext cx="9081521" cy="3880773"/>
-          </a:xfrm>
-        </p:spPr>
-        <p:txBody>
-          <a:bodyPr>
-            <a:normAutofit fontScale="92500" lnSpcReduction="20000"/>
-          </a:bodyPr>
-          <a:lstStyle/>
-          <a:p>
-            <a:pPr marL="0" indent="0">
-              <a:buNone/>
-            </a:pPr>
-            <a:r>
-              <a:rPr lang="en-US" sz="3600" dirty="0"/>
-              <a:t> </a:t>
-            </a:r>
-            <a:r>
-              <a:rPr lang="en-US" sz="3600" dirty="0">
-                <a:solidFill>
-                  <a:schemeClr val="accent1"/>
-                </a:solidFill>
-              </a:rPr>
-              <a:t>pawn – list of directions:</a:t>
-            </a:r>
-          </a:p>
-          <a:p>
-            <a:pPr marL="0" indent="0">
-              <a:buNone/>
-            </a:pPr>
-            <a:r>
-              <a:rPr lang="en-US" sz="3600" dirty="0">
-                <a:solidFill>
-                  <a:schemeClr val="accent1"/>
-                </a:solidFill>
-              </a:rPr>
-              <a:t> Third entry for </a:t>
-            </a:r>
-            <a:r>
-              <a:rPr lang="en-US" sz="3600" dirty="0">
-                <a:solidFill>
-                  <a:schemeClr val="accent2"/>
-                </a:solidFill>
-              </a:rPr>
-              <a:t>move</a:t>
-            </a:r>
-            <a:r>
-              <a:rPr lang="en-US" sz="3600" dirty="0">
-                <a:solidFill>
-                  <a:schemeClr val="accent1"/>
-                </a:solidFill>
-              </a:rPr>
-              <a:t> /</a:t>
-            </a:r>
-            <a:r>
-              <a:rPr lang="en-US" sz="3600" dirty="0">
-                <a:solidFill>
-                  <a:schemeClr val="accent5"/>
-                </a:solidFill>
-              </a:rPr>
-              <a:t>capture</a:t>
-            </a:r>
-          </a:p>
-          <a:p>
-            <a:pPr marL="0" indent="0">
-              <a:buNone/>
-            </a:pPr>
-            <a:r>
-              <a:rPr lang="en-US" sz="3600" dirty="0">
-                <a:solidFill>
-                  <a:schemeClr val="accent1"/>
-                </a:solidFill>
-              </a:rPr>
-              <a:t>  </a:t>
-            </a:r>
-          </a:p>
-          <a:p>
-            <a:pPr marL="0" indent="0">
-              <a:buNone/>
-            </a:pPr>
-            <a:r>
-              <a:rPr lang="en-US" sz="3600" dirty="0"/>
-              <a:t>  white:  (0,1,"</a:t>
-            </a:r>
-            <a:r>
-              <a:rPr lang="en-US" sz="3600" dirty="0">
-                <a:solidFill>
-                  <a:srgbClr val="00B050"/>
-                </a:solidFill>
-              </a:rPr>
-              <a:t>move</a:t>
-            </a:r>
-            <a:r>
-              <a:rPr lang="en-US" sz="3600" dirty="0"/>
-              <a:t>"), (-1,1, "</a:t>
-            </a:r>
-            <a:r>
-              <a:rPr lang="en-US" sz="3600" dirty="0">
-                <a:solidFill>
-                  <a:schemeClr val="accent5"/>
-                </a:solidFill>
-              </a:rPr>
-              <a:t>capture</a:t>
-            </a:r>
-            <a:r>
-              <a:rPr lang="en-US" sz="3600" dirty="0"/>
-              <a:t>")</a:t>
-            </a:r>
-          </a:p>
-          <a:p>
-            <a:pPr marL="0" indent="0">
-              <a:buNone/>
-            </a:pPr>
-            <a:r>
-              <a:rPr lang="en-US" sz="3600" dirty="0"/>
-              <a:t>             (1,1,"</a:t>
-            </a:r>
-            <a:r>
-              <a:rPr lang="en-US" sz="3600" dirty="0">
-                <a:solidFill>
-                  <a:schemeClr val="accent5"/>
-                </a:solidFill>
-              </a:rPr>
-              <a:t>capture</a:t>
-            </a:r>
-            <a:r>
-              <a:rPr lang="en-US" sz="3600" dirty="0"/>
-              <a:t>")</a:t>
-            </a:r>
-          </a:p>
-          <a:p>
-            <a:pPr marL="0" indent="0">
-              <a:buNone/>
-            </a:pPr>
-            <a:r>
-              <a:rPr lang="en-US" sz="3600" dirty="0"/>
-              <a:t>  black:  (0,-1,"</a:t>
-            </a:r>
-            <a:r>
-              <a:rPr lang="en-US" sz="3600" dirty="0">
-                <a:solidFill>
-                  <a:schemeClr val="accent2"/>
-                </a:solidFill>
-              </a:rPr>
-              <a:t>move</a:t>
-            </a:r>
-            <a:r>
-              <a:rPr lang="en-US" sz="3600" dirty="0"/>
-              <a:t>"), (-1,-1, "</a:t>
-            </a:r>
-            <a:r>
-              <a:rPr lang="en-US" sz="3600" dirty="0">
-                <a:solidFill>
-                  <a:schemeClr val="accent5"/>
-                </a:solidFill>
-              </a:rPr>
-              <a:t>capture</a:t>
-            </a:r>
-            <a:r>
-              <a:rPr lang="en-US" sz="3600" dirty="0"/>
-              <a:t>"),</a:t>
-            </a:r>
-          </a:p>
-          <a:p>
-            <a:pPr marL="0" indent="0">
-              <a:buNone/>
-            </a:pPr>
-            <a:r>
-              <a:rPr lang="en-US" sz="3600" dirty="0"/>
-              <a:t>             (1,-1,"</a:t>
-            </a:r>
-            <a:r>
-              <a:rPr lang="en-US" sz="3600" dirty="0">
-                <a:solidFill>
-                  <a:schemeClr val="accent5"/>
-                </a:solidFill>
-              </a:rPr>
-              <a:t>capture</a:t>
-            </a:r>
-            <a:r>
-              <a:rPr lang="en-US" sz="3600" dirty="0"/>
-              <a:t>")],</a:t>
-            </a:r>
-          </a:p>
-          <a:p>
-            <a:endParaRPr lang="en-US" sz="3600" dirty="0"/>
-          </a:p>
-        </p:txBody>
-      </p:sp>
-      <p:sp>
-        <p:nvSpPr>
-          <p:cNvPr id="4" name="Date Placeholder 3">
-            <a:extLst>
-              <a:ext uri="{FF2B5EF4-FFF2-40B4-BE49-F238E27FC236}">
-                <a16:creationId xmlns:a16="http://schemas.microsoft.com/office/drawing/2014/main" id="{C36264F9-8A8F-908D-231E-B5B2AB5DE42D}"/>
-              </a:ext>
-            </a:extLst>
-          </p:cNvPr>
-          <p:cNvSpPr>
-            <a:spLocks noGrp="1"/>
-          </p:cNvSpPr>
-          <p:nvPr>
-            <p:ph type="dt" sz="half" idx="10"/>
-          </p:nvPr>
-        </p:nvSpPr>
-        <p:spPr/>
-        <p:txBody>
-          <a:bodyPr/>
-          <a:lstStyle/>
-          <a:p>
-            <a:fld id="{6F8407F0-4949-4EDC-A592-6ECEEFF5A038}" type="datetime1">
-              <a:rPr lang="en-US" smtClean="0"/>
-              <a:t>7/24/2026</a:t>
-            </a:fld>
-            <a:endParaRPr lang="en-US" dirty="0"/>
-          </a:p>
-        </p:txBody>
-      </p:sp>
-      <p:sp>
-        <p:nvSpPr>
-          <p:cNvPr id="5" name="Footer Placeholder 4">
-            <a:extLst>
-              <a:ext uri="{FF2B5EF4-FFF2-40B4-BE49-F238E27FC236}">
-                <a16:creationId xmlns:a16="http://schemas.microsoft.com/office/drawing/2014/main" id="{B5E763EC-CF35-80FC-6010-FC4821ABD43A}"/>
-              </a:ext>
-            </a:extLst>
-          </p:cNvPr>
-          <p:cNvSpPr>
-            <a:spLocks noGrp="1"/>
-          </p:cNvSpPr>
-          <p:nvPr>
-            <p:ph type="ftr" sz="quarter" idx="11"/>
-          </p:nvPr>
-        </p:nvSpPr>
-        <p:spPr/>
-        <p:txBody>
-          <a:bodyPr/>
-          <a:lstStyle/>
-          <a:p>
-            <a:r>
-              <a:rPr lang="en-US"/>
-              <a:t>raysmith@alum.mit.edu                     Session 2 – Building Blocks</a:t>
-            </a:r>
-            <a:endParaRPr lang="en-US" dirty="0"/>
-          </a:p>
-        </p:txBody>
-      </p:sp>
-      <p:sp>
-        <p:nvSpPr>
-          <p:cNvPr id="6" name="Slide Number Placeholder 5">
-            <a:extLst>
-              <a:ext uri="{FF2B5EF4-FFF2-40B4-BE49-F238E27FC236}">
-                <a16:creationId xmlns:a16="http://schemas.microsoft.com/office/drawing/2014/main" id="{AABE5C57-4D0C-0A4B-CDA9-59126E65613F}"/>
-              </a:ext>
-            </a:extLst>
-          </p:cNvPr>
-          <p:cNvSpPr>
-            <a:spLocks noGrp="1"/>
-          </p:cNvSpPr>
-          <p:nvPr>
-            <p:ph type="sldNum" sz="quarter" idx="12"/>
-          </p:nvPr>
-        </p:nvSpPr>
-        <p:spPr/>
-        <p:txBody>
-          <a:bodyPr/>
-          <a:lstStyle/>
-          <a:p>
-            <a:fld id="{6D22F896-40B5-4ADD-8801-0D06FADFA095}" type="slidenum">
-              <a:rPr lang="en-US" smtClean="0"/>
-              <a:t>20</a:t>
-            </a:fld>
-            <a:endParaRPr lang="en-US" dirty="0"/>
-          </a:p>
-        </p:txBody>
-      </p:sp>
-    </p:spTree>
-    <p:extLst>
-      <p:ext uri="{BB962C8B-B14F-4D97-AF65-F5344CB8AC3E}">
-        <p14:creationId xmlns:p14="http://schemas.microsoft.com/office/powerpoint/2010/main" val="895188894"/>
-      </p:ext>
-    </p:extLst>
-  </p:cSld>
-  <p:clrMapOvr>
-    <a:masterClrMapping/>
-  </p:clrMapOvr>
-</p:sld>
-</file>
-
-<file path=ppt/slides/slide21.xml><?xml version="1.0" encoding="utf-8"?>
-<p:sld xmlns:a="http://schemas.openxmlformats.org/drawingml/2006/main" xmlns:r="http://schemas.openxmlformats.org/officeDocument/2006/relationships" xmlns:p="http://schemas.openxmlformats.org/presentationml/2006/main">
-  <p:cSld>
-    <p:spTree>
-      <p:nvGrpSpPr>
-        <p:cNvPr id="1" name="">
-          <a:extLst>
-            <a:ext uri="{FF2B5EF4-FFF2-40B4-BE49-F238E27FC236}">
               <a16:creationId xmlns:a16="http://schemas.microsoft.com/office/drawing/2014/main" id="{8A28471E-41DC-94CC-0E06-9BF01DCEA186}"/>
             </a:ext>
           </a:extLst>
@@ -12844,7 +12432,7 @@
           <a:p>
             <a:fld id="{6F8407F0-4949-4EDC-A592-6ECEEFF5A038}" type="datetime1">
               <a:rPr lang="en-US" smtClean="0"/>
-              <a:t>7/24/2026</a:t>
+              <a:t>7/27/2026</a:t>
             </a:fld>
             <a:endParaRPr lang="en-US" dirty="0"/>
           </a:p>
@@ -12901,7 +12489,7 @@
           <a:p>
             <a:fld id="{6D22F896-40B5-4ADD-8801-0D06FADFA095}" type="slidenum">
               <a:rPr lang="en-US" smtClean="0"/>
-              <a:t>21</a:t>
+              <a:t>20</a:t>
             </a:fld>
             <a:endParaRPr lang="en-US" dirty="0"/>
           </a:p>
@@ -12920,7 +12508,7 @@
 </p:sld>
 </file>
 
-<file path=ppt/slides/slide22.xml><?xml version="1.0" encoding="utf-8"?>
+<file path=ppt/slides/slide21.xml><?xml version="1.0" encoding="utf-8"?>
 <p:sld xmlns:a="http://schemas.openxmlformats.org/drawingml/2006/main" xmlns:r="http://schemas.openxmlformats.org/officeDocument/2006/relationships" xmlns:p="http://schemas.openxmlformats.org/presentationml/2006/main">
   <p:cSld>
     <p:spTree>
@@ -13224,7 +12812,7 @@
           <a:p>
             <a:fld id="{6F8407F0-4949-4EDC-A592-6ECEEFF5A038}" type="datetime1">
               <a:rPr lang="en-US" smtClean="0"/>
-              <a:t>7/24/2026</a:t>
+              <a:t>7/27/2026</a:t>
             </a:fld>
             <a:endParaRPr lang="en-US" dirty="0"/>
           </a:p>
@@ -13282,7 +12870,7 @@
           <a:p>
             <a:fld id="{6D22F896-40B5-4ADD-8801-0D06FADFA095}" type="slidenum">
               <a:rPr lang="en-US" smtClean="0"/>
-              <a:t>22</a:t>
+              <a:t>21</a:t>
             </a:fld>
             <a:endParaRPr lang="en-US" dirty="0"/>
           </a:p>
@@ -13301,7 +12889,7 @@
 </p:sld>
 </file>
 
-<file path=ppt/slides/slide23.xml><?xml version="1.0" encoding="utf-8"?>
+<file path=ppt/slides/slide22.xml><?xml version="1.0" encoding="utf-8"?>
 <p:sld xmlns:a="http://schemas.openxmlformats.org/drawingml/2006/main" xmlns:r="http://schemas.openxmlformats.org/officeDocument/2006/relationships" xmlns:p="http://schemas.openxmlformats.org/presentationml/2006/main">
   <p:cSld>
     <p:spTree>
@@ -13485,7 +13073,7 @@
           <a:p>
             <a:fld id="{6F8407F0-4949-4EDC-A592-6ECEEFF5A038}" type="datetime1">
               <a:rPr lang="en-US" smtClean="0"/>
-              <a:t>7/24/2026</a:t>
+              <a:t>7/27/2026</a:t>
             </a:fld>
             <a:endParaRPr lang="en-US" dirty="0"/>
           </a:p>
@@ -13543,7 +13131,7 @@
           <a:p>
             <a:fld id="{6D22F896-40B5-4ADD-8801-0D06FADFA095}" type="slidenum">
               <a:rPr lang="en-US" smtClean="0"/>
-              <a:t>23</a:t>
+              <a:t>22</a:t>
             </a:fld>
             <a:endParaRPr lang="en-US" dirty="0"/>
           </a:p>
@@ -13562,7 +13150,7 @@
 </p:sld>
 </file>
 
-<file path=ppt/slides/slide24.xml><?xml version="1.0" encoding="utf-8"?>
+<file path=ppt/slides/slide23.xml><?xml version="1.0" encoding="utf-8"?>
 <p:sld xmlns:a="http://schemas.openxmlformats.org/drawingml/2006/main" xmlns:r="http://schemas.openxmlformats.org/officeDocument/2006/relationships" xmlns:p="http://schemas.openxmlformats.org/presentationml/2006/main">
   <p:cSld>
     <p:spTree>
@@ -13783,7 +13371,7 @@
           <a:p>
             <a:fld id="{6F8407F0-4949-4EDC-A592-6ECEEFF5A038}" type="datetime1">
               <a:rPr lang="en-US" smtClean="0"/>
-              <a:t>7/24/2026</a:t>
+              <a:t>7/27/2026</a:t>
             </a:fld>
             <a:endParaRPr lang="en-US" dirty="0"/>
           </a:p>
@@ -13841,7 +13429,7 @@
           <a:p>
             <a:fld id="{6D22F896-40B5-4ADD-8801-0D06FADFA095}" type="slidenum">
               <a:rPr lang="en-US" smtClean="0"/>
-              <a:t>24</a:t>
+              <a:t>23</a:t>
             </a:fld>
             <a:endParaRPr lang="en-US" dirty="0"/>
           </a:p>
@@ -13860,7 +13448,7 @@
 </p:sld>
 </file>
 
-<file path=ppt/slides/slide25.xml><?xml version="1.0" encoding="utf-8"?>
+<file path=ppt/slides/slide24.xml><?xml version="1.0" encoding="utf-8"?>
 <p:sld xmlns:a="http://schemas.openxmlformats.org/drawingml/2006/main" xmlns:r="http://schemas.openxmlformats.org/officeDocument/2006/relationships" xmlns:p="http://schemas.openxmlformats.org/presentationml/2006/main">
   <p:cSld>
     <p:spTree>
@@ -13900,7 +13488,7 @@
           <a:p>
             <a:fld id="{6F8407F0-4949-4EDC-A592-6ECEEFF5A038}" type="datetime1">
               <a:rPr lang="en-US" smtClean="0"/>
-              <a:t>7/24/2026</a:t>
+              <a:t>7/27/2026</a:t>
             </a:fld>
             <a:endParaRPr lang="en-US" dirty="0"/>
           </a:p>
@@ -13958,7 +13546,7 @@
           <a:p>
             <a:fld id="{6D22F896-40B5-4ADD-8801-0D06FADFA095}" type="slidenum">
               <a:rPr lang="en-US" smtClean="0"/>
-              <a:t>25</a:t>
+              <a:t>24</a:t>
             </a:fld>
             <a:endParaRPr lang="en-US" dirty="0"/>
           </a:p>
@@ -14007,6 +13595,201 @@
 </p:sld>
 </file>
 
+<file path=ppt/slides/slide25.xml><?xml version="1.0" encoding="utf-8"?>
+<p:sld xmlns:a="http://schemas.openxmlformats.org/drawingml/2006/main" xmlns:r="http://schemas.openxmlformats.org/officeDocument/2006/relationships" xmlns:p="http://schemas.openxmlformats.org/presentationml/2006/main">
+  <p:cSld>
+    <p:spTree>
+      <p:nvGrpSpPr>
+        <p:cNvPr id="1" name=""/>
+        <p:cNvGrpSpPr/>
+        <p:nvPr/>
+      </p:nvGrpSpPr>
+      <p:grpSpPr>
+        <a:xfrm>
+          <a:off x="0" y="0"/>
+          <a:ext cx="0" cy="0"/>
+          <a:chOff x="0" y="0"/>
+          <a:chExt cx="0" cy="0"/>
+        </a:xfrm>
+      </p:grpSpPr>
+      <p:sp>
+        <p:nvSpPr>
+          <p:cNvPr id="5" name="Title 4">
+            <a:extLst>
+              <a:ext uri="{FF2B5EF4-FFF2-40B4-BE49-F238E27FC236}">
+                <a16:creationId xmlns:a16="http://schemas.microsoft.com/office/drawing/2014/main" id="{BF9C39FE-31B9-52A2-5269-0EB66D0AE10D}"/>
+              </a:ext>
+            </a:extLst>
+          </p:cNvPr>
+          <p:cNvSpPr>
+            <a:spLocks noGrp="1"/>
+          </p:cNvSpPr>
+          <p:nvPr>
+            <p:ph type="title"/>
+          </p:nvPr>
+        </p:nvSpPr>
+        <p:spPr/>
+        <p:txBody>
+          <a:bodyPr/>
+          <a:lstStyle/>
+          <a:p>
+            <a:r>
+              <a:rPr lang="en-US" dirty="0"/>
+              <a:t>Destination squares after 16. Bc5</a:t>
+            </a:r>
+            <a:br>
+              <a:rPr lang="en-US" dirty="0"/>
+            </a:br>
+            <a:r>
+              <a:rPr lang="en-US" dirty="0"/>
+              <a:t>for Rook at F8</a:t>
+            </a:r>
+          </a:p>
+        </p:txBody>
+      </p:sp>
+      <p:sp>
+        <p:nvSpPr>
+          <p:cNvPr id="6" name="Content Placeholder 5">
+            <a:extLst>
+              <a:ext uri="{FF2B5EF4-FFF2-40B4-BE49-F238E27FC236}">
+                <a16:creationId xmlns:a16="http://schemas.microsoft.com/office/drawing/2014/main" id="{5BB596F4-9C52-73D1-825B-B95E6E35C4C0}"/>
+              </a:ext>
+            </a:extLst>
+          </p:cNvPr>
+          <p:cNvSpPr>
+            <a:spLocks noGrp="1"/>
+          </p:cNvSpPr>
+          <p:nvPr>
+            <p:ph idx="1"/>
+          </p:nvPr>
+        </p:nvSpPr>
+        <p:spPr/>
+        <p:txBody>
+          <a:bodyPr/>
+          <a:lstStyle/>
+          <a:p>
+            <a:r>
+              <a:rPr lang="en-US" sz="2800" dirty="0"/>
+              <a:t>(move direction): square - result</a:t>
+            </a:r>
+          </a:p>
+          <a:p>
+            <a:r>
+              <a:rPr lang="en-US" sz="2800" dirty="0"/>
+              <a:t>(-1,0): e8, (-1,0): d8, (-1,0): c8, (-1,0): b8 (-1,0): a8 - obstacle: our color piece</a:t>
+            </a:r>
+          </a:p>
+          <a:p>
+            <a:r>
+              <a:rPr lang="en-US" sz="2800" dirty="0"/>
+              <a:t>Destination list: e8, d8, c8, b8</a:t>
+            </a:r>
+          </a:p>
+          <a:p>
+            <a:endParaRPr lang="en-US" dirty="0"/>
+          </a:p>
+        </p:txBody>
+      </p:sp>
+      <p:sp>
+        <p:nvSpPr>
+          <p:cNvPr id="2" name="Date Placeholder 1">
+            <a:extLst>
+              <a:ext uri="{FF2B5EF4-FFF2-40B4-BE49-F238E27FC236}">
+                <a16:creationId xmlns:a16="http://schemas.microsoft.com/office/drawing/2014/main" id="{0F09BEF5-825D-2520-80C5-9313DAD927AA}"/>
+              </a:ext>
+            </a:extLst>
+          </p:cNvPr>
+          <p:cNvSpPr>
+            <a:spLocks noGrp="1"/>
+          </p:cNvSpPr>
+          <p:nvPr>
+            <p:ph type="dt" sz="half" idx="10"/>
+          </p:nvPr>
+        </p:nvSpPr>
+        <p:spPr/>
+        <p:txBody>
+          <a:bodyPr/>
+          <a:lstStyle/>
+          <a:p>
+            <a:fld id="{F1811B85-6381-4843-915E-A80D8CF566B9}" type="datetime1">
+              <a:rPr lang="en-US" smtClean="0"/>
+              <a:t>7/27/2026</a:t>
+            </a:fld>
+            <a:endParaRPr lang="en-US" dirty="0"/>
+          </a:p>
+        </p:txBody>
+      </p:sp>
+      <p:sp>
+        <p:nvSpPr>
+          <p:cNvPr id="3" name="Footer Placeholder 2">
+            <a:extLst>
+              <a:ext uri="{FF2B5EF4-FFF2-40B4-BE49-F238E27FC236}">
+                <a16:creationId xmlns:a16="http://schemas.microsoft.com/office/drawing/2014/main" id="{EF55A215-0EEC-7189-78E9-F2F35F76ECFC}"/>
+              </a:ext>
+            </a:extLst>
+          </p:cNvPr>
+          <p:cNvSpPr>
+            <a:spLocks noGrp="1"/>
+          </p:cNvSpPr>
+          <p:nvPr>
+            <p:ph type="ftr" sz="quarter" idx="11"/>
+          </p:nvPr>
+        </p:nvSpPr>
+        <p:spPr/>
+        <p:txBody>
+          <a:bodyPr/>
+          <a:lstStyle/>
+          <a:p>
+            <a:r>
+              <a:rPr lang="en-US"/>
+              <a:t>raysmith@alum.mit.edu                     Session 2 – Building Blocks</a:t>
+            </a:r>
+            <a:endParaRPr lang="en-US" dirty="0"/>
+          </a:p>
+        </p:txBody>
+      </p:sp>
+      <p:sp>
+        <p:nvSpPr>
+          <p:cNvPr id="4" name="Slide Number Placeholder 3">
+            <a:extLst>
+              <a:ext uri="{FF2B5EF4-FFF2-40B4-BE49-F238E27FC236}">
+                <a16:creationId xmlns:a16="http://schemas.microsoft.com/office/drawing/2014/main" id="{4BCDD355-535D-D950-4741-34AE762C5740}"/>
+              </a:ext>
+            </a:extLst>
+          </p:cNvPr>
+          <p:cNvSpPr>
+            <a:spLocks noGrp="1"/>
+          </p:cNvSpPr>
+          <p:nvPr>
+            <p:ph type="sldNum" sz="quarter" idx="12"/>
+          </p:nvPr>
+        </p:nvSpPr>
+        <p:spPr/>
+        <p:txBody>
+          <a:bodyPr/>
+          <a:lstStyle/>
+          <a:p>
+            <a:fld id="{6D22F896-40B5-4ADD-8801-0D06FADFA095}" type="slidenum">
+              <a:rPr lang="en-US" smtClean="0"/>
+              <a:t>25</a:t>
+            </a:fld>
+            <a:endParaRPr lang="en-US" dirty="0"/>
+          </a:p>
+        </p:txBody>
+      </p:sp>
+    </p:spTree>
+    <p:extLst>
+      <p:ext uri="{BB962C8B-B14F-4D97-AF65-F5344CB8AC3E}">
+        <p14:creationId xmlns:p14="http://schemas.microsoft.com/office/powerpoint/2010/main" val="2904740161"/>
+      </p:ext>
+    </p:extLst>
+  </p:cSld>
+  <p:clrMapOvr>
+    <a:masterClrMapping/>
+  </p:clrMapOvr>
+</p:sld>
+</file>
+
 <file path=ppt/slides/slide26.xml><?xml version="1.0" encoding="utf-8"?>
 <p:sld xmlns:a="http://schemas.openxmlformats.org/drawingml/2006/main" xmlns:r="http://schemas.openxmlformats.org/officeDocument/2006/relationships" xmlns:p="http://schemas.openxmlformats.org/presentationml/2006/main">
   <p:cSld>
@@ -14026,201 +13809,6 @@
       </p:grpSpPr>
       <p:sp>
         <p:nvSpPr>
-          <p:cNvPr id="5" name="Title 4">
-            <a:extLst>
-              <a:ext uri="{FF2B5EF4-FFF2-40B4-BE49-F238E27FC236}">
-                <a16:creationId xmlns:a16="http://schemas.microsoft.com/office/drawing/2014/main" id="{BF9C39FE-31B9-52A2-5269-0EB66D0AE10D}"/>
-              </a:ext>
-            </a:extLst>
-          </p:cNvPr>
-          <p:cNvSpPr>
-            <a:spLocks noGrp="1"/>
-          </p:cNvSpPr>
-          <p:nvPr>
-            <p:ph type="title"/>
-          </p:nvPr>
-        </p:nvSpPr>
-        <p:spPr/>
-        <p:txBody>
-          <a:bodyPr/>
-          <a:lstStyle/>
-          <a:p>
-            <a:r>
-              <a:rPr lang="en-US" dirty="0"/>
-              <a:t>Destination squares after 16. Bc5</a:t>
-            </a:r>
-            <a:br>
-              <a:rPr lang="en-US" dirty="0"/>
-            </a:br>
-            <a:r>
-              <a:rPr lang="en-US" dirty="0"/>
-              <a:t>for Rook at F8</a:t>
-            </a:r>
-          </a:p>
-        </p:txBody>
-      </p:sp>
-      <p:sp>
-        <p:nvSpPr>
-          <p:cNvPr id="6" name="Content Placeholder 5">
-            <a:extLst>
-              <a:ext uri="{FF2B5EF4-FFF2-40B4-BE49-F238E27FC236}">
-                <a16:creationId xmlns:a16="http://schemas.microsoft.com/office/drawing/2014/main" id="{5BB596F4-9C52-73D1-825B-B95E6E35C4C0}"/>
-              </a:ext>
-            </a:extLst>
-          </p:cNvPr>
-          <p:cNvSpPr>
-            <a:spLocks noGrp="1"/>
-          </p:cNvSpPr>
-          <p:nvPr>
-            <p:ph idx="1"/>
-          </p:nvPr>
-        </p:nvSpPr>
-        <p:spPr/>
-        <p:txBody>
-          <a:bodyPr/>
-          <a:lstStyle/>
-          <a:p>
-            <a:r>
-              <a:rPr lang="en-US" sz="2800" dirty="0"/>
-              <a:t>(move direction): square - result</a:t>
-            </a:r>
-          </a:p>
-          <a:p>
-            <a:r>
-              <a:rPr lang="en-US" sz="2800" dirty="0"/>
-              <a:t>(-1,0): e8, (-1,0): d8, (-1,0): c8, (-1,0): b8 (-1,0): a8 - obstacle: our color piece</a:t>
-            </a:r>
-          </a:p>
-          <a:p>
-            <a:r>
-              <a:rPr lang="en-US" sz="2800" dirty="0"/>
-              <a:t>Destination list: e8, d8, c8, c8, b8</a:t>
-            </a:r>
-          </a:p>
-          <a:p>
-            <a:endParaRPr lang="en-US" dirty="0"/>
-          </a:p>
-        </p:txBody>
-      </p:sp>
-      <p:sp>
-        <p:nvSpPr>
-          <p:cNvPr id="2" name="Date Placeholder 1">
-            <a:extLst>
-              <a:ext uri="{FF2B5EF4-FFF2-40B4-BE49-F238E27FC236}">
-                <a16:creationId xmlns:a16="http://schemas.microsoft.com/office/drawing/2014/main" id="{0F09BEF5-825D-2520-80C5-9313DAD927AA}"/>
-              </a:ext>
-            </a:extLst>
-          </p:cNvPr>
-          <p:cNvSpPr>
-            <a:spLocks noGrp="1"/>
-          </p:cNvSpPr>
-          <p:nvPr>
-            <p:ph type="dt" sz="half" idx="10"/>
-          </p:nvPr>
-        </p:nvSpPr>
-        <p:spPr/>
-        <p:txBody>
-          <a:bodyPr/>
-          <a:lstStyle/>
-          <a:p>
-            <a:fld id="{F1811B85-6381-4843-915E-A80D8CF566B9}" type="datetime1">
-              <a:rPr lang="en-US" smtClean="0"/>
-              <a:t>7/24/2026</a:t>
-            </a:fld>
-            <a:endParaRPr lang="en-US" dirty="0"/>
-          </a:p>
-        </p:txBody>
-      </p:sp>
-      <p:sp>
-        <p:nvSpPr>
-          <p:cNvPr id="3" name="Footer Placeholder 2">
-            <a:extLst>
-              <a:ext uri="{FF2B5EF4-FFF2-40B4-BE49-F238E27FC236}">
-                <a16:creationId xmlns:a16="http://schemas.microsoft.com/office/drawing/2014/main" id="{EF55A215-0EEC-7189-78E9-F2F35F76ECFC}"/>
-              </a:ext>
-            </a:extLst>
-          </p:cNvPr>
-          <p:cNvSpPr>
-            <a:spLocks noGrp="1"/>
-          </p:cNvSpPr>
-          <p:nvPr>
-            <p:ph type="ftr" sz="quarter" idx="11"/>
-          </p:nvPr>
-        </p:nvSpPr>
-        <p:spPr/>
-        <p:txBody>
-          <a:bodyPr/>
-          <a:lstStyle/>
-          <a:p>
-            <a:r>
-              <a:rPr lang="en-US"/>
-              <a:t>raysmith@alum.mit.edu                     Session 2 – Building Blocks</a:t>
-            </a:r>
-            <a:endParaRPr lang="en-US" dirty="0"/>
-          </a:p>
-        </p:txBody>
-      </p:sp>
-      <p:sp>
-        <p:nvSpPr>
-          <p:cNvPr id="4" name="Slide Number Placeholder 3">
-            <a:extLst>
-              <a:ext uri="{FF2B5EF4-FFF2-40B4-BE49-F238E27FC236}">
-                <a16:creationId xmlns:a16="http://schemas.microsoft.com/office/drawing/2014/main" id="{4BCDD355-535D-D950-4741-34AE762C5740}"/>
-              </a:ext>
-            </a:extLst>
-          </p:cNvPr>
-          <p:cNvSpPr>
-            <a:spLocks noGrp="1"/>
-          </p:cNvSpPr>
-          <p:nvPr>
-            <p:ph type="sldNum" sz="quarter" idx="12"/>
-          </p:nvPr>
-        </p:nvSpPr>
-        <p:spPr/>
-        <p:txBody>
-          <a:bodyPr/>
-          <a:lstStyle/>
-          <a:p>
-            <a:fld id="{6D22F896-40B5-4ADD-8801-0D06FADFA095}" type="slidenum">
-              <a:rPr lang="en-US" smtClean="0"/>
-              <a:t>26</a:t>
-            </a:fld>
-            <a:endParaRPr lang="en-US" dirty="0"/>
-          </a:p>
-        </p:txBody>
-      </p:sp>
-    </p:spTree>
-    <p:extLst>
-      <p:ext uri="{BB962C8B-B14F-4D97-AF65-F5344CB8AC3E}">
-        <p14:creationId xmlns:p14="http://schemas.microsoft.com/office/powerpoint/2010/main" val="2904740161"/>
-      </p:ext>
-    </p:extLst>
-  </p:cSld>
-  <p:clrMapOvr>
-    <a:masterClrMapping/>
-  </p:clrMapOvr>
-</p:sld>
-</file>
-
-<file path=ppt/slides/slide27.xml><?xml version="1.0" encoding="utf-8"?>
-<p:sld xmlns:a="http://schemas.openxmlformats.org/drawingml/2006/main" xmlns:r="http://schemas.openxmlformats.org/officeDocument/2006/relationships" xmlns:p="http://schemas.openxmlformats.org/presentationml/2006/main">
-  <p:cSld>
-    <p:spTree>
-      <p:nvGrpSpPr>
-        <p:cNvPr id="1" name=""/>
-        <p:cNvGrpSpPr/>
-        <p:nvPr/>
-      </p:nvGrpSpPr>
-      <p:grpSpPr>
-        <a:xfrm>
-          <a:off x="0" y="0"/>
-          <a:ext cx="0" cy="0"/>
-          <a:chOff x="0" y="0"/>
-          <a:chExt cx="0" cy="0"/>
-        </a:xfrm>
-      </p:grpSpPr>
-      <p:sp>
-        <p:nvSpPr>
           <p:cNvPr id="2" name="Title 1">
             <a:extLst>
               <a:ext uri="{FF2B5EF4-FFF2-40B4-BE49-F238E27FC236}">
@@ -14277,7 +13865,7 @@
           <a:p>
             <a:fld id="{D4091550-E13A-47A9-8AAC-51D029CF9A78}" type="datetime1">
               <a:rPr lang="en-US" smtClean="0"/>
-              <a:t>7/24/2026</a:t>
+              <a:t>7/27/2026</a:t>
             </a:fld>
             <a:endParaRPr lang="en-US" dirty="0"/>
           </a:p>
@@ -14335,7 +13923,7 @@
           <a:p>
             <a:fld id="{6D22F896-40B5-4ADD-8801-0D06FADFA095}" type="slidenum">
               <a:rPr lang="en-US" smtClean="0"/>
-              <a:t>27</a:t>
+              <a:t>26</a:t>
             </a:fld>
             <a:endParaRPr lang="en-US" dirty="0"/>
           </a:p>
@@ -14478,7 +14066,7 @@
           <a:p>
             <a:fld id="{771FCE44-14AA-407B-9781-80C2DD8F374A}" type="datetime1">
               <a:rPr lang="en-US" smtClean="0"/>
-              <a:t>7/24/2026</a:t>
+              <a:t>7/27/2026</a:t>
             </a:fld>
             <a:endParaRPr lang="en-US" dirty="0"/>
           </a:p>
@@ -14704,7 +14292,7 @@
           <a:p>
             <a:fld id="{771FCE44-14AA-407B-9781-80C2DD8F374A}" type="datetime1">
               <a:rPr lang="en-US" smtClean="0"/>
-              <a:t>7/24/2026</a:t>
+              <a:t>7/27/2026</a:t>
             </a:fld>
             <a:endParaRPr lang="en-US" dirty="0"/>
           </a:p>
@@ -14942,7 +14530,7 @@
           <a:p>
             <a:fld id="{771FCE44-14AA-407B-9781-80C2DD8F374A}" type="datetime1">
               <a:rPr lang="en-US" smtClean="0"/>
-              <a:t>7/24/2026</a:t>
+              <a:t>7/27/2026</a:t>
             </a:fld>
             <a:endParaRPr lang="en-US" dirty="0"/>
           </a:p>
@@ -15072,7 +14660,7 @@
             <a:fld id="{6F8407F0-4949-4EDC-A592-6ECEEFF5A038}" type="datetime1">
               <a:rPr lang="en-US" smtClean="0"/>
               <a:pPr/>
-              <a:t>7/24/2026</a:t>
+              <a:t>7/27/2026</a:t>
             </a:fld>
             <a:endParaRPr lang="en-US" dirty="0"/>
           </a:p>
@@ -15227,7 +14815,7 @@
             <a:fld id="{6F8407F0-4949-4EDC-A592-6ECEEFF5A038}" type="datetime1">
               <a:rPr lang="en-US" smtClean="0"/>
               <a:pPr/>
-              <a:t>7/24/2026</a:t>
+              <a:t>7/27/2026</a:t>
             </a:fld>
             <a:endParaRPr lang="en-US" dirty="0"/>
           </a:p>
@@ -15554,7 +15142,7 @@
           <a:p>
             <a:fld id="{6F8407F0-4949-4EDC-A592-6ECEEFF5A038}" type="datetime1">
               <a:rPr lang="en-US" smtClean="0"/>
-              <a:t>7/24/2026</a:t>
+              <a:t>7/27/2026</a:t>
             </a:fld>
             <a:endParaRPr lang="en-US" dirty="0"/>
           </a:p>
@@ -15799,7 +15387,7 @@
           <a:p>
             <a:fld id="{6F8407F0-4949-4EDC-A592-6ECEEFF5A038}" type="datetime1">
               <a:rPr lang="en-US" smtClean="0"/>
-              <a:t>7/24/2026</a:t>
+              <a:t>7/27/2026</a:t>
             </a:fld>
             <a:endParaRPr lang="en-US" dirty="0"/>
           </a:p>

</xml_diff>

<commit_message>
Add a few slides on algebraic notation parsing.
</commit_message>
<xml_diff>
--- a/Docs/Chess Display and Computers.pptx
+++ b/Docs/Chess Display and Computers.pptx
@@ -5,10 +5,10 @@
     <p:sldMasterId id="2147483687" r:id="rId1"/>
   </p:sldMasterIdLst>
   <p:notesMasterIdLst>
-    <p:notesMasterId r:id="rId28"/>
+    <p:notesMasterId r:id="rId30"/>
   </p:notesMasterIdLst>
   <p:handoutMasterIdLst>
-    <p:handoutMasterId r:id="rId29"/>
+    <p:handoutMasterId r:id="rId31"/>
   </p:handoutMasterIdLst>
   <p:sldIdLst>
     <p:sldId id="256" r:id="rId2"/>
@@ -25,18 +25,20 @@
     <p:sldId id="410" r:id="rId13"/>
     <p:sldId id="414" r:id="rId14"/>
     <p:sldId id="415" r:id="rId15"/>
-    <p:sldId id="416" r:id="rId16"/>
-    <p:sldId id="421" r:id="rId17"/>
-    <p:sldId id="424" r:id="rId18"/>
-    <p:sldId id="418" r:id="rId19"/>
-    <p:sldId id="420" r:id="rId20"/>
-    <p:sldId id="422" r:id="rId21"/>
-    <p:sldId id="423" r:id="rId22"/>
-    <p:sldId id="417" r:id="rId23"/>
-    <p:sldId id="427" r:id="rId24"/>
-    <p:sldId id="430" r:id="rId25"/>
-    <p:sldId id="429" r:id="rId26"/>
-    <p:sldId id="403" r:id="rId27"/>
+    <p:sldId id="432" r:id="rId16"/>
+    <p:sldId id="431" r:id="rId17"/>
+    <p:sldId id="416" r:id="rId18"/>
+    <p:sldId id="421" r:id="rId19"/>
+    <p:sldId id="424" r:id="rId20"/>
+    <p:sldId id="418" r:id="rId21"/>
+    <p:sldId id="420" r:id="rId22"/>
+    <p:sldId id="422" r:id="rId23"/>
+    <p:sldId id="423" r:id="rId24"/>
+    <p:sldId id="433" r:id="rId25"/>
+    <p:sldId id="427" r:id="rId26"/>
+    <p:sldId id="430" r:id="rId27"/>
+    <p:sldId id="429" r:id="rId28"/>
+    <p:sldId id="403" r:id="rId29"/>
   </p:sldIdLst>
   <p:sldSz cx="12192000" cy="6858000"/>
   <p:notesSz cx="7102475" cy="9388475"/>
@@ -256,7 +258,7 @@
           <a:p>
             <a:fld id="{71F68F6A-2B9C-4819-AC3B-6AE3589F1402}" type="datetime1">
               <a:rPr lang="en-US" smtClean="0"/>
-              <a:t>7/27/2026</a:t>
+              <a:t>8/8/2026</a:t>
             </a:fld>
             <a:endParaRPr lang="en-US" dirty="0"/>
           </a:p>
@@ -440,7 +442,7 @@
           <a:p>
             <a:fld id="{5397933D-7A1B-4403-8C00-DE52D8FE2162}" type="datetime1">
               <a:rPr lang="en-US" smtClean="0"/>
-              <a:t>7/27/2026</a:t>
+              <a:t>8/5/2026</a:t>
             </a:fld>
             <a:endParaRPr lang="en-US" dirty="0"/>
           </a:p>
@@ -805,7 +807,7 @@
           <a:p>
             <a:fld id="{DC084F0E-41CF-4207-8B70-198F21418836}" type="datetime1">
               <a:rPr lang="en-US" smtClean="0"/>
-              <a:t>7/27/2026</a:t>
+              <a:t>8/5/2026</a:t>
             </a:fld>
             <a:endParaRPr lang="en-US" dirty="0"/>
           </a:p>
@@ -993,7 +995,7 @@
           <a:p>
             <a:fld id="{E734D050-5128-424E-B0C7-5BFB4917C3AB}" type="datetime1">
               <a:rPr lang="en-US" smtClean="0"/>
-              <a:t>7/27/2026</a:t>
+              <a:t>8/5/2026</a:t>
             </a:fld>
             <a:endParaRPr lang="en-US" dirty="0"/>
           </a:p>
@@ -1070,6 +1072,406 @@
 </file>
 
 <file path=ppt/notesSlides/notesSlide11.xml><?xml version="1.0" encoding="utf-8"?>
+<p:notes xmlns:a="http://schemas.openxmlformats.org/drawingml/2006/main" xmlns:r="http://schemas.openxmlformats.org/officeDocument/2006/relationships" xmlns:p="http://schemas.openxmlformats.org/presentationml/2006/main">
+  <p:cSld>
+    <p:spTree>
+      <p:nvGrpSpPr>
+        <p:cNvPr id="1" name="">
+          <a:extLst>
+            <a:ext uri="{FF2B5EF4-FFF2-40B4-BE49-F238E27FC236}">
+              <a16:creationId xmlns:a16="http://schemas.microsoft.com/office/drawing/2014/main" id="{EE0F1C5B-21A3-B698-A521-3EDABE9E6949}"/>
+            </a:ext>
+          </a:extLst>
+        </p:cNvPr>
+        <p:cNvGrpSpPr/>
+        <p:nvPr/>
+      </p:nvGrpSpPr>
+      <p:grpSpPr>
+        <a:xfrm>
+          <a:off x="0" y="0"/>
+          <a:ext cx="0" cy="0"/>
+          <a:chOff x="0" y="0"/>
+          <a:chExt cx="0" cy="0"/>
+        </a:xfrm>
+      </p:grpSpPr>
+      <p:sp>
+        <p:nvSpPr>
+          <p:cNvPr id="2" name="Slide Image Placeholder 1">
+            <a:extLst>
+              <a:ext uri="{FF2B5EF4-FFF2-40B4-BE49-F238E27FC236}">
+                <a16:creationId xmlns:a16="http://schemas.microsoft.com/office/drawing/2014/main" id="{0D7924EE-5201-9F1B-E432-300631F318BA}"/>
+              </a:ext>
+            </a:extLst>
+          </p:cNvPr>
+          <p:cNvSpPr>
+            <a:spLocks noGrp="1" noRot="1" noChangeAspect="1"/>
+          </p:cNvSpPr>
+          <p:nvPr>
+            <p:ph type="sldImg"/>
+          </p:nvPr>
+        </p:nvSpPr>
+        <p:spPr/>
+        <p:txBody>
+          <a:bodyPr/>
+          <a:lstStyle/>
+          <a:p>
+            <a:endParaRPr lang="en-US"/>
+          </a:p>
+        </p:txBody>
+      </p:sp>
+      <p:sp>
+        <p:nvSpPr>
+          <p:cNvPr id="3" name="Notes Placeholder 2">
+            <a:extLst>
+              <a:ext uri="{FF2B5EF4-FFF2-40B4-BE49-F238E27FC236}">
+                <a16:creationId xmlns:a16="http://schemas.microsoft.com/office/drawing/2014/main" id="{BA420542-02BF-A0FD-1519-B9232FE29AAB}"/>
+              </a:ext>
+            </a:extLst>
+          </p:cNvPr>
+          <p:cNvSpPr>
+            <a:spLocks noGrp="1"/>
+          </p:cNvSpPr>
+          <p:nvPr>
+            <p:ph type="body" idx="1"/>
+          </p:nvPr>
+        </p:nvSpPr>
+        <p:spPr/>
+        <p:txBody>
+          <a:bodyPr/>
+          <a:lstStyle/>
+          <a:p>
+            <a:endParaRPr lang="en-US" dirty="0"/>
+          </a:p>
+        </p:txBody>
+      </p:sp>
+      <p:sp>
+        <p:nvSpPr>
+          <p:cNvPr id="4" name="Header Placeholder 3">
+            <a:extLst>
+              <a:ext uri="{FF2B5EF4-FFF2-40B4-BE49-F238E27FC236}">
+                <a16:creationId xmlns:a16="http://schemas.microsoft.com/office/drawing/2014/main" id="{53BCE171-2978-83D8-7FC9-A030B0043B0B}"/>
+              </a:ext>
+            </a:extLst>
+          </p:cNvPr>
+          <p:cNvSpPr>
+            <a:spLocks noGrp="1"/>
+          </p:cNvSpPr>
+          <p:nvPr>
+            <p:ph type="hdr" sz="quarter" idx="10"/>
+          </p:nvPr>
+        </p:nvSpPr>
+        <p:spPr/>
+        <p:txBody>
+          <a:bodyPr/>
+          <a:lstStyle/>
+          <a:p>
+            <a:r>
+              <a:rPr lang="en-US" dirty="0"/>
+              <a:t>Introduction to Programming using Python</a:t>
+            </a:r>
+          </a:p>
+        </p:txBody>
+      </p:sp>
+      <p:sp>
+        <p:nvSpPr>
+          <p:cNvPr id="5" name="Date Placeholder 4">
+            <a:extLst>
+              <a:ext uri="{FF2B5EF4-FFF2-40B4-BE49-F238E27FC236}">
+                <a16:creationId xmlns:a16="http://schemas.microsoft.com/office/drawing/2014/main" id="{8C89C607-B129-9FFC-9FED-F0E57B3997AE}"/>
+              </a:ext>
+            </a:extLst>
+          </p:cNvPr>
+          <p:cNvSpPr>
+            <a:spLocks noGrp="1"/>
+          </p:cNvSpPr>
+          <p:nvPr>
+            <p:ph type="dt" idx="11"/>
+          </p:nvPr>
+        </p:nvSpPr>
+        <p:spPr/>
+        <p:txBody>
+          <a:bodyPr/>
+          <a:lstStyle/>
+          <a:p>
+            <a:fld id="{E734D050-5128-424E-B0C7-5BFB4917C3AB}" type="datetime1">
+              <a:rPr lang="en-US" smtClean="0"/>
+              <a:t>8/8/2026</a:t>
+            </a:fld>
+            <a:endParaRPr lang="en-US" dirty="0"/>
+          </a:p>
+        </p:txBody>
+      </p:sp>
+      <p:sp>
+        <p:nvSpPr>
+          <p:cNvPr id="6" name="Footer Placeholder 5">
+            <a:extLst>
+              <a:ext uri="{FF2B5EF4-FFF2-40B4-BE49-F238E27FC236}">
+                <a16:creationId xmlns:a16="http://schemas.microsoft.com/office/drawing/2014/main" id="{8BAEC99A-A3F0-6DCC-1687-5975DFD34704}"/>
+              </a:ext>
+            </a:extLst>
+          </p:cNvPr>
+          <p:cNvSpPr>
+            <a:spLocks noGrp="1"/>
+          </p:cNvSpPr>
+          <p:nvPr>
+            <p:ph type="ftr" sz="quarter" idx="12"/>
+          </p:nvPr>
+        </p:nvSpPr>
+        <p:spPr/>
+        <p:txBody>
+          <a:bodyPr/>
+          <a:lstStyle/>
+          <a:p>
+            <a:r>
+              <a:rPr lang="en-US" dirty="0"/>
+              <a:t>raysmith@alum.mit.edu</a:t>
+            </a:r>
+          </a:p>
+        </p:txBody>
+      </p:sp>
+      <p:sp>
+        <p:nvSpPr>
+          <p:cNvPr id="7" name="Slide Number Placeholder 6">
+            <a:extLst>
+              <a:ext uri="{FF2B5EF4-FFF2-40B4-BE49-F238E27FC236}">
+                <a16:creationId xmlns:a16="http://schemas.microsoft.com/office/drawing/2014/main" id="{A33BB619-6C5A-3E81-5B8D-10D6EF93B45E}"/>
+              </a:ext>
+            </a:extLst>
+          </p:cNvPr>
+          <p:cNvSpPr>
+            <a:spLocks noGrp="1"/>
+          </p:cNvSpPr>
+          <p:nvPr>
+            <p:ph type="sldNum" sz="quarter" idx="13"/>
+          </p:nvPr>
+        </p:nvSpPr>
+        <p:spPr/>
+        <p:txBody>
+          <a:bodyPr/>
+          <a:lstStyle/>
+          <a:p>
+            <a:fld id="{BA791329-992B-4F83-8435-C33B0EC26DB3}" type="slidenum">
+              <a:rPr lang="en-US" smtClean="0"/>
+              <a:t>15</a:t>
+            </a:fld>
+            <a:endParaRPr lang="en-US" dirty="0"/>
+          </a:p>
+        </p:txBody>
+      </p:sp>
+    </p:spTree>
+    <p:extLst>
+      <p:ext uri="{BB962C8B-B14F-4D97-AF65-F5344CB8AC3E}">
+        <p14:creationId xmlns:p14="http://schemas.microsoft.com/office/powerpoint/2010/main" val="2314095251"/>
+      </p:ext>
+    </p:extLst>
+  </p:cSld>
+  <p:clrMapOvr>
+    <a:masterClrMapping/>
+  </p:clrMapOvr>
+</p:notes>
+</file>
+
+<file path=ppt/notesSlides/notesSlide12.xml><?xml version="1.0" encoding="utf-8"?>
+<p:notes xmlns:a="http://schemas.openxmlformats.org/drawingml/2006/main" xmlns:r="http://schemas.openxmlformats.org/officeDocument/2006/relationships" xmlns:p="http://schemas.openxmlformats.org/presentationml/2006/main">
+  <p:cSld>
+    <p:spTree>
+      <p:nvGrpSpPr>
+        <p:cNvPr id="1" name="">
+          <a:extLst>
+            <a:ext uri="{FF2B5EF4-FFF2-40B4-BE49-F238E27FC236}">
+              <a16:creationId xmlns:a16="http://schemas.microsoft.com/office/drawing/2014/main" id="{000B4967-581F-7965-1CD2-0857D531184C}"/>
+            </a:ext>
+          </a:extLst>
+        </p:cNvPr>
+        <p:cNvGrpSpPr/>
+        <p:nvPr/>
+      </p:nvGrpSpPr>
+      <p:grpSpPr>
+        <a:xfrm>
+          <a:off x="0" y="0"/>
+          <a:ext cx="0" cy="0"/>
+          <a:chOff x="0" y="0"/>
+          <a:chExt cx="0" cy="0"/>
+        </a:xfrm>
+      </p:grpSpPr>
+      <p:sp>
+        <p:nvSpPr>
+          <p:cNvPr id="2" name="Slide Image Placeholder 1">
+            <a:extLst>
+              <a:ext uri="{FF2B5EF4-FFF2-40B4-BE49-F238E27FC236}">
+                <a16:creationId xmlns:a16="http://schemas.microsoft.com/office/drawing/2014/main" id="{DC540A5F-310A-2B9B-C2AD-1F56B2DF70E0}"/>
+              </a:ext>
+            </a:extLst>
+          </p:cNvPr>
+          <p:cNvSpPr>
+            <a:spLocks noGrp="1" noRot="1" noChangeAspect="1"/>
+          </p:cNvSpPr>
+          <p:nvPr>
+            <p:ph type="sldImg"/>
+          </p:nvPr>
+        </p:nvSpPr>
+        <p:spPr/>
+        <p:txBody>
+          <a:bodyPr/>
+          <a:lstStyle/>
+          <a:p>
+            <a:endParaRPr lang="en-US"/>
+          </a:p>
+        </p:txBody>
+      </p:sp>
+      <p:sp>
+        <p:nvSpPr>
+          <p:cNvPr id="3" name="Notes Placeholder 2">
+            <a:extLst>
+              <a:ext uri="{FF2B5EF4-FFF2-40B4-BE49-F238E27FC236}">
+                <a16:creationId xmlns:a16="http://schemas.microsoft.com/office/drawing/2014/main" id="{FC4393BE-5BDC-954B-4E0D-A34E12C44754}"/>
+              </a:ext>
+            </a:extLst>
+          </p:cNvPr>
+          <p:cNvSpPr>
+            <a:spLocks noGrp="1"/>
+          </p:cNvSpPr>
+          <p:nvPr>
+            <p:ph type="body" idx="1"/>
+          </p:nvPr>
+        </p:nvSpPr>
+        <p:spPr/>
+        <p:txBody>
+          <a:bodyPr/>
+          <a:lstStyle/>
+          <a:p>
+            <a:endParaRPr lang="en-US" dirty="0"/>
+          </a:p>
+        </p:txBody>
+      </p:sp>
+      <p:sp>
+        <p:nvSpPr>
+          <p:cNvPr id="4" name="Header Placeholder 3">
+            <a:extLst>
+              <a:ext uri="{FF2B5EF4-FFF2-40B4-BE49-F238E27FC236}">
+                <a16:creationId xmlns:a16="http://schemas.microsoft.com/office/drawing/2014/main" id="{DCEA7FB0-E5DE-4980-7A06-7BD8486574F8}"/>
+              </a:ext>
+            </a:extLst>
+          </p:cNvPr>
+          <p:cNvSpPr>
+            <a:spLocks noGrp="1"/>
+          </p:cNvSpPr>
+          <p:nvPr>
+            <p:ph type="hdr" sz="quarter" idx="10"/>
+          </p:nvPr>
+        </p:nvSpPr>
+        <p:spPr/>
+        <p:txBody>
+          <a:bodyPr/>
+          <a:lstStyle/>
+          <a:p>
+            <a:r>
+              <a:rPr lang="en-US" dirty="0"/>
+              <a:t>Introduction to Programming using Python</a:t>
+            </a:r>
+          </a:p>
+        </p:txBody>
+      </p:sp>
+      <p:sp>
+        <p:nvSpPr>
+          <p:cNvPr id="5" name="Date Placeholder 4">
+            <a:extLst>
+              <a:ext uri="{FF2B5EF4-FFF2-40B4-BE49-F238E27FC236}">
+                <a16:creationId xmlns:a16="http://schemas.microsoft.com/office/drawing/2014/main" id="{FC9587F0-A22F-D89C-AD22-15A4110B2B60}"/>
+              </a:ext>
+            </a:extLst>
+          </p:cNvPr>
+          <p:cNvSpPr>
+            <a:spLocks noGrp="1"/>
+          </p:cNvSpPr>
+          <p:nvPr>
+            <p:ph type="dt" idx="11"/>
+          </p:nvPr>
+        </p:nvSpPr>
+        <p:spPr/>
+        <p:txBody>
+          <a:bodyPr/>
+          <a:lstStyle/>
+          <a:p>
+            <a:fld id="{E734D050-5128-424E-B0C7-5BFB4917C3AB}" type="datetime1">
+              <a:rPr lang="en-US" smtClean="0"/>
+              <a:t>8/8/2026</a:t>
+            </a:fld>
+            <a:endParaRPr lang="en-US" dirty="0"/>
+          </a:p>
+        </p:txBody>
+      </p:sp>
+      <p:sp>
+        <p:nvSpPr>
+          <p:cNvPr id="6" name="Footer Placeholder 5">
+            <a:extLst>
+              <a:ext uri="{FF2B5EF4-FFF2-40B4-BE49-F238E27FC236}">
+                <a16:creationId xmlns:a16="http://schemas.microsoft.com/office/drawing/2014/main" id="{57DB71FC-6CF3-F9E3-D5E5-0FA9DDD1A55E}"/>
+              </a:ext>
+            </a:extLst>
+          </p:cNvPr>
+          <p:cNvSpPr>
+            <a:spLocks noGrp="1"/>
+          </p:cNvSpPr>
+          <p:nvPr>
+            <p:ph type="ftr" sz="quarter" idx="12"/>
+          </p:nvPr>
+        </p:nvSpPr>
+        <p:spPr/>
+        <p:txBody>
+          <a:bodyPr/>
+          <a:lstStyle/>
+          <a:p>
+            <a:r>
+              <a:rPr lang="en-US" dirty="0"/>
+              <a:t>raysmith@alum.mit.edu</a:t>
+            </a:r>
+          </a:p>
+        </p:txBody>
+      </p:sp>
+      <p:sp>
+        <p:nvSpPr>
+          <p:cNvPr id="7" name="Slide Number Placeholder 6">
+            <a:extLst>
+              <a:ext uri="{FF2B5EF4-FFF2-40B4-BE49-F238E27FC236}">
+                <a16:creationId xmlns:a16="http://schemas.microsoft.com/office/drawing/2014/main" id="{CA81548E-94F5-F6E1-E043-75207682C7DF}"/>
+              </a:ext>
+            </a:extLst>
+          </p:cNvPr>
+          <p:cNvSpPr>
+            <a:spLocks noGrp="1"/>
+          </p:cNvSpPr>
+          <p:nvPr>
+            <p:ph type="sldNum" sz="quarter" idx="13"/>
+          </p:nvPr>
+        </p:nvSpPr>
+        <p:spPr/>
+        <p:txBody>
+          <a:bodyPr/>
+          <a:lstStyle/>
+          <a:p>
+            <a:fld id="{BA791329-992B-4F83-8435-C33B0EC26DB3}" type="slidenum">
+              <a:rPr lang="en-US" smtClean="0"/>
+              <a:t>16</a:t>
+            </a:fld>
+            <a:endParaRPr lang="en-US" dirty="0"/>
+          </a:p>
+        </p:txBody>
+      </p:sp>
+    </p:spTree>
+    <p:extLst>
+      <p:ext uri="{BB962C8B-B14F-4D97-AF65-F5344CB8AC3E}">
+        <p14:creationId xmlns:p14="http://schemas.microsoft.com/office/powerpoint/2010/main" val="379860042"/>
+      </p:ext>
+    </p:extLst>
+  </p:cSld>
+  <p:clrMapOvr>
+    <a:masterClrMapping/>
+  </p:clrMapOvr>
+</p:notes>
+</file>
+
+<file path=ppt/notesSlides/notesSlide13.xml><?xml version="1.0" encoding="utf-8"?>
 <p:notes xmlns:a="http://schemas.openxmlformats.org/drawingml/2006/main" xmlns:r="http://schemas.openxmlformats.org/officeDocument/2006/relationships" xmlns:p="http://schemas.openxmlformats.org/presentationml/2006/main">
   <p:cSld>
     <p:spTree>
@@ -1193,7 +1595,7 @@
           <a:p>
             <a:fld id="{E734D050-5128-424E-B0C7-5BFB4917C3AB}" type="datetime1">
               <a:rPr lang="en-US" smtClean="0"/>
-              <a:t>7/27/2026</a:t>
+              <a:t>8/5/2026</a:t>
             </a:fld>
             <a:endParaRPr lang="en-US" dirty="0"/>
           </a:p>
@@ -1250,7 +1652,7 @@
           <a:p>
             <a:fld id="{BA791329-992B-4F83-8435-C33B0EC26DB3}" type="slidenum">
               <a:rPr lang="en-US" smtClean="0"/>
-              <a:t>15</a:t>
+              <a:t>17</a:t>
             </a:fld>
             <a:endParaRPr lang="en-US" dirty="0"/>
           </a:p>
@@ -1260,329 +1662,6 @@
     <p:extLst>
       <p:ext uri="{BB962C8B-B14F-4D97-AF65-F5344CB8AC3E}">
         <p14:creationId xmlns:p14="http://schemas.microsoft.com/office/powerpoint/2010/main" val="222032709"/>
-      </p:ext>
-    </p:extLst>
-  </p:cSld>
-  <p:clrMapOvr>
-    <a:masterClrMapping/>
-  </p:clrMapOvr>
-</p:notes>
-</file>
-
-<file path=ppt/notesSlides/notesSlide12.xml><?xml version="1.0" encoding="utf-8"?>
-<p:notes xmlns:a="http://schemas.openxmlformats.org/drawingml/2006/main" xmlns:r="http://schemas.openxmlformats.org/officeDocument/2006/relationships" xmlns:p="http://schemas.openxmlformats.org/presentationml/2006/main">
-  <p:cSld>
-    <p:spTree>
-      <p:nvGrpSpPr>
-        <p:cNvPr id="1" name=""/>
-        <p:cNvGrpSpPr/>
-        <p:nvPr/>
-      </p:nvGrpSpPr>
-      <p:grpSpPr>
-        <a:xfrm>
-          <a:off x="0" y="0"/>
-          <a:ext cx="0" cy="0"/>
-          <a:chOff x="0" y="0"/>
-          <a:chExt cx="0" cy="0"/>
-        </a:xfrm>
-      </p:grpSpPr>
-      <p:sp>
-        <p:nvSpPr>
-          <p:cNvPr id="2" name="Slide Image Placeholder 1"/>
-          <p:cNvSpPr>
-            <a:spLocks noGrp="1" noRot="1" noChangeAspect="1"/>
-          </p:cNvSpPr>
-          <p:nvPr>
-            <p:ph type="sldImg"/>
-          </p:nvPr>
-        </p:nvSpPr>
-        <p:spPr/>
-        <p:txBody>
-          <a:bodyPr/>
-          <a:lstStyle/>
-          <a:p>
-            <a:endParaRPr lang="en-US"/>
-          </a:p>
-        </p:txBody>
-      </p:sp>
-      <p:sp>
-        <p:nvSpPr>
-          <p:cNvPr id="3" name="Notes Placeholder 2"/>
-          <p:cNvSpPr>
-            <a:spLocks noGrp="1"/>
-          </p:cNvSpPr>
-          <p:nvPr>
-            <p:ph type="body" idx="1"/>
-          </p:nvPr>
-        </p:nvSpPr>
-        <p:spPr/>
-        <p:txBody>
-          <a:bodyPr/>
-          <a:lstStyle/>
-          <a:p>
-            <a:r>
-              <a:rPr lang="en-US" dirty="0"/>
-              <a:t>Table reverses up(1) with down(-1) for black</a:t>
-            </a:r>
-          </a:p>
-        </p:txBody>
-      </p:sp>
-      <p:sp>
-        <p:nvSpPr>
-          <p:cNvPr id="4" name="Header Placeholder 3"/>
-          <p:cNvSpPr>
-            <a:spLocks noGrp="1"/>
-          </p:cNvSpPr>
-          <p:nvPr>
-            <p:ph type="hdr" sz="quarter"/>
-          </p:nvPr>
-        </p:nvSpPr>
-        <p:spPr/>
-        <p:txBody>
-          <a:bodyPr/>
-          <a:lstStyle/>
-          <a:p>
-            <a:r>
-              <a:rPr lang="en-US"/>
-              <a:t>Introduction to Programming using Python</a:t>
-            </a:r>
-            <a:endParaRPr lang="en-US" dirty="0"/>
-          </a:p>
-        </p:txBody>
-      </p:sp>
-      <p:sp>
-        <p:nvSpPr>
-          <p:cNvPr id="5" name="Date Placeholder 4"/>
-          <p:cNvSpPr>
-            <a:spLocks noGrp="1"/>
-          </p:cNvSpPr>
-          <p:nvPr>
-            <p:ph type="dt" idx="1"/>
-          </p:nvPr>
-        </p:nvSpPr>
-        <p:spPr/>
-        <p:txBody>
-          <a:bodyPr/>
-          <a:lstStyle/>
-          <a:p>
-            <a:fld id="{5397933D-7A1B-4403-8C00-DE52D8FE2162}" type="datetime1">
-              <a:rPr lang="en-US" smtClean="0"/>
-              <a:t>7/27/2026</a:t>
-            </a:fld>
-            <a:endParaRPr lang="en-US" dirty="0"/>
-          </a:p>
-        </p:txBody>
-      </p:sp>
-      <p:sp>
-        <p:nvSpPr>
-          <p:cNvPr id="6" name="Footer Placeholder 5"/>
-          <p:cNvSpPr>
-            <a:spLocks noGrp="1"/>
-          </p:cNvSpPr>
-          <p:nvPr>
-            <p:ph type="ftr" sz="quarter" idx="4"/>
-          </p:nvPr>
-        </p:nvSpPr>
-        <p:spPr/>
-        <p:txBody>
-          <a:bodyPr/>
-          <a:lstStyle/>
-          <a:p>
-            <a:r>
-              <a:rPr lang="en-US"/>
-              <a:t>raysmith@alum.mit.edu</a:t>
-            </a:r>
-            <a:endParaRPr lang="en-US" dirty="0"/>
-          </a:p>
-        </p:txBody>
-      </p:sp>
-      <p:sp>
-        <p:nvSpPr>
-          <p:cNvPr id="7" name="Slide Number Placeholder 6"/>
-          <p:cNvSpPr>
-            <a:spLocks noGrp="1"/>
-          </p:cNvSpPr>
-          <p:nvPr>
-            <p:ph type="sldNum" sz="quarter" idx="5"/>
-          </p:nvPr>
-        </p:nvSpPr>
-        <p:spPr/>
-        <p:txBody>
-          <a:bodyPr/>
-          <a:lstStyle/>
-          <a:p>
-            <a:fld id="{BA791329-992B-4F83-8435-C33B0EC26DB3}" type="slidenum">
-              <a:rPr lang="en-US" smtClean="0"/>
-              <a:t>19</a:t>
-            </a:fld>
-            <a:endParaRPr lang="en-US" dirty="0"/>
-          </a:p>
-        </p:txBody>
-      </p:sp>
-    </p:spTree>
-    <p:extLst>
-      <p:ext uri="{BB962C8B-B14F-4D97-AF65-F5344CB8AC3E}">
-        <p14:creationId xmlns:p14="http://schemas.microsoft.com/office/powerpoint/2010/main" val="1724100328"/>
-      </p:ext>
-    </p:extLst>
-  </p:cSld>
-  <p:clrMapOvr>
-    <a:masterClrMapping/>
-  </p:clrMapOvr>
-</p:notes>
-</file>
-
-<file path=ppt/notesSlides/notesSlide13.xml><?xml version="1.0" encoding="utf-8"?>
-<p:notes xmlns:a="http://schemas.openxmlformats.org/drawingml/2006/main" xmlns:r="http://schemas.openxmlformats.org/officeDocument/2006/relationships" xmlns:p="http://schemas.openxmlformats.org/presentationml/2006/main">
-  <p:cSld>
-    <p:spTree>
-      <p:nvGrpSpPr>
-        <p:cNvPr id="1" name=""/>
-        <p:cNvGrpSpPr/>
-        <p:nvPr/>
-      </p:nvGrpSpPr>
-      <p:grpSpPr>
-        <a:xfrm>
-          <a:off x="0" y="0"/>
-          <a:ext cx="0" cy="0"/>
-          <a:chOff x="0" y="0"/>
-          <a:chExt cx="0" cy="0"/>
-        </a:xfrm>
-      </p:grpSpPr>
-      <p:sp>
-        <p:nvSpPr>
-          <p:cNvPr id="2" name="Slide Image Placeholder 1"/>
-          <p:cNvSpPr>
-            <a:spLocks noGrp="1" noRot="1" noChangeAspect="1"/>
-          </p:cNvSpPr>
-          <p:nvPr>
-            <p:ph type="sldImg"/>
-          </p:nvPr>
-        </p:nvSpPr>
-        <p:spPr/>
-        <p:txBody>
-          <a:bodyPr/>
-          <a:lstStyle/>
-          <a:p>
-            <a:endParaRPr lang="en-US"/>
-          </a:p>
-        </p:txBody>
-      </p:sp>
-      <p:sp>
-        <p:nvSpPr>
-          <p:cNvPr id="3" name="Notes Placeholder 2"/>
-          <p:cNvSpPr>
-            <a:spLocks noGrp="1"/>
-          </p:cNvSpPr>
-          <p:nvPr>
-            <p:ph type="body" idx="1"/>
-          </p:nvPr>
-        </p:nvSpPr>
-        <p:spPr/>
-        <p:txBody>
-          <a:bodyPr/>
-          <a:lstStyle/>
-          <a:p>
-            <a:endParaRPr lang="en-US" dirty="0"/>
-          </a:p>
-        </p:txBody>
-      </p:sp>
-      <p:sp>
-        <p:nvSpPr>
-          <p:cNvPr id="4" name="Header Placeholder 3"/>
-          <p:cNvSpPr>
-            <a:spLocks noGrp="1"/>
-          </p:cNvSpPr>
-          <p:nvPr>
-            <p:ph type="hdr" sz="quarter"/>
-          </p:nvPr>
-        </p:nvSpPr>
-        <p:spPr/>
-        <p:txBody>
-          <a:bodyPr/>
-          <a:lstStyle/>
-          <a:p>
-            <a:r>
-              <a:rPr lang="en-US"/>
-              <a:t>Introduction to Programming using Python</a:t>
-            </a:r>
-            <a:endParaRPr lang="en-US" dirty="0"/>
-          </a:p>
-        </p:txBody>
-      </p:sp>
-      <p:sp>
-        <p:nvSpPr>
-          <p:cNvPr id="5" name="Date Placeholder 4"/>
-          <p:cNvSpPr>
-            <a:spLocks noGrp="1"/>
-          </p:cNvSpPr>
-          <p:nvPr>
-            <p:ph type="dt" idx="1"/>
-          </p:nvPr>
-        </p:nvSpPr>
-        <p:spPr/>
-        <p:txBody>
-          <a:bodyPr/>
-          <a:lstStyle/>
-          <a:p>
-            <a:fld id="{5397933D-7A1B-4403-8C00-DE52D8FE2162}" type="datetime1">
-              <a:rPr lang="en-US" smtClean="0"/>
-              <a:t>7/27/2026</a:t>
-            </a:fld>
-            <a:endParaRPr lang="en-US" dirty="0"/>
-          </a:p>
-        </p:txBody>
-      </p:sp>
-      <p:sp>
-        <p:nvSpPr>
-          <p:cNvPr id="6" name="Footer Placeholder 5"/>
-          <p:cNvSpPr>
-            <a:spLocks noGrp="1"/>
-          </p:cNvSpPr>
-          <p:nvPr>
-            <p:ph type="ftr" sz="quarter" idx="4"/>
-          </p:nvPr>
-        </p:nvSpPr>
-        <p:spPr/>
-        <p:txBody>
-          <a:bodyPr/>
-          <a:lstStyle/>
-          <a:p>
-            <a:r>
-              <a:rPr lang="en-US"/>
-              <a:t>raysmith@alum.mit.edu</a:t>
-            </a:r>
-            <a:endParaRPr lang="en-US" dirty="0"/>
-          </a:p>
-        </p:txBody>
-      </p:sp>
-      <p:sp>
-        <p:nvSpPr>
-          <p:cNvPr id="7" name="Slide Number Placeholder 6"/>
-          <p:cNvSpPr>
-            <a:spLocks noGrp="1"/>
-          </p:cNvSpPr>
-          <p:nvPr>
-            <p:ph type="sldNum" sz="quarter" idx="5"/>
-          </p:nvPr>
-        </p:nvSpPr>
-        <p:spPr/>
-        <p:txBody>
-          <a:bodyPr/>
-          <a:lstStyle/>
-          <a:p>
-            <a:fld id="{BA791329-992B-4F83-8435-C33B0EC26DB3}" type="slidenum">
-              <a:rPr lang="en-US" smtClean="0"/>
-              <a:t>21</a:t>
-            </a:fld>
-            <a:endParaRPr lang="en-US" dirty="0"/>
-          </a:p>
-        </p:txBody>
-      </p:sp>
-    </p:spTree>
-    <p:extLst>
-      <p:ext uri="{BB962C8B-B14F-4D97-AF65-F5344CB8AC3E}">
-        <p14:creationId xmlns:p14="http://schemas.microsoft.com/office/powerpoint/2010/main" val="3083072296"/>
       </p:ext>
     </p:extLst>
   </p:cSld>
@@ -1643,6 +1722,329 @@
           <a:bodyPr/>
           <a:lstStyle/>
           <a:p>
+            <a:r>
+              <a:rPr lang="en-US" dirty="0"/>
+              <a:t>Table reverses up(1) with down(-1) for black</a:t>
+            </a:r>
+          </a:p>
+        </p:txBody>
+      </p:sp>
+      <p:sp>
+        <p:nvSpPr>
+          <p:cNvPr id="4" name="Header Placeholder 3"/>
+          <p:cNvSpPr>
+            <a:spLocks noGrp="1"/>
+          </p:cNvSpPr>
+          <p:nvPr>
+            <p:ph type="hdr" sz="quarter"/>
+          </p:nvPr>
+        </p:nvSpPr>
+        <p:spPr/>
+        <p:txBody>
+          <a:bodyPr/>
+          <a:lstStyle/>
+          <a:p>
+            <a:r>
+              <a:rPr lang="en-US"/>
+              <a:t>Introduction to Programming using Python</a:t>
+            </a:r>
+            <a:endParaRPr lang="en-US" dirty="0"/>
+          </a:p>
+        </p:txBody>
+      </p:sp>
+      <p:sp>
+        <p:nvSpPr>
+          <p:cNvPr id="5" name="Date Placeholder 4"/>
+          <p:cNvSpPr>
+            <a:spLocks noGrp="1"/>
+          </p:cNvSpPr>
+          <p:nvPr>
+            <p:ph type="dt" idx="1"/>
+          </p:nvPr>
+        </p:nvSpPr>
+        <p:spPr/>
+        <p:txBody>
+          <a:bodyPr/>
+          <a:lstStyle/>
+          <a:p>
+            <a:fld id="{5397933D-7A1B-4403-8C00-DE52D8FE2162}" type="datetime1">
+              <a:rPr lang="en-US" smtClean="0"/>
+              <a:t>8/5/2026</a:t>
+            </a:fld>
+            <a:endParaRPr lang="en-US" dirty="0"/>
+          </a:p>
+        </p:txBody>
+      </p:sp>
+      <p:sp>
+        <p:nvSpPr>
+          <p:cNvPr id="6" name="Footer Placeholder 5"/>
+          <p:cNvSpPr>
+            <a:spLocks noGrp="1"/>
+          </p:cNvSpPr>
+          <p:nvPr>
+            <p:ph type="ftr" sz="quarter" idx="4"/>
+          </p:nvPr>
+        </p:nvSpPr>
+        <p:spPr/>
+        <p:txBody>
+          <a:bodyPr/>
+          <a:lstStyle/>
+          <a:p>
+            <a:r>
+              <a:rPr lang="en-US"/>
+              <a:t>raysmith@alum.mit.edu</a:t>
+            </a:r>
+            <a:endParaRPr lang="en-US" dirty="0"/>
+          </a:p>
+        </p:txBody>
+      </p:sp>
+      <p:sp>
+        <p:nvSpPr>
+          <p:cNvPr id="7" name="Slide Number Placeholder 6"/>
+          <p:cNvSpPr>
+            <a:spLocks noGrp="1"/>
+          </p:cNvSpPr>
+          <p:nvPr>
+            <p:ph type="sldNum" sz="quarter" idx="5"/>
+          </p:nvPr>
+        </p:nvSpPr>
+        <p:spPr/>
+        <p:txBody>
+          <a:bodyPr/>
+          <a:lstStyle/>
+          <a:p>
+            <a:fld id="{BA791329-992B-4F83-8435-C33B0EC26DB3}" type="slidenum">
+              <a:rPr lang="en-US" smtClean="0"/>
+              <a:t>21</a:t>
+            </a:fld>
+            <a:endParaRPr lang="en-US" dirty="0"/>
+          </a:p>
+        </p:txBody>
+      </p:sp>
+    </p:spTree>
+    <p:extLst>
+      <p:ext uri="{BB962C8B-B14F-4D97-AF65-F5344CB8AC3E}">
+        <p14:creationId xmlns:p14="http://schemas.microsoft.com/office/powerpoint/2010/main" val="1724100328"/>
+      </p:ext>
+    </p:extLst>
+  </p:cSld>
+  <p:clrMapOvr>
+    <a:masterClrMapping/>
+  </p:clrMapOvr>
+</p:notes>
+</file>
+
+<file path=ppt/notesSlides/notesSlide15.xml><?xml version="1.0" encoding="utf-8"?>
+<p:notes xmlns:a="http://schemas.openxmlformats.org/drawingml/2006/main" xmlns:r="http://schemas.openxmlformats.org/officeDocument/2006/relationships" xmlns:p="http://schemas.openxmlformats.org/presentationml/2006/main">
+  <p:cSld>
+    <p:spTree>
+      <p:nvGrpSpPr>
+        <p:cNvPr id="1" name=""/>
+        <p:cNvGrpSpPr/>
+        <p:nvPr/>
+      </p:nvGrpSpPr>
+      <p:grpSpPr>
+        <a:xfrm>
+          <a:off x="0" y="0"/>
+          <a:ext cx="0" cy="0"/>
+          <a:chOff x="0" y="0"/>
+          <a:chExt cx="0" cy="0"/>
+        </a:xfrm>
+      </p:grpSpPr>
+      <p:sp>
+        <p:nvSpPr>
+          <p:cNvPr id="2" name="Slide Image Placeholder 1"/>
+          <p:cNvSpPr>
+            <a:spLocks noGrp="1" noRot="1" noChangeAspect="1"/>
+          </p:cNvSpPr>
+          <p:nvPr>
+            <p:ph type="sldImg"/>
+          </p:nvPr>
+        </p:nvSpPr>
+        <p:spPr/>
+        <p:txBody>
+          <a:bodyPr/>
+          <a:lstStyle/>
+          <a:p>
+            <a:endParaRPr lang="en-US"/>
+          </a:p>
+        </p:txBody>
+      </p:sp>
+      <p:sp>
+        <p:nvSpPr>
+          <p:cNvPr id="3" name="Notes Placeholder 2"/>
+          <p:cNvSpPr>
+            <a:spLocks noGrp="1"/>
+          </p:cNvSpPr>
+          <p:nvPr>
+            <p:ph type="body" idx="1"/>
+          </p:nvPr>
+        </p:nvSpPr>
+        <p:spPr/>
+        <p:txBody>
+          <a:bodyPr/>
+          <a:lstStyle/>
+          <a:p>
+            <a:endParaRPr lang="en-US" dirty="0"/>
+          </a:p>
+        </p:txBody>
+      </p:sp>
+      <p:sp>
+        <p:nvSpPr>
+          <p:cNvPr id="4" name="Header Placeholder 3"/>
+          <p:cNvSpPr>
+            <a:spLocks noGrp="1"/>
+          </p:cNvSpPr>
+          <p:nvPr>
+            <p:ph type="hdr" sz="quarter"/>
+          </p:nvPr>
+        </p:nvSpPr>
+        <p:spPr/>
+        <p:txBody>
+          <a:bodyPr/>
+          <a:lstStyle/>
+          <a:p>
+            <a:r>
+              <a:rPr lang="en-US"/>
+              <a:t>Introduction to Programming using Python</a:t>
+            </a:r>
+            <a:endParaRPr lang="en-US" dirty="0"/>
+          </a:p>
+        </p:txBody>
+      </p:sp>
+      <p:sp>
+        <p:nvSpPr>
+          <p:cNvPr id="5" name="Date Placeholder 4"/>
+          <p:cNvSpPr>
+            <a:spLocks noGrp="1"/>
+          </p:cNvSpPr>
+          <p:nvPr>
+            <p:ph type="dt" idx="1"/>
+          </p:nvPr>
+        </p:nvSpPr>
+        <p:spPr/>
+        <p:txBody>
+          <a:bodyPr/>
+          <a:lstStyle/>
+          <a:p>
+            <a:fld id="{5397933D-7A1B-4403-8C00-DE52D8FE2162}" type="datetime1">
+              <a:rPr lang="en-US" smtClean="0"/>
+              <a:t>8/5/2026</a:t>
+            </a:fld>
+            <a:endParaRPr lang="en-US" dirty="0"/>
+          </a:p>
+        </p:txBody>
+      </p:sp>
+      <p:sp>
+        <p:nvSpPr>
+          <p:cNvPr id="6" name="Footer Placeholder 5"/>
+          <p:cNvSpPr>
+            <a:spLocks noGrp="1"/>
+          </p:cNvSpPr>
+          <p:nvPr>
+            <p:ph type="ftr" sz="quarter" idx="4"/>
+          </p:nvPr>
+        </p:nvSpPr>
+        <p:spPr/>
+        <p:txBody>
+          <a:bodyPr/>
+          <a:lstStyle/>
+          <a:p>
+            <a:r>
+              <a:rPr lang="en-US"/>
+              <a:t>raysmith@alum.mit.edu</a:t>
+            </a:r>
+            <a:endParaRPr lang="en-US" dirty="0"/>
+          </a:p>
+        </p:txBody>
+      </p:sp>
+      <p:sp>
+        <p:nvSpPr>
+          <p:cNvPr id="7" name="Slide Number Placeholder 6"/>
+          <p:cNvSpPr>
+            <a:spLocks noGrp="1"/>
+          </p:cNvSpPr>
+          <p:nvPr>
+            <p:ph type="sldNum" sz="quarter" idx="5"/>
+          </p:nvPr>
+        </p:nvSpPr>
+        <p:spPr/>
+        <p:txBody>
+          <a:bodyPr/>
+          <a:lstStyle/>
+          <a:p>
+            <a:fld id="{BA791329-992B-4F83-8435-C33B0EC26DB3}" type="slidenum">
+              <a:rPr lang="en-US" smtClean="0"/>
+              <a:t>23</a:t>
+            </a:fld>
+            <a:endParaRPr lang="en-US" dirty="0"/>
+          </a:p>
+        </p:txBody>
+      </p:sp>
+    </p:spTree>
+    <p:extLst>
+      <p:ext uri="{BB962C8B-B14F-4D97-AF65-F5344CB8AC3E}">
+        <p14:creationId xmlns:p14="http://schemas.microsoft.com/office/powerpoint/2010/main" val="3083072296"/>
+      </p:ext>
+    </p:extLst>
+  </p:cSld>
+  <p:clrMapOvr>
+    <a:masterClrMapping/>
+  </p:clrMapOvr>
+</p:notes>
+</file>
+
+<file path=ppt/notesSlides/notesSlide16.xml><?xml version="1.0" encoding="utf-8"?>
+<p:notes xmlns:a="http://schemas.openxmlformats.org/drawingml/2006/main" xmlns:r="http://schemas.openxmlformats.org/officeDocument/2006/relationships" xmlns:p="http://schemas.openxmlformats.org/presentationml/2006/main">
+  <p:cSld>
+    <p:spTree>
+      <p:nvGrpSpPr>
+        <p:cNvPr id="1" name=""/>
+        <p:cNvGrpSpPr/>
+        <p:nvPr/>
+      </p:nvGrpSpPr>
+      <p:grpSpPr>
+        <a:xfrm>
+          <a:off x="0" y="0"/>
+          <a:ext cx="0" cy="0"/>
+          <a:chOff x="0" y="0"/>
+          <a:chExt cx="0" cy="0"/>
+        </a:xfrm>
+      </p:grpSpPr>
+      <p:sp>
+        <p:nvSpPr>
+          <p:cNvPr id="2" name="Slide Image Placeholder 1"/>
+          <p:cNvSpPr>
+            <a:spLocks noGrp="1" noRot="1" noChangeAspect="1"/>
+          </p:cNvSpPr>
+          <p:nvPr>
+            <p:ph type="sldImg"/>
+          </p:nvPr>
+        </p:nvSpPr>
+        <p:spPr/>
+        <p:txBody>
+          <a:bodyPr/>
+          <a:lstStyle/>
+          <a:p>
+            <a:endParaRPr lang="en-US"/>
+          </a:p>
+        </p:txBody>
+      </p:sp>
+      <p:sp>
+        <p:nvSpPr>
+          <p:cNvPr id="3" name="Notes Placeholder 2"/>
+          <p:cNvSpPr>
+            <a:spLocks noGrp="1"/>
+          </p:cNvSpPr>
+          <p:nvPr>
+            <p:ph type="body" idx="1"/>
+          </p:nvPr>
+        </p:nvSpPr>
+        <p:spPr/>
+        <p:txBody>
+          <a:bodyPr/>
+          <a:lstStyle/>
+          <a:p>
             <a:endParaRPr lang="en-US" dirty="0"/>
           </a:p>
         </p:txBody>
@@ -1686,7 +2088,7 @@
           <a:p>
             <a:fld id="{81E0ADA2-1B64-45DB-B2E6-F6A11AB7EB98}" type="datetime1">
               <a:rPr lang="en-US" smtClean="0"/>
-              <a:t>7/27/2026</a:t>
+              <a:t>8/5/2026</a:t>
             </a:fld>
             <a:endParaRPr lang="en-US" dirty="0"/>
           </a:p>
@@ -1731,7 +2133,7 @@
           <a:p>
             <a:fld id="{BA791329-992B-4F83-8435-C33B0EC26DB3}" type="slidenum">
               <a:rPr lang="en-US" smtClean="0"/>
-              <a:t>26</a:t>
+              <a:t>28</a:t>
             </a:fld>
             <a:endParaRPr lang="en-US" dirty="0"/>
           </a:p>
@@ -1844,7 +2246,7 @@
           <a:p>
             <a:fld id="{E734D050-5128-424E-B0C7-5BFB4917C3AB}" type="datetime1">
               <a:rPr lang="en-US" smtClean="0"/>
-              <a:t>7/27/2026</a:t>
+              <a:t>8/5/2026</a:t>
             </a:fld>
             <a:endParaRPr lang="en-US" dirty="0"/>
           </a:p>
@@ -2032,7 +2434,7 @@
           <a:p>
             <a:fld id="{E734D050-5128-424E-B0C7-5BFB4917C3AB}" type="datetime1">
               <a:rPr lang="en-US" smtClean="0"/>
-              <a:t>7/27/2026</a:t>
+              <a:t>8/5/2026</a:t>
             </a:fld>
             <a:endParaRPr lang="en-US" dirty="0"/>
           </a:p>
@@ -2235,7 +2637,7 @@
           <a:p>
             <a:fld id="{E734D050-5128-424E-B0C7-5BFB4917C3AB}" type="datetime1">
               <a:rPr lang="en-US" smtClean="0"/>
-              <a:t>7/27/2026</a:t>
+              <a:t>8/5/2026</a:t>
             </a:fld>
             <a:endParaRPr lang="en-US" dirty="0"/>
           </a:p>
@@ -2438,7 +2840,7 @@
           <a:p>
             <a:fld id="{E734D050-5128-424E-B0C7-5BFB4917C3AB}" type="datetime1">
               <a:rPr lang="en-US" smtClean="0"/>
-              <a:t>7/27/2026</a:t>
+              <a:t>8/5/2026</a:t>
             </a:fld>
             <a:endParaRPr lang="en-US" dirty="0"/>
           </a:p>
@@ -2638,7 +3040,7 @@
           <a:p>
             <a:fld id="{E734D050-5128-424E-B0C7-5BFB4917C3AB}" type="datetime1">
               <a:rPr lang="en-US" smtClean="0"/>
-              <a:t>7/27/2026</a:t>
+              <a:t>8/5/2026</a:t>
             </a:fld>
             <a:endParaRPr lang="en-US" dirty="0"/>
           </a:p>
@@ -2838,7 +3240,7 @@
           <a:p>
             <a:fld id="{E734D050-5128-424E-B0C7-5BFB4917C3AB}" type="datetime1">
               <a:rPr lang="en-US" smtClean="0"/>
-              <a:t>7/27/2026</a:t>
+              <a:t>8/5/2026</a:t>
             </a:fld>
             <a:endParaRPr lang="en-US" dirty="0"/>
           </a:p>
@@ -3038,7 +3440,7 @@
           <a:p>
             <a:fld id="{E734D050-5128-424E-B0C7-5BFB4917C3AB}" type="datetime1">
               <a:rPr lang="en-US" smtClean="0"/>
-              <a:t>7/27/2026</a:t>
+              <a:t>8/5/2026</a:t>
             </a:fld>
             <a:endParaRPr lang="en-US" dirty="0"/>
           </a:p>
@@ -3238,7 +3640,7 @@
           <a:p>
             <a:fld id="{E734D050-5128-424E-B0C7-5BFB4917C3AB}" type="datetime1">
               <a:rPr lang="en-US" smtClean="0"/>
-              <a:t>7/27/2026</a:t>
+              <a:t>8/5/2026</a:t>
             </a:fld>
             <a:endParaRPr lang="en-US" dirty="0"/>
           </a:p>
@@ -4092,7 +4494,7 @@
           <a:p>
             <a:fld id="{5110D8A6-D61F-4DCA-82DB-6A888A9B2487}" type="datetime1">
               <a:rPr lang="en-US" smtClean="0"/>
-              <a:t>7/27/2026</a:t>
+              <a:t>8/5/2026</a:t>
             </a:fld>
             <a:endParaRPr lang="en-US" dirty="0"/>
           </a:p>
@@ -4359,7 +4761,7 @@
           <a:p>
             <a:fld id="{62C5B04C-660C-4601-8C32-DAC504F51286}" type="datetime1">
               <a:rPr lang="en-US" smtClean="0"/>
-              <a:t>7/27/2026</a:t>
+              <a:t>8/5/2026</a:t>
             </a:fld>
             <a:endParaRPr lang="en-US" dirty="0"/>
           </a:p>
@@ -4678,7 +5080,7 @@
           <a:p>
             <a:fld id="{28495457-F83B-45BB-B822-2DF2A1FD0C27}" type="datetime1">
               <a:rPr lang="en-US" smtClean="0"/>
-              <a:t>7/27/2026</a:t>
+              <a:t>8/5/2026</a:t>
             </a:fld>
             <a:endParaRPr lang="en-US" dirty="0"/>
           </a:p>
@@ -5024,7 +5426,7 @@
           <a:p>
             <a:fld id="{AF75F462-1497-413B-A43E-E69E6D8E4BEF}" type="datetime1">
               <a:rPr lang="en-US" smtClean="0"/>
-              <a:t>7/27/2026</a:t>
+              <a:t>8/5/2026</a:t>
             </a:fld>
             <a:endParaRPr lang="en-US" dirty="0"/>
           </a:p>
@@ -5343,7 +5745,7 @@
           <a:p>
             <a:fld id="{F552C08A-409D-4E56-98A3-A36D8B5C9F4C}" type="datetime1">
               <a:rPr lang="en-US" smtClean="0"/>
-              <a:t>7/27/2026</a:t>
+              <a:t>8/5/2026</a:t>
             </a:fld>
             <a:endParaRPr lang="en-US" dirty="0"/>
           </a:p>
@@ -5741,7 +6143,7 @@
           <a:p>
             <a:fld id="{8469E2CF-C14A-49FB-8201-FEEF3BF16570}" type="datetime1">
               <a:rPr lang="en-US" smtClean="0"/>
-              <a:t>7/27/2026</a:t>
+              <a:t>8/5/2026</a:t>
             </a:fld>
             <a:endParaRPr lang="en-US" dirty="0"/>
           </a:p>
@@ -5916,7 +6318,7 @@
           <a:p>
             <a:fld id="{B4FD04B1-0384-44B0-8537-B8F12FD50EF8}" type="datetime1">
               <a:rPr lang="en-US" smtClean="0"/>
-              <a:t>7/27/2026</a:t>
+              <a:t>8/5/2026</a:t>
             </a:fld>
             <a:endParaRPr lang="en-US" dirty="0"/>
           </a:p>
@@ -6100,7 +6502,7 @@
           <a:p>
             <a:fld id="{DC5F4745-C362-4373-8D92-8EF41093E018}" type="datetime1">
               <a:rPr lang="en-US" smtClean="0"/>
-              <a:t>7/27/2026</a:t>
+              <a:t>8/5/2026</a:t>
             </a:fld>
             <a:endParaRPr lang="en-US" dirty="0"/>
           </a:p>
@@ -6280,7 +6682,7 @@
           <a:p>
             <a:fld id="{6F8407F0-4949-4EDC-A592-6ECEEFF5A038}" type="datetime1">
               <a:rPr lang="en-US" smtClean="0"/>
-              <a:t>7/27/2026</a:t>
+              <a:t>8/5/2026</a:t>
             </a:fld>
             <a:endParaRPr lang="en-US" dirty="0"/>
           </a:p>
@@ -6531,7 +6933,7 @@
           <a:p>
             <a:fld id="{298A7F69-C248-41A3-8602-E8D54188EDB0}" type="datetime1">
               <a:rPr lang="en-US" smtClean="0"/>
-              <a:t>7/27/2026</a:t>
+              <a:t>8/5/2026</a:t>
             </a:fld>
             <a:endParaRPr lang="en-US" dirty="0"/>
           </a:p>
@@ -6767,7 +7169,7 @@
           <a:p>
             <a:fld id="{1F20B086-39C4-4128-985B-FB07F33D3CF3}" type="datetime1">
               <a:rPr lang="en-US" smtClean="0"/>
-              <a:t>7/27/2026</a:t>
+              <a:t>8/5/2026</a:t>
             </a:fld>
             <a:endParaRPr lang="en-US" dirty="0"/>
           </a:p>
@@ -7145,7 +7547,7 @@
           <a:p>
             <a:fld id="{2A2ADCF5-0A36-4D40-B549-3F06F2B68F47}" type="datetime1">
               <a:rPr lang="en-US" smtClean="0"/>
-              <a:t>7/27/2026</a:t>
+              <a:t>8/5/2026</a:t>
             </a:fld>
             <a:endParaRPr lang="en-US" dirty="0"/>
           </a:p>
@@ -7272,7 +7674,7 @@
           <a:p>
             <a:fld id="{7D89728E-A64F-4CB2-A929-EC8F77743E5A}" type="datetime1">
               <a:rPr lang="en-US" smtClean="0"/>
-              <a:t>7/27/2026</a:t>
+              <a:t>8/5/2026</a:t>
             </a:fld>
             <a:endParaRPr lang="en-US" dirty="0"/>
           </a:p>
@@ -7371,7 +7773,7 @@
           <a:p>
             <a:fld id="{F1811B85-6381-4843-915E-A80D8CF566B9}" type="datetime1">
               <a:rPr lang="en-US" smtClean="0"/>
-              <a:t>7/27/2026</a:t>
+              <a:t>8/5/2026</a:t>
             </a:fld>
             <a:endParaRPr lang="en-US" dirty="0"/>
           </a:p>
@@ -7630,7 +8032,7 @@
           <a:p>
             <a:fld id="{038FA659-E42E-4DAC-9069-4C6BD9C68659}" type="datetime1">
               <a:rPr lang="en-US" smtClean="0"/>
-              <a:t>7/27/2026</a:t>
+              <a:t>8/5/2026</a:t>
             </a:fld>
             <a:endParaRPr lang="en-US" dirty="0"/>
           </a:p>
@@ -7896,7 +8298,7 @@
           <a:p>
             <a:fld id="{E08F6933-E9E6-4227-B3A4-00207D316420}" type="datetime1">
               <a:rPr lang="en-US" smtClean="0"/>
-              <a:t>7/27/2026</a:t>
+              <a:t>8/5/2026</a:t>
             </a:fld>
             <a:endParaRPr lang="en-US" dirty="0"/>
           </a:p>
@@ -8699,7 +9101,7 @@
           <a:p>
             <a:fld id="{A0393A93-C82D-47F0-A099-2DE871639089}" type="datetime1">
               <a:rPr lang="en-US" smtClean="0"/>
-              <a:t>7/27/2026</a:t>
+              <a:t>8/5/2026</a:t>
             </a:fld>
             <a:endParaRPr lang="en-US" dirty="0"/>
           </a:p>
@@ -9289,7 +9691,7 @@
           <a:p>
             <a:fld id="{AC2EE02F-DFA0-4A0E-B523-2B95372C2781}" type="datetime1">
               <a:rPr lang="en-US" smtClean="0"/>
-              <a:t>7/27/2026</a:t>
+              <a:t>8/5/2026</a:t>
             </a:fld>
             <a:endParaRPr lang="en-US" dirty="0"/>
           </a:p>
@@ -9516,7 +9918,7 @@
           <a:p>
             <a:fld id="{771FCE44-14AA-407B-9781-80C2DD8F374A}" type="datetime1">
               <a:rPr lang="en-US" smtClean="0"/>
-              <a:t>7/27/2026</a:t>
+              <a:t>8/5/2026</a:t>
             </a:fld>
             <a:endParaRPr lang="en-US" dirty="0"/>
           </a:p>
@@ -9726,7 +10128,7 @@
           <a:p>
             <a:fld id="{771FCE44-14AA-407B-9781-80C2DD8F374A}" type="datetime1">
               <a:rPr lang="en-US" smtClean="0"/>
-              <a:t>7/27/2026</a:t>
+              <a:t>8/5/2026</a:t>
             </a:fld>
             <a:endParaRPr lang="en-US" dirty="0"/>
           </a:p>
@@ -10022,7 +10424,7 @@
           <a:p>
             <a:fld id="{771FCE44-14AA-407B-9781-80C2DD8F374A}" type="datetime1">
               <a:rPr lang="en-US" smtClean="0"/>
-              <a:t>7/27/2026</a:t>
+              <a:t>8/5/2026</a:t>
             </a:fld>
             <a:endParaRPr lang="en-US" dirty="0"/>
           </a:p>
@@ -10253,7 +10655,7 @@
           <a:p>
             <a:fld id="{771FCE44-14AA-407B-9781-80C2DD8F374A}" type="datetime1">
               <a:rPr lang="en-US" smtClean="0"/>
-              <a:t>7/27/2026</a:t>
+              <a:t>8/5/2026</a:t>
             </a:fld>
             <a:endParaRPr lang="en-US" dirty="0"/>
           </a:p>
@@ -10430,20 +10832,20 @@
           <a:p>
             <a:r>
               <a:rPr lang="en-US" sz="3800" dirty="0"/>
-              <a:t>Parse 1. Nf3 into white knight moving to square f3</a:t>
+              <a:t>Determine move, piece, destination</a:t>
             </a:r>
           </a:p>
           <a:p>
             <a:r>
               <a:rPr lang="en-US" sz="3800" dirty="0"/>
-              <a:t>Determine white knight (at g1) is the one and  only white knight that can move to f3</a:t>
-            </a:r>
-          </a:p>
-          <a:p>
-            <a:pPr marL="0" indent="0">
-              <a:buNone/>
-            </a:pPr>
-            <a:endParaRPr lang="en-US" sz="3800" dirty="0"/>
+              <a:t>1. Nf3 = white’s move 1, Knight, to square f3</a:t>
+            </a:r>
+          </a:p>
+          <a:p>
+            <a:r>
+              <a:rPr lang="en-US" sz="3800" dirty="0"/>
+              <a:t>16… Rfe8+ = black move 16, Rook on f file, to square e8 with check</a:t>
+            </a:r>
           </a:p>
         </p:txBody>
       </p:sp>
@@ -10470,7 +10872,7 @@
           <a:p>
             <a:fld id="{771FCE44-14AA-407B-9781-80C2DD8F374A}" type="datetime1">
               <a:rPr lang="en-US" smtClean="0"/>
-              <a:t>7/27/2026</a:t>
+              <a:t>8/5/2026</a:t>
             </a:fld>
             <a:endParaRPr lang="en-US" dirty="0"/>
           </a:p>
@@ -10567,6 +10969,466 @@
         <p:cNvPr id="1" name="">
           <a:extLst>
             <a:ext uri="{FF2B5EF4-FFF2-40B4-BE49-F238E27FC236}">
+              <a16:creationId xmlns:a16="http://schemas.microsoft.com/office/drawing/2014/main" id="{5B3B157F-6FAE-0E9F-7548-BA77A93ABEB0}"/>
+            </a:ext>
+          </a:extLst>
+        </p:cNvPr>
+        <p:cNvGrpSpPr/>
+        <p:nvPr/>
+      </p:nvGrpSpPr>
+      <p:grpSpPr>
+        <a:xfrm>
+          <a:off x="0" y="0"/>
+          <a:ext cx="0" cy="0"/>
+          <a:chOff x="0" y="0"/>
+          <a:chExt cx="0" cy="0"/>
+        </a:xfrm>
+      </p:grpSpPr>
+      <p:sp>
+        <p:nvSpPr>
+          <p:cNvPr id="2" name="Title 1">
+            <a:extLst>
+              <a:ext uri="{FF2B5EF4-FFF2-40B4-BE49-F238E27FC236}">
+                <a16:creationId xmlns:a16="http://schemas.microsoft.com/office/drawing/2014/main" id="{BA1C7AF4-2419-5B40-9106-2099DF19FF9A}"/>
+              </a:ext>
+            </a:extLst>
+          </p:cNvPr>
+          <p:cNvSpPr>
+            <a:spLocks noGrp="1"/>
+          </p:cNvSpPr>
+          <p:nvPr>
+            <p:ph type="title"/>
+          </p:nvPr>
+        </p:nvSpPr>
+        <p:spPr>
+          <a:xfrm>
+            <a:off x="677333" y="609600"/>
+            <a:ext cx="9049991" cy="1320800"/>
+          </a:xfrm>
+        </p:spPr>
+        <p:txBody>
+          <a:bodyPr>
+            <a:normAutofit/>
+          </a:bodyPr>
+          <a:lstStyle/>
+          <a:p>
+            <a:r>
+              <a:rPr lang="en-US" sz="4000" dirty="0"/>
+              <a:t>Move Parsing – onion skin approach</a:t>
+            </a:r>
+          </a:p>
+        </p:txBody>
+      </p:sp>
+      <p:sp>
+        <p:nvSpPr>
+          <p:cNvPr id="3" name="Content Placeholder 2">
+            <a:extLst>
+              <a:ext uri="{FF2B5EF4-FFF2-40B4-BE49-F238E27FC236}">
+                <a16:creationId xmlns:a16="http://schemas.microsoft.com/office/drawing/2014/main" id="{9E8B3970-AC63-7A85-2093-E2E672EAD1C7}"/>
+              </a:ext>
+            </a:extLst>
+          </p:cNvPr>
+          <p:cNvSpPr>
+            <a:spLocks noGrp="1"/>
+          </p:cNvSpPr>
+          <p:nvPr>
+            <p:ph idx="1"/>
+          </p:nvPr>
+        </p:nvSpPr>
+        <p:spPr>
+          <a:xfrm>
+            <a:off x="677333" y="1593477"/>
+            <a:ext cx="9396833" cy="4447886"/>
+          </a:xfrm>
+        </p:spPr>
+        <p:txBody>
+          <a:bodyPr>
+            <a:normAutofit/>
+          </a:bodyPr>
+          <a:lstStyle/>
+          <a:p>
+            <a:r>
+              <a:rPr lang="en-US" sz="3800" dirty="0"/>
+              <a:t>In stages downward, r</a:t>
+            </a:r>
+            <a:r>
+              <a:rPr lang="en-US" sz="3600" dirty="0"/>
+              <a:t>emoving, if found</a:t>
+            </a:r>
+          </a:p>
+          <a:p>
+            <a:pPr lvl="1"/>
+            <a:r>
+              <a:rPr lang="en-US" sz="3600" dirty="0"/>
+              <a:t>Game Result: 1-0, 0-1, ½-½ - DONE</a:t>
+            </a:r>
+          </a:p>
+          <a:p>
+            <a:pPr lvl="1"/>
+            <a:r>
+              <a:rPr lang="en-US" sz="3600" dirty="0"/>
+              <a:t>From right end: + check, # checkmate</a:t>
+            </a:r>
+          </a:p>
+          <a:p>
+            <a:pPr lvl="1"/>
+            <a:r>
+              <a:rPr lang="en-US" sz="3600" dirty="0"/>
+              <a:t>Unique: O-O, O-O-O - DONE</a:t>
+            </a:r>
+          </a:p>
+          <a:p>
+            <a:pPr lvl="1"/>
+            <a:r>
+              <a:rPr lang="en-US" sz="3600" dirty="0"/>
+              <a:t>From right end: destination e.g., e8</a:t>
+            </a:r>
+          </a:p>
+          <a:p>
+            <a:endParaRPr lang="en-US" sz="3800" dirty="0"/>
+          </a:p>
+        </p:txBody>
+      </p:sp>
+      <p:sp>
+        <p:nvSpPr>
+          <p:cNvPr id="4" name="Date Placeholder 3">
+            <a:extLst>
+              <a:ext uri="{FF2B5EF4-FFF2-40B4-BE49-F238E27FC236}">
+                <a16:creationId xmlns:a16="http://schemas.microsoft.com/office/drawing/2014/main" id="{338CB73E-872D-AF93-3F06-59F65B908598}"/>
+              </a:ext>
+            </a:extLst>
+          </p:cNvPr>
+          <p:cNvSpPr>
+            <a:spLocks noGrp="1"/>
+          </p:cNvSpPr>
+          <p:nvPr>
+            <p:ph type="dt" sz="half" idx="10"/>
+          </p:nvPr>
+        </p:nvSpPr>
+        <p:spPr/>
+        <p:txBody>
+          <a:bodyPr/>
+          <a:lstStyle/>
+          <a:p>
+            <a:fld id="{771FCE44-14AA-407B-9781-80C2DD8F374A}" type="datetime1">
+              <a:rPr lang="en-US" smtClean="0"/>
+              <a:t>8/8/2026</a:t>
+            </a:fld>
+            <a:endParaRPr lang="en-US" dirty="0"/>
+          </a:p>
+        </p:txBody>
+      </p:sp>
+      <p:sp>
+        <p:nvSpPr>
+          <p:cNvPr id="6" name="Slide Number Placeholder 5">
+            <a:extLst>
+              <a:ext uri="{FF2B5EF4-FFF2-40B4-BE49-F238E27FC236}">
+                <a16:creationId xmlns:a16="http://schemas.microsoft.com/office/drawing/2014/main" id="{DD890427-A80E-9120-E229-29CDEF930C3E}"/>
+              </a:ext>
+            </a:extLst>
+          </p:cNvPr>
+          <p:cNvSpPr>
+            <a:spLocks noGrp="1"/>
+          </p:cNvSpPr>
+          <p:nvPr>
+            <p:ph type="sldNum" sz="quarter" idx="12"/>
+          </p:nvPr>
+        </p:nvSpPr>
+        <p:spPr/>
+        <p:txBody>
+          <a:bodyPr/>
+          <a:lstStyle/>
+          <a:p>
+            <a:fld id="{6D22F896-40B5-4ADD-8801-0D06FADFA095}" type="slidenum">
+              <a:rPr lang="en-US" smtClean="0"/>
+              <a:t>15</a:t>
+            </a:fld>
+            <a:endParaRPr lang="en-US" dirty="0"/>
+          </a:p>
+        </p:txBody>
+      </p:sp>
+      <p:sp>
+        <p:nvSpPr>
+          <p:cNvPr id="7" name="Footer Placeholder 6">
+            <a:extLst>
+              <a:ext uri="{FF2B5EF4-FFF2-40B4-BE49-F238E27FC236}">
+                <a16:creationId xmlns:a16="http://schemas.microsoft.com/office/drawing/2014/main" id="{CD5F6344-3762-54E8-FBBD-27DCBC555E3E}"/>
+              </a:ext>
+            </a:extLst>
+          </p:cNvPr>
+          <p:cNvSpPr>
+            <a:spLocks noGrp="1"/>
+          </p:cNvSpPr>
+          <p:nvPr>
+            <p:ph type="ftr" sz="quarter" idx="11"/>
+          </p:nvPr>
+        </p:nvSpPr>
+        <p:spPr/>
+        <p:txBody>
+          <a:bodyPr/>
+          <a:lstStyle/>
+          <a:p>
+            <a:r>
+              <a:rPr lang="en-US"/>
+              <a:t>raysmith@alum.mit.edu                     Session 2 – Building Blocks</a:t>
+            </a:r>
+            <a:endParaRPr lang="en-US" dirty="0"/>
+          </a:p>
+        </p:txBody>
+      </p:sp>
+    </p:spTree>
+    <p:extLst>
+      <p:ext uri="{BB962C8B-B14F-4D97-AF65-F5344CB8AC3E}">
+        <p14:creationId xmlns:p14="http://schemas.microsoft.com/office/powerpoint/2010/main" val="1740492516"/>
+      </p:ext>
+    </p:extLst>
+  </p:cSld>
+  <p:clrMapOvr>
+    <a:masterClrMapping/>
+  </p:clrMapOvr>
+  <mc:AlternateContent xmlns:mc="http://schemas.openxmlformats.org/markup-compatibility/2006">
+    <mc:Choice xmlns:p14="http://schemas.microsoft.com/office/powerpoint/2010/main" Requires="p14">
+      <p:transition spd="med" p14:dur="700">
+        <p:fade/>
+      </p:transition>
+    </mc:Choice>
+    <mc:Fallback>
+      <p:transition spd="med">
+        <p:fade/>
+      </p:transition>
+    </mc:Fallback>
+  </mc:AlternateContent>
+</p:sld>
+</file>
+
+<file path=ppt/slides/slide16.xml><?xml version="1.0" encoding="utf-8"?>
+<p:sld xmlns:a="http://schemas.openxmlformats.org/drawingml/2006/main" xmlns:r="http://schemas.openxmlformats.org/officeDocument/2006/relationships" xmlns:p="http://schemas.openxmlformats.org/presentationml/2006/main">
+  <p:cSld>
+    <p:spTree>
+      <p:nvGrpSpPr>
+        <p:cNvPr id="1" name="">
+          <a:extLst>
+            <a:ext uri="{FF2B5EF4-FFF2-40B4-BE49-F238E27FC236}">
+              <a16:creationId xmlns:a16="http://schemas.microsoft.com/office/drawing/2014/main" id="{DCF640AD-E814-C2BE-0DAB-FFF4DFF8F623}"/>
+            </a:ext>
+          </a:extLst>
+        </p:cNvPr>
+        <p:cNvGrpSpPr/>
+        <p:nvPr/>
+      </p:nvGrpSpPr>
+      <p:grpSpPr>
+        <a:xfrm>
+          <a:off x="0" y="0"/>
+          <a:ext cx="0" cy="0"/>
+          <a:chOff x="0" y="0"/>
+          <a:chExt cx="0" cy="0"/>
+        </a:xfrm>
+      </p:grpSpPr>
+      <p:sp>
+        <p:nvSpPr>
+          <p:cNvPr id="2" name="Title 1">
+            <a:extLst>
+              <a:ext uri="{FF2B5EF4-FFF2-40B4-BE49-F238E27FC236}">
+                <a16:creationId xmlns:a16="http://schemas.microsoft.com/office/drawing/2014/main" id="{EA00D801-268C-C19D-BE8D-0076825E4B6C}"/>
+              </a:ext>
+            </a:extLst>
+          </p:cNvPr>
+          <p:cNvSpPr>
+            <a:spLocks noGrp="1"/>
+          </p:cNvSpPr>
+          <p:nvPr>
+            <p:ph type="title"/>
+          </p:nvPr>
+        </p:nvSpPr>
+        <p:spPr>
+          <a:xfrm>
+            <a:off x="677333" y="609600"/>
+            <a:ext cx="9049991" cy="1320800"/>
+          </a:xfrm>
+        </p:spPr>
+        <p:txBody>
+          <a:bodyPr>
+            <a:normAutofit/>
+          </a:bodyPr>
+          <a:lstStyle/>
+          <a:p>
+            <a:r>
+              <a:rPr lang="en-US" sz="4000" dirty="0"/>
+              <a:t>Move Parsing – onion skin - continued</a:t>
+            </a:r>
+          </a:p>
+        </p:txBody>
+      </p:sp>
+      <p:sp>
+        <p:nvSpPr>
+          <p:cNvPr id="3" name="Content Placeholder 2">
+            <a:extLst>
+              <a:ext uri="{FF2B5EF4-FFF2-40B4-BE49-F238E27FC236}">
+                <a16:creationId xmlns:a16="http://schemas.microsoft.com/office/drawing/2014/main" id="{BD57D907-7D3D-9A1E-384D-5CA4565F7F52}"/>
+              </a:ext>
+            </a:extLst>
+          </p:cNvPr>
+          <p:cNvSpPr>
+            <a:spLocks noGrp="1"/>
+          </p:cNvSpPr>
+          <p:nvPr>
+            <p:ph idx="1"/>
+          </p:nvPr>
+        </p:nvSpPr>
+        <p:spPr>
+          <a:xfrm>
+            <a:off x="677333" y="1593477"/>
+            <a:ext cx="9396833" cy="4447886"/>
+          </a:xfrm>
+        </p:spPr>
+        <p:txBody>
+          <a:bodyPr>
+            <a:normAutofit/>
+          </a:bodyPr>
+          <a:lstStyle/>
+          <a:p>
+            <a:r>
+              <a:rPr lang="en-US" sz="3800" dirty="0"/>
+              <a:t>From left end: Piece, e.g., K</a:t>
+            </a:r>
+          </a:p>
+          <a:p>
+            <a:r>
+              <a:rPr lang="en-US" sz="3800" dirty="0"/>
+              <a:t>From left end: source file, e.g., f</a:t>
+            </a:r>
+          </a:p>
+          <a:p>
+            <a:r>
+              <a:rPr lang="en-US" sz="3800" dirty="0"/>
+              <a:t>From left end: source rank, e.g., 1</a:t>
+            </a:r>
+          </a:p>
+          <a:p>
+            <a:endParaRPr lang="en-US" sz="3800" dirty="0"/>
+          </a:p>
+        </p:txBody>
+      </p:sp>
+      <p:sp>
+        <p:nvSpPr>
+          <p:cNvPr id="4" name="Date Placeholder 3">
+            <a:extLst>
+              <a:ext uri="{FF2B5EF4-FFF2-40B4-BE49-F238E27FC236}">
+                <a16:creationId xmlns:a16="http://schemas.microsoft.com/office/drawing/2014/main" id="{212278AB-6FC8-8AA1-8FB2-F14A8CE911C1}"/>
+              </a:ext>
+            </a:extLst>
+          </p:cNvPr>
+          <p:cNvSpPr>
+            <a:spLocks noGrp="1"/>
+          </p:cNvSpPr>
+          <p:nvPr>
+            <p:ph type="dt" sz="half" idx="10"/>
+          </p:nvPr>
+        </p:nvSpPr>
+        <p:spPr/>
+        <p:txBody>
+          <a:bodyPr/>
+          <a:lstStyle/>
+          <a:p>
+            <a:fld id="{771FCE44-14AA-407B-9781-80C2DD8F374A}" type="datetime1">
+              <a:rPr lang="en-US" smtClean="0"/>
+              <a:t>8/8/2026</a:t>
+            </a:fld>
+            <a:endParaRPr lang="en-US" dirty="0"/>
+          </a:p>
+        </p:txBody>
+      </p:sp>
+      <p:sp>
+        <p:nvSpPr>
+          <p:cNvPr id="6" name="Slide Number Placeholder 5">
+            <a:extLst>
+              <a:ext uri="{FF2B5EF4-FFF2-40B4-BE49-F238E27FC236}">
+                <a16:creationId xmlns:a16="http://schemas.microsoft.com/office/drawing/2014/main" id="{77FB70D8-55A2-ECF5-E9AF-5B157BA4273D}"/>
+              </a:ext>
+            </a:extLst>
+          </p:cNvPr>
+          <p:cNvSpPr>
+            <a:spLocks noGrp="1"/>
+          </p:cNvSpPr>
+          <p:nvPr>
+            <p:ph type="sldNum" sz="quarter" idx="12"/>
+          </p:nvPr>
+        </p:nvSpPr>
+        <p:spPr/>
+        <p:txBody>
+          <a:bodyPr/>
+          <a:lstStyle/>
+          <a:p>
+            <a:fld id="{6D22F896-40B5-4ADD-8801-0D06FADFA095}" type="slidenum">
+              <a:rPr lang="en-US" smtClean="0"/>
+              <a:t>16</a:t>
+            </a:fld>
+            <a:endParaRPr lang="en-US" dirty="0"/>
+          </a:p>
+        </p:txBody>
+      </p:sp>
+      <p:sp>
+        <p:nvSpPr>
+          <p:cNvPr id="7" name="Footer Placeholder 6">
+            <a:extLst>
+              <a:ext uri="{FF2B5EF4-FFF2-40B4-BE49-F238E27FC236}">
+                <a16:creationId xmlns:a16="http://schemas.microsoft.com/office/drawing/2014/main" id="{116FD53B-C631-33E5-4DDC-B27D99DBCF33}"/>
+              </a:ext>
+            </a:extLst>
+          </p:cNvPr>
+          <p:cNvSpPr>
+            <a:spLocks noGrp="1"/>
+          </p:cNvSpPr>
+          <p:nvPr>
+            <p:ph type="ftr" sz="quarter" idx="11"/>
+          </p:nvPr>
+        </p:nvSpPr>
+        <p:spPr/>
+        <p:txBody>
+          <a:bodyPr/>
+          <a:lstStyle/>
+          <a:p>
+            <a:r>
+              <a:rPr lang="en-US"/>
+              <a:t>raysmith@alum.mit.edu                     Session 2 – Building Blocks</a:t>
+            </a:r>
+            <a:endParaRPr lang="en-US" dirty="0"/>
+          </a:p>
+        </p:txBody>
+      </p:sp>
+    </p:spTree>
+    <p:extLst>
+      <p:ext uri="{BB962C8B-B14F-4D97-AF65-F5344CB8AC3E}">
+        <p14:creationId xmlns:p14="http://schemas.microsoft.com/office/powerpoint/2010/main" val="3816978618"/>
+      </p:ext>
+    </p:extLst>
+  </p:cSld>
+  <p:clrMapOvr>
+    <a:masterClrMapping/>
+  </p:clrMapOvr>
+  <mc:AlternateContent xmlns:mc="http://schemas.openxmlformats.org/markup-compatibility/2006">
+    <mc:Choice xmlns:p14="http://schemas.microsoft.com/office/powerpoint/2010/main" Requires="p14">
+      <p:transition spd="med" p14:dur="700">
+        <p:fade/>
+      </p:transition>
+    </mc:Choice>
+    <mc:Fallback>
+      <p:transition spd="med">
+        <p:fade/>
+      </p:transition>
+    </mc:Fallback>
+  </mc:AlternateContent>
+</p:sld>
+</file>
+
+<file path=ppt/slides/slide17.xml><?xml version="1.0" encoding="utf-8"?>
+<p:sld xmlns:a="http://schemas.openxmlformats.org/drawingml/2006/main" xmlns:r="http://schemas.openxmlformats.org/officeDocument/2006/relationships" xmlns:p="http://schemas.openxmlformats.org/presentationml/2006/main">
+  <p:cSld>
+    <p:spTree>
+      <p:nvGrpSpPr>
+        <p:cNvPr id="1" name="">
+          <a:extLst>
+            <a:ext uri="{FF2B5EF4-FFF2-40B4-BE49-F238E27FC236}">
               <a16:creationId xmlns:a16="http://schemas.microsoft.com/office/drawing/2014/main" id="{C3DB5E45-A2BB-24B6-7ADE-021D5E73D9B3}"/>
             </a:ext>
           </a:extLst>
@@ -10702,7 +11564,7 @@
           <a:p>
             <a:fld id="{771FCE44-14AA-407B-9781-80C2DD8F374A}" type="datetime1">
               <a:rPr lang="en-US" smtClean="0"/>
-              <a:t>7/27/2026</a:t>
+              <a:t>8/5/2026</a:t>
             </a:fld>
             <a:endParaRPr lang="en-US" dirty="0"/>
           </a:p>
@@ -10731,7 +11593,7 @@
           <a:p>
             <a:fld id="{6D22F896-40B5-4ADD-8801-0D06FADFA095}" type="slidenum">
               <a:rPr lang="en-US" smtClean="0"/>
-              <a:t>15</a:t>
+              <a:t>17</a:t>
             </a:fld>
             <a:endParaRPr lang="en-US" dirty="0"/>
           </a:p>
@@ -10791,7 +11653,7 @@
 </p:sld>
 </file>
 
-<file path=ppt/slides/slide16.xml><?xml version="1.0" encoding="utf-8"?>
+<file path=ppt/slides/slide18.xml><?xml version="1.0" encoding="utf-8"?>
 <p:sld xmlns:a="http://schemas.openxmlformats.org/drawingml/2006/main" xmlns:r="http://schemas.openxmlformats.org/officeDocument/2006/relationships" xmlns:p="http://schemas.openxmlformats.org/presentationml/2006/main">
   <p:cSld>
     <p:spTree>
@@ -10913,7 +11775,7 @@
           <a:p>
             <a:fld id="{6F8407F0-4949-4EDC-A592-6ECEEFF5A038}" type="datetime1">
               <a:rPr lang="en-US" smtClean="0"/>
-              <a:t>7/27/2026</a:t>
+              <a:t>8/5/2026</a:t>
             </a:fld>
             <a:endParaRPr lang="en-US" dirty="0"/>
           </a:p>
@@ -10971,7 +11833,7 @@
           <a:p>
             <a:fld id="{6D22F896-40B5-4ADD-8801-0D06FADFA095}" type="slidenum">
               <a:rPr lang="en-US" smtClean="0"/>
-              <a:t>16</a:t>
+              <a:t>18</a:t>
             </a:fld>
             <a:endParaRPr lang="en-US" dirty="0"/>
           </a:p>
@@ -10990,7 +11852,7 @@
 </p:sld>
 </file>
 
-<file path=ppt/slides/slide17.xml><?xml version="1.0" encoding="utf-8"?>
+<file path=ppt/slides/slide19.xml><?xml version="1.0" encoding="utf-8"?>
 <p:sld xmlns:a="http://schemas.openxmlformats.org/drawingml/2006/main" xmlns:r="http://schemas.openxmlformats.org/officeDocument/2006/relationships" xmlns:p="http://schemas.openxmlformats.org/presentationml/2006/main">
   <p:cSld>
     <p:spTree>
@@ -11135,7 +11997,7 @@
           <a:p>
             <a:fld id="{6F8407F0-4949-4EDC-A592-6ECEEFF5A038}" type="datetime1">
               <a:rPr lang="en-US" smtClean="0"/>
-              <a:t>7/27/2026</a:t>
+              <a:t>8/5/2026</a:t>
             </a:fld>
             <a:endParaRPr lang="en-US" dirty="0"/>
           </a:p>
@@ -11193,7 +12055,7 @@
           <a:p>
             <a:fld id="{6D22F896-40B5-4ADD-8801-0D06FADFA095}" type="slidenum">
               <a:rPr lang="en-US" smtClean="0"/>
-              <a:t>17</a:t>
+              <a:t>19</a:t>
             </a:fld>
             <a:endParaRPr lang="en-US" dirty="0"/>
           </a:p>
@@ -11203,650 +12065,6 @@
     <p:extLst>
       <p:ext uri="{BB962C8B-B14F-4D97-AF65-F5344CB8AC3E}">
         <p14:creationId xmlns:p14="http://schemas.microsoft.com/office/powerpoint/2010/main" val="3329793323"/>
-      </p:ext>
-    </p:extLst>
-  </p:cSld>
-  <p:clrMapOvr>
-    <a:masterClrMapping/>
-  </p:clrMapOvr>
-</p:sld>
-</file>
-
-<file path=ppt/slides/slide18.xml><?xml version="1.0" encoding="utf-8"?>
-<p:sld xmlns:a="http://schemas.openxmlformats.org/drawingml/2006/main" xmlns:r="http://schemas.openxmlformats.org/officeDocument/2006/relationships" xmlns:p="http://schemas.openxmlformats.org/presentationml/2006/main">
-  <p:cSld>
-    <p:spTree>
-      <p:nvGrpSpPr>
-        <p:cNvPr id="1" name="">
-          <a:extLst>
-            <a:ext uri="{FF2B5EF4-FFF2-40B4-BE49-F238E27FC236}">
-              <a16:creationId xmlns:a16="http://schemas.microsoft.com/office/drawing/2014/main" id="{568A6AB6-45D7-F0A0-7CEE-B0367677A124}"/>
-            </a:ext>
-          </a:extLst>
-        </p:cNvPr>
-        <p:cNvGrpSpPr/>
-        <p:nvPr/>
-      </p:nvGrpSpPr>
-      <p:grpSpPr>
-        <a:xfrm>
-          <a:off x="0" y="0"/>
-          <a:ext cx="0" cy="0"/>
-          <a:chOff x="0" y="0"/>
-          <a:chExt cx="0" cy="0"/>
-        </a:xfrm>
-      </p:grpSpPr>
-      <p:sp>
-        <p:nvSpPr>
-          <p:cNvPr id="2" name="Title 1">
-            <a:extLst>
-              <a:ext uri="{FF2B5EF4-FFF2-40B4-BE49-F238E27FC236}">
-                <a16:creationId xmlns:a16="http://schemas.microsoft.com/office/drawing/2014/main" id="{5F8C4005-840E-B349-05C4-F38CF89360F9}"/>
-              </a:ext>
-            </a:extLst>
-          </p:cNvPr>
-          <p:cNvSpPr>
-            <a:spLocks noGrp="1"/>
-          </p:cNvSpPr>
-          <p:nvPr>
-            <p:ph type="title"/>
-          </p:nvPr>
-        </p:nvSpPr>
-        <p:spPr>
-          <a:xfrm>
-            <a:off x="677334" y="609600"/>
-            <a:ext cx="8596668" cy="919655"/>
-          </a:xfrm>
-        </p:spPr>
-        <p:txBody>
-          <a:bodyPr>
-            <a:normAutofit fontScale="90000"/>
-          </a:bodyPr>
-          <a:lstStyle/>
-          <a:p>
-            <a:r>
-              <a:rPr lang="en-US" dirty="0"/>
-              <a:t> How the Pieces Move (in computer eyes)</a:t>
-            </a:r>
-          </a:p>
-        </p:txBody>
-      </p:sp>
-      <p:sp>
-        <p:nvSpPr>
-          <p:cNvPr id="3" name="Content Placeholder 2">
-            <a:extLst>
-              <a:ext uri="{FF2B5EF4-FFF2-40B4-BE49-F238E27FC236}">
-                <a16:creationId xmlns:a16="http://schemas.microsoft.com/office/drawing/2014/main" id="{83CA724E-E66D-3CBA-CC00-B7A53C1CA232}"/>
-              </a:ext>
-            </a:extLst>
-          </p:cNvPr>
-          <p:cNvSpPr>
-            <a:spLocks noGrp="1"/>
-          </p:cNvSpPr>
-          <p:nvPr>
-            <p:ph idx="1"/>
-          </p:nvPr>
-        </p:nvSpPr>
-        <p:spPr>
-          <a:xfrm>
-            <a:off x="362607" y="1529255"/>
-            <a:ext cx="9601200" cy="4512107"/>
-          </a:xfrm>
-        </p:spPr>
-        <p:txBody>
-          <a:bodyPr>
-            <a:normAutofit/>
-          </a:bodyPr>
-          <a:lstStyle/>
-          <a:p>
-            <a:r>
-              <a:rPr lang="en-US" sz="3600" dirty="0"/>
-              <a:t>Move/Capture in a direction</a:t>
-            </a:r>
-          </a:p>
-          <a:p>
-            <a:r>
-              <a:rPr lang="en-US" sz="3600" dirty="0"/>
-              <a:t> Move directions, as number pairs</a:t>
-            </a:r>
-          </a:p>
-          <a:p>
-            <a:pPr marL="800100" lvl="2" indent="0">
-              <a:buNone/>
-            </a:pPr>
-            <a:r>
-              <a:rPr lang="en-US" sz="3200" dirty="0">
-                <a:latin typeface="Courier New" panose="02070309020205020404" pitchFamily="49" charset="0"/>
-                <a:cs typeface="Courier New" panose="02070309020205020404" pitchFamily="49" charset="0"/>
-              </a:rPr>
-              <a:t>(-1,1)  (0,1)  (1,1)</a:t>
-            </a:r>
-          </a:p>
-          <a:p>
-            <a:pPr marL="800100" lvl="2" indent="0">
-              <a:buNone/>
-            </a:pPr>
-            <a:r>
-              <a:rPr lang="en-US" sz="3200" dirty="0">
-                <a:latin typeface="Courier New" panose="02070309020205020404" pitchFamily="49" charset="0"/>
-                <a:cs typeface="Courier New" panose="02070309020205020404" pitchFamily="49" charset="0"/>
-              </a:rPr>
-              <a:t>(-1,0)  </a:t>
-            </a:r>
-            <a:r>
-              <a:rPr lang="en-US" sz="3200" b="1" dirty="0">
-                <a:solidFill>
-                  <a:srgbClr val="00B0F0"/>
-                </a:solidFill>
-                <a:latin typeface="Courier New" panose="02070309020205020404" pitchFamily="49" charset="0"/>
-                <a:cs typeface="Courier New" panose="02070309020205020404" pitchFamily="49" charset="0"/>
-              </a:rPr>
-              <a:t>piece</a:t>
-            </a:r>
-            <a:r>
-              <a:rPr lang="en-US" sz="3200" dirty="0">
-                <a:latin typeface="Courier New" panose="02070309020205020404" pitchFamily="49" charset="0"/>
-                <a:cs typeface="Courier New" panose="02070309020205020404" pitchFamily="49" charset="0"/>
-              </a:rPr>
-              <a:t>  (1,0)</a:t>
-            </a:r>
-          </a:p>
-          <a:p>
-            <a:pPr marL="800100" lvl="2" indent="0">
-              <a:buNone/>
-            </a:pPr>
-            <a:r>
-              <a:rPr lang="en-US" sz="3200" dirty="0">
-                <a:latin typeface="Courier New" panose="02070309020205020404" pitchFamily="49" charset="0"/>
-                <a:cs typeface="Courier New" panose="02070309020205020404" pitchFamily="49" charset="0"/>
-              </a:rPr>
-              <a:t>(-1,-1) (0,-1) (1,-1)</a:t>
-            </a:r>
-          </a:p>
-          <a:p>
-            <a:pPr marL="0" indent="0">
-              <a:buNone/>
-            </a:pPr>
-            <a:r>
-              <a:rPr lang="en-US" sz="3000" dirty="0">
-                <a:solidFill>
-                  <a:schemeClr val="tx1"/>
-                </a:solidFill>
-              </a:rPr>
-              <a:t>(-:left, 0:same, +:right, -:down, 0:same, +:up)</a:t>
-            </a:r>
-          </a:p>
-          <a:p>
-            <a:pPr marL="457200" indent="-457200"/>
-            <a:r>
-              <a:rPr lang="en-US" sz="3600" dirty="0"/>
-              <a:t>Arithmetic calculates destinations</a:t>
-            </a:r>
-          </a:p>
-          <a:p>
-            <a:pPr marL="800100" lvl="2" indent="0">
-              <a:buNone/>
-            </a:pPr>
-            <a:endParaRPr lang="en-US" sz="3200" dirty="0">
-              <a:latin typeface="Courier New" panose="02070309020205020404" pitchFamily="49" charset="0"/>
-              <a:cs typeface="Courier New" panose="02070309020205020404" pitchFamily="49" charset="0"/>
-            </a:endParaRPr>
-          </a:p>
-        </p:txBody>
-      </p:sp>
-      <p:sp>
-        <p:nvSpPr>
-          <p:cNvPr id="4" name="Date Placeholder 3">
-            <a:extLst>
-              <a:ext uri="{FF2B5EF4-FFF2-40B4-BE49-F238E27FC236}">
-                <a16:creationId xmlns:a16="http://schemas.microsoft.com/office/drawing/2014/main" id="{2B0D7575-DB95-D1B9-970F-D17F1AEE494F}"/>
-              </a:ext>
-            </a:extLst>
-          </p:cNvPr>
-          <p:cNvSpPr>
-            <a:spLocks noGrp="1"/>
-          </p:cNvSpPr>
-          <p:nvPr>
-            <p:ph type="dt" sz="half" idx="10"/>
-          </p:nvPr>
-        </p:nvSpPr>
-        <p:spPr/>
-        <p:txBody>
-          <a:bodyPr/>
-          <a:lstStyle/>
-          <a:p>
-            <a:fld id="{6F8407F0-4949-4EDC-A592-6ECEEFF5A038}" type="datetime1">
-              <a:rPr lang="en-US" smtClean="0"/>
-              <a:t>7/27/2026</a:t>
-            </a:fld>
-            <a:endParaRPr lang="en-US" dirty="0"/>
-          </a:p>
-        </p:txBody>
-      </p:sp>
-      <p:sp>
-        <p:nvSpPr>
-          <p:cNvPr id="5" name="Footer Placeholder 4">
-            <a:extLst>
-              <a:ext uri="{FF2B5EF4-FFF2-40B4-BE49-F238E27FC236}">
-                <a16:creationId xmlns:a16="http://schemas.microsoft.com/office/drawing/2014/main" id="{DD3CA130-7166-B530-51DB-143C46A1F628}"/>
-              </a:ext>
-            </a:extLst>
-          </p:cNvPr>
-          <p:cNvSpPr>
-            <a:spLocks noGrp="1"/>
-          </p:cNvSpPr>
-          <p:nvPr>
-            <p:ph type="ftr" sz="quarter" idx="11"/>
-          </p:nvPr>
-        </p:nvSpPr>
-        <p:spPr/>
-        <p:txBody>
-          <a:bodyPr/>
-          <a:lstStyle/>
-          <a:p>
-            <a:r>
-              <a:rPr lang="en-US"/>
-              <a:t>raysmith@alum.mit.edu                     Session 2 – Building Blocks</a:t>
-            </a:r>
-            <a:endParaRPr lang="en-US" dirty="0"/>
-          </a:p>
-        </p:txBody>
-      </p:sp>
-      <p:sp>
-        <p:nvSpPr>
-          <p:cNvPr id="6" name="Slide Number Placeholder 5">
-            <a:extLst>
-              <a:ext uri="{FF2B5EF4-FFF2-40B4-BE49-F238E27FC236}">
-                <a16:creationId xmlns:a16="http://schemas.microsoft.com/office/drawing/2014/main" id="{683B6B92-1060-278C-DB8A-FCC281440B42}"/>
-              </a:ext>
-            </a:extLst>
-          </p:cNvPr>
-          <p:cNvSpPr>
-            <a:spLocks noGrp="1"/>
-          </p:cNvSpPr>
-          <p:nvPr>
-            <p:ph type="sldNum" sz="quarter" idx="12"/>
-          </p:nvPr>
-        </p:nvSpPr>
-        <p:spPr/>
-        <p:txBody>
-          <a:bodyPr/>
-          <a:lstStyle/>
-          <a:p>
-            <a:fld id="{6D22F896-40B5-4ADD-8801-0D06FADFA095}" type="slidenum">
-              <a:rPr lang="en-US" smtClean="0"/>
-              <a:t>18</a:t>
-            </a:fld>
-            <a:endParaRPr lang="en-US" dirty="0"/>
-          </a:p>
-        </p:txBody>
-      </p:sp>
-    </p:spTree>
-    <p:extLst>
-      <p:ext uri="{BB962C8B-B14F-4D97-AF65-F5344CB8AC3E}">
-        <p14:creationId xmlns:p14="http://schemas.microsoft.com/office/powerpoint/2010/main" val="2584085676"/>
-      </p:ext>
-    </p:extLst>
-  </p:cSld>
-  <p:clrMapOvr>
-    <a:masterClrMapping/>
-  </p:clrMapOvr>
-</p:sld>
-</file>
-
-<file path=ppt/slides/slide19.xml><?xml version="1.0" encoding="utf-8"?>
-<p:sld xmlns:a="http://schemas.openxmlformats.org/drawingml/2006/main" xmlns:r="http://schemas.openxmlformats.org/officeDocument/2006/relationships" xmlns:p="http://schemas.openxmlformats.org/presentationml/2006/main">
-  <p:cSld>
-    <p:spTree>
-      <p:nvGrpSpPr>
-        <p:cNvPr id="1" name="">
-          <a:extLst>
-            <a:ext uri="{FF2B5EF4-FFF2-40B4-BE49-F238E27FC236}">
-              <a16:creationId xmlns:a16="http://schemas.microsoft.com/office/drawing/2014/main" id="{96F9300A-91D4-0213-0591-8BCCA96D6202}"/>
-            </a:ext>
-          </a:extLst>
-        </p:cNvPr>
-        <p:cNvGrpSpPr/>
-        <p:nvPr/>
-      </p:nvGrpSpPr>
-      <p:grpSpPr>
-        <a:xfrm>
-          <a:off x="0" y="0"/>
-          <a:ext cx="0" cy="0"/>
-          <a:chOff x="0" y="0"/>
-          <a:chExt cx="0" cy="0"/>
-        </a:xfrm>
-      </p:grpSpPr>
-      <p:sp>
-        <p:nvSpPr>
-          <p:cNvPr id="2" name="Title 1">
-            <a:extLst>
-              <a:ext uri="{FF2B5EF4-FFF2-40B4-BE49-F238E27FC236}">
-                <a16:creationId xmlns:a16="http://schemas.microsoft.com/office/drawing/2014/main" id="{4B2D49CF-42A2-5BFB-1662-DA26C66EFFE4}"/>
-              </a:ext>
-            </a:extLst>
-          </p:cNvPr>
-          <p:cNvSpPr>
-            <a:spLocks noGrp="1"/>
-          </p:cNvSpPr>
-          <p:nvPr>
-            <p:ph type="title"/>
-          </p:nvPr>
-        </p:nvSpPr>
-        <p:spPr>
-          <a:xfrm>
-            <a:off x="677334" y="609600"/>
-            <a:ext cx="8596668" cy="919655"/>
-          </a:xfrm>
-        </p:spPr>
-        <p:txBody>
-          <a:bodyPr/>
-          <a:lstStyle/>
-          <a:p>
-            <a:r>
-              <a:rPr lang="en-US" dirty="0"/>
-              <a:t> Pawn Move Direction Lists</a:t>
-            </a:r>
-          </a:p>
-        </p:txBody>
-      </p:sp>
-      <p:sp>
-        <p:nvSpPr>
-          <p:cNvPr id="3" name="Content Placeholder 2">
-            <a:extLst>
-              <a:ext uri="{FF2B5EF4-FFF2-40B4-BE49-F238E27FC236}">
-                <a16:creationId xmlns:a16="http://schemas.microsoft.com/office/drawing/2014/main" id="{34AEEDB6-69A7-D882-E9BB-9784EDB8F0E9}"/>
-              </a:ext>
-            </a:extLst>
-          </p:cNvPr>
-          <p:cNvSpPr>
-            <a:spLocks noGrp="1"/>
-          </p:cNvSpPr>
-          <p:nvPr>
-            <p:ph idx="1"/>
-          </p:nvPr>
-        </p:nvSpPr>
-        <p:spPr>
-          <a:xfrm>
-            <a:off x="677333" y="2160589"/>
-            <a:ext cx="9081521" cy="3880773"/>
-          </a:xfrm>
-        </p:spPr>
-        <p:txBody>
-          <a:bodyPr>
-            <a:normAutofit fontScale="92500" lnSpcReduction="20000"/>
-          </a:bodyPr>
-          <a:lstStyle/>
-          <a:p>
-            <a:pPr marL="0" indent="0">
-              <a:buNone/>
-            </a:pPr>
-            <a:r>
-              <a:rPr lang="en-US" sz="3600" dirty="0"/>
-              <a:t> </a:t>
-            </a:r>
-            <a:r>
-              <a:rPr lang="en-US" sz="3600" dirty="0">
-                <a:solidFill>
-                  <a:schemeClr val="accent1"/>
-                </a:solidFill>
-              </a:rPr>
-              <a:t>pawn – list of directions:</a:t>
-            </a:r>
-          </a:p>
-          <a:p>
-            <a:pPr marL="0" indent="0">
-              <a:buNone/>
-            </a:pPr>
-            <a:r>
-              <a:rPr lang="en-US" sz="3600" dirty="0">
-                <a:solidFill>
-                  <a:schemeClr val="accent1"/>
-                </a:solidFill>
-              </a:rPr>
-              <a:t> Third entry for </a:t>
-            </a:r>
-            <a:r>
-              <a:rPr lang="en-US" sz="3600" dirty="0">
-                <a:solidFill>
-                  <a:schemeClr val="accent2"/>
-                </a:solidFill>
-              </a:rPr>
-              <a:t>move</a:t>
-            </a:r>
-            <a:r>
-              <a:rPr lang="en-US" sz="3600" dirty="0">
-                <a:solidFill>
-                  <a:schemeClr val="accent1"/>
-                </a:solidFill>
-              </a:rPr>
-              <a:t> /</a:t>
-            </a:r>
-            <a:r>
-              <a:rPr lang="en-US" sz="3600" dirty="0">
-                <a:solidFill>
-                  <a:schemeClr val="accent5"/>
-                </a:solidFill>
-              </a:rPr>
-              <a:t>capture</a:t>
-            </a:r>
-          </a:p>
-          <a:p>
-            <a:pPr marL="0" indent="0">
-              <a:buNone/>
-            </a:pPr>
-            <a:r>
-              <a:rPr lang="en-US" sz="3600" dirty="0">
-                <a:solidFill>
-                  <a:schemeClr val="accent1"/>
-                </a:solidFill>
-              </a:rPr>
-              <a:t>  </a:t>
-            </a:r>
-          </a:p>
-          <a:p>
-            <a:pPr marL="0" indent="0">
-              <a:buNone/>
-            </a:pPr>
-            <a:r>
-              <a:rPr lang="en-US" sz="3600" dirty="0"/>
-              <a:t>  white:  (0,1,"</a:t>
-            </a:r>
-            <a:r>
-              <a:rPr lang="en-US" sz="3600" dirty="0">
-                <a:solidFill>
-                  <a:srgbClr val="00B050"/>
-                </a:solidFill>
-              </a:rPr>
-              <a:t>move</a:t>
-            </a:r>
-            <a:r>
-              <a:rPr lang="en-US" sz="3600" dirty="0"/>
-              <a:t>"), (-1,1, "</a:t>
-            </a:r>
-            <a:r>
-              <a:rPr lang="en-US" sz="3600" dirty="0">
-                <a:solidFill>
-                  <a:schemeClr val="accent5"/>
-                </a:solidFill>
-              </a:rPr>
-              <a:t>capture</a:t>
-            </a:r>
-            <a:r>
-              <a:rPr lang="en-US" sz="3600" dirty="0"/>
-              <a:t>")</a:t>
-            </a:r>
-          </a:p>
-          <a:p>
-            <a:pPr marL="0" indent="0">
-              <a:buNone/>
-            </a:pPr>
-            <a:r>
-              <a:rPr lang="en-US" sz="3600" dirty="0"/>
-              <a:t>             (1,1,"</a:t>
-            </a:r>
-            <a:r>
-              <a:rPr lang="en-US" sz="3600" dirty="0">
-                <a:solidFill>
-                  <a:schemeClr val="accent5"/>
-                </a:solidFill>
-              </a:rPr>
-              <a:t>capture</a:t>
-            </a:r>
-            <a:r>
-              <a:rPr lang="en-US" sz="3600" dirty="0"/>
-              <a:t>")</a:t>
-            </a:r>
-          </a:p>
-          <a:p>
-            <a:pPr marL="0" indent="0">
-              <a:buNone/>
-            </a:pPr>
-            <a:r>
-              <a:rPr lang="en-US" sz="3600" dirty="0"/>
-              <a:t>  black:  (0,-1,"</a:t>
-            </a:r>
-            <a:r>
-              <a:rPr lang="en-US" sz="3600" dirty="0">
-                <a:solidFill>
-                  <a:schemeClr val="accent2"/>
-                </a:solidFill>
-              </a:rPr>
-              <a:t>move</a:t>
-            </a:r>
-            <a:r>
-              <a:rPr lang="en-US" sz="3600" dirty="0"/>
-              <a:t>"), (-1,-1, "</a:t>
-            </a:r>
-            <a:r>
-              <a:rPr lang="en-US" sz="3600" dirty="0">
-                <a:solidFill>
-                  <a:schemeClr val="accent5"/>
-                </a:solidFill>
-              </a:rPr>
-              <a:t>capture</a:t>
-            </a:r>
-            <a:r>
-              <a:rPr lang="en-US" sz="3600" dirty="0"/>
-              <a:t>"),</a:t>
-            </a:r>
-          </a:p>
-          <a:p>
-            <a:pPr marL="0" indent="0">
-              <a:buNone/>
-            </a:pPr>
-            <a:r>
-              <a:rPr lang="en-US" sz="3600" dirty="0"/>
-              <a:t>             (1,-1,"</a:t>
-            </a:r>
-            <a:r>
-              <a:rPr lang="en-US" sz="3600" dirty="0">
-                <a:solidFill>
-                  <a:schemeClr val="accent5"/>
-                </a:solidFill>
-              </a:rPr>
-              <a:t>capture</a:t>
-            </a:r>
-            <a:r>
-              <a:rPr lang="en-US" sz="3600" dirty="0"/>
-              <a:t>")],</a:t>
-            </a:r>
-          </a:p>
-          <a:p>
-            <a:endParaRPr lang="en-US" sz="3600" dirty="0"/>
-          </a:p>
-        </p:txBody>
-      </p:sp>
-      <p:sp>
-        <p:nvSpPr>
-          <p:cNvPr id="4" name="Date Placeholder 3">
-            <a:extLst>
-              <a:ext uri="{FF2B5EF4-FFF2-40B4-BE49-F238E27FC236}">
-                <a16:creationId xmlns:a16="http://schemas.microsoft.com/office/drawing/2014/main" id="{C36264F9-8A8F-908D-231E-B5B2AB5DE42D}"/>
-              </a:ext>
-            </a:extLst>
-          </p:cNvPr>
-          <p:cNvSpPr>
-            <a:spLocks noGrp="1"/>
-          </p:cNvSpPr>
-          <p:nvPr>
-            <p:ph type="dt" sz="half" idx="10"/>
-          </p:nvPr>
-        </p:nvSpPr>
-        <p:spPr/>
-        <p:txBody>
-          <a:bodyPr/>
-          <a:lstStyle/>
-          <a:p>
-            <a:fld id="{6F8407F0-4949-4EDC-A592-6ECEEFF5A038}" type="datetime1">
-              <a:rPr lang="en-US" smtClean="0"/>
-              <a:t>7/27/2026</a:t>
-            </a:fld>
-            <a:endParaRPr lang="en-US" dirty="0"/>
-          </a:p>
-        </p:txBody>
-      </p:sp>
-      <p:sp>
-        <p:nvSpPr>
-          <p:cNvPr id="5" name="Footer Placeholder 4">
-            <a:extLst>
-              <a:ext uri="{FF2B5EF4-FFF2-40B4-BE49-F238E27FC236}">
-                <a16:creationId xmlns:a16="http://schemas.microsoft.com/office/drawing/2014/main" id="{B5E763EC-CF35-80FC-6010-FC4821ABD43A}"/>
-              </a:ext>
-            </a:extLst>
-          </p:cNvPr>
-          <p:cNvSpPr>
-            <a:spLocks noGrp="1"/>
-          </p:cNvSpPr>
-          <p:nvPr>
-            <p:ph type="ftr" sz="quarter" idx="11"/>
-          </p:nvPr>
-        </p:nvSpPr>
-        <p:spPr/>
-        <p:txBody>
-          <a:bodyPr/>
-          <a:lstStyle/>
-          <a:p>
-            <a:r>
-              <a:rPr lang="en-US"/>
-              <a:t>raysmith@alum.mit.edu                     Session 2 – Building Blocks</a:t>
-            </a:r>
-            <a:endParaRPr lang="en-US" dirty="0"/>
-          </a:p>
-        </p:txBody>
-      </p:sp>
-      <p:sp>
-        <p:nvSpPr>
-          <p:cNvPr id="6" name="Slide Number Placeholder 5">
-            <a:extLst>
-              <a:ext uri="{FF2B5EF4-FFF2-40B4-BE49-F238E27FC236}">
-                <a16:creationId xmlns:a16="http://schemas.microsoft.com/office/drawing/2014/main" id="{AABE5C57-4D0C-0A4B-CDA9-59126E65613F}"/>
-              </a:ext>
-            </a:extLst>
-          </p:cNvPr>
-          <p:cNvSpPr>
-            <a:spLocks noGrp="1"/>
-          </p:cNvSpPr>
-          <p:nvPr>
-            <p:ph type="sldNum" sz="quarter" idx="12"/>
-          </p:nvPr>
-        </p:nvSpPr>
-        <p:spPr/>
-        <p:txBody>
-          <a:bodyPr/>
-          <a:lstStyle/>
-          <a:p>
-            <a:fld id="{6D22F896-40B5-4ADD-8801-0D06FADFA095}" type="slidenum">
-              <a:rPr lang="en-US" smtClean="0"/>
-              <a:t>19</a:t>
-            </a:fld>
-            <a:endParaRPr lang="en-US" dirty="0"/>
-          </a:p>
-        </p:txBody>
-      </p:sp>
-    </p:spTree>
-    <p:extLst>
-      <p:ext uri="{BB962C8B-B14F-4D97-AF65-F5344CB8AC3E}">
-        <p14:creationId xmlns:p14="http://schemas.microsoft.com/office/powerpoint/2010/main" val="895188894"/>
       </p:ext>
     </p:extLst>
   </p:cSld>
@@ -11971,7 +12189,7 @@
           <a:p>
             <a:fld id="{771FCE44-14AA-407B-9781-80C2DD8F374A}" type="datetime1">
               <a:rPr lang="en-US" smtClean="0"/>
-              <a:t>7/27/2026</a:t>
+              <a:t>8/5/2026</a:t>
             </a:fld>
             <a:endParaRPr lang="en-US" dirty="0"/>
           </a:p>
@@ -12067,6 +12285,650 @@
         <p:cNvPr id="1" name="">
           <a:extLst>
             <a:ext uri="{FF2B5EF4-FFF2-40B4-BE49-F238E27FC236}">
+              <a16:creationId xmlns:a16="http://schemas.microsoft.com/office/drawing/2014/main" id="{568A6AB6-45D7-F0A0-7CEE-B0367677A124}"/>
+            </a:ext>
+          </a:extLst>
+        </p:cNvPr>
+        <p:cNvGrpSpPr/>
+        <p:nvPr/>
+      </p:nvGrpSpPr>
+      <p:grpSpPr>
+        <a:xfrm>
+          <a:off x="0" y="0"/>
+          <a:ext cx="0" cy="0"/>
+          <a:chOff x="0" y="0"/>
+          <a:chExt cx="0" cy="0"/>
+        </a:xfrm>
+      </p:grpSpPr>
+      <p:sp>
+        <p:nvSpPr>
+          <p:cNvPr id="2" name="Title 1">
+            <a:extLst>
+              <a:ext uri="{FF2B5EF4-FFF2-40B4-BE49-F238E27FC236}">
+                <a16:creationId xmlns:a16="http://schemas.microsoft.com/office/drawing/2014/main" id="{5F8C4005-840E-B349-05C4-F38CF89360F9}"/>
+              </a:ext>
+            </a:extLst>
+          </p:cNvPr>
+          <p:cNvSpPr>
+            <a:spLocks noGrp="1"/>
+          </p:cNvSpPr>
+          <p:nvPr>
+            <p:ph type="title"/>
+          </p:nvPr>
+        </p:nvSpPr>
+        <p:spPr>
+          <a:xfrm>
+            <a:off x="677334" y="609600"/>
+            <a:ext cx="8596668" cy="919655"/>
+          </a:xfrm>
+        </p:spPr>
+        <p:txBody>
+          <a:bodyPr>
+            <a:normAutofit fontScale="90000"/>
+          </a:bodyPr>
+          <a:lstStyle/>
+          <a:p>
+            <a:r>
+              <a:rPr lang="en-US" dirty="0"/>
+              <a:t> How the Pieces Move (in computer eyes)</a:t>
+            </a:r>
+          </a:p>
+        </p:txBody>
+      </p:sp>
+      <p:sp>
+        <p:nvSpPr>
+          <p:cNvPr id="3" name="Content Placeholder 2">
+            <a:extLst>
+              <a:ext uri="{FF2B5EF4-FFF2-40B4-BE49-F238E27FC236}">
+                <a16:creationId xmlns:a16="http://schemas.microsoft.com/office/drawing/2014/main" id="{83CA724E-E66D-3CBA-CC00-B7A53C1CA232}"/>
+              </a:ext>
+            </a:extLst>
+          </p:cNvPr>
+          <p:cNvSpPr>
+            <a:spLocks noGrp="1"/>
+          </p:cNvSpPr>
+          <p:nvPr>
+            <p:ph idx="1"/>
+          </p:nvPr>
+        </p:nvSpPr>
+        <p:spPr>
+          <a:xfrm>
+            <a:off x="362607" y="1529255"/>
+            <a:ext cx="9601200" cy="4512107"/>
+          </a:xfrm>
+        </p:spPr>
+        <p:txBody>
+          <a:bodyPr>
+            <a:normAutofit/>
+          </a:bodyPr>
+          <a:lstStyle/>
+          <a:p>
+            <a:r>
+              <a:rPr lang="en-US" sz="3600" dirty="0"/>
+              <a:t>Move/Capture in a direction</a:t>
+            </a:r>
+          </a:p>
+          <a:p>
+            <a:r>
+              <a:rPr lang="en-US" sz="3600" dirty="0"/>
+              <a:t> Move directions, as number pairs</a:t>
+            </a:r>
+          </a:p>
+          <a:p>
+            <a:pPr marL="800100" lvl="2" indent="0">
+              <a:buNone/>
+            </a:pPr>
+            <a:r>
+              <a:rPr lang="en-US" sz="3200" dirty="0">
+                <a:latin typeface="Courier New" panose="02070309020205020404" pitchFamily="49" charset="0"/>
+                <a:cs typeface="Courier New" panose="02070309020205020404" pitchFamily="49" charset="0"/>
+              </a:rPr>
+              <a:t>(-1,1)  (0,1)  (1,1)</a:t>
+            </a:r>
+          </a:p>
+          <a:p>
+            <a:pPr marL="800100" lvl="2" indent="0">
+              <a:buNone/>
+            </a:pPr>
+            <a:r>
+              <a:rPr lang="en-US" sz="3200" dirty="0">
+                <a:latin typeface="Courier New" panose="02070309020205020404" pitchFamily="49" charset="0"/>
+                <a:cs typeface="Courier New" panose="02070309020205020404" pitchFamily="49" charset="0"/>
+              </a:rPr>
+              <a:t>(-1,0)  </a:t>
+            </a:r>
+            <a:r>
+              <a:rPr lang="en-US" sz="3200" b="1" dirty="0">
+                <a:solidFill>
+                  <a:srgbClr val="00B0F0"/>
+                </a:solidFill>
+                <a:latin typeface="Courier New" panose="02070309020205020404" pitchFamily="49" charset="0"/>
+                <a:cs typeface="Courier New" panose="02070309020205020404" pitchFamily="49" charset="0"/>
+              </a:rPr>
+              <a:t>piece</a:t>
+            </a:r>
+            <a:r>
+              <a:rPr lang="en-US" sz="3200" dirty="0">
+                <a:latin typeface="Courier New" panose="02070309020205020404" pitchFamily="49" charset="0"/>
+                <a:cs typeface="Courier New" panose="02070309020205020404" pitchFamily="49" charset="0"/>
+              </a:rPr>
+              <a:t>  (1,0)</a:t>
+            </a:r>
+          </a:p>
+          <a:p>
+            <a:pPr marL="800100" lvl="2" indent="0">
+              <a:buNone/>
+            </a:pPr>
+            <a:r>
+              <a:rPr lang="en-US" sz="3200" dirty="0">
+                <a:latin typeface="Courier New" panose="02070309020205020404" pitchFamily="49" charset="0"/>
+                <a:cs typeface="Courier New" panose="02070309020205020404" pitchFamily="49" charset="0"/>
+              </a:rPr>
+              <a:t>(-1,-1) (0,-1) (1,-1)</a:t>
+            </a:r>
+          </a:p>
+          <a:p>
+            <a:pPr marL="0" indent="0">
+              <a:buNone/>
+            </a:pPr>
+            <a:r>
+              <a:rPr lang="en-US" sz="3000" dirty="0">
+                <a:solidFill>
+                  <a:schemeClr val="tx1"/>
+                </a:solidFill>
+              </a:rPr>
+              <a:t>(-:left, 0:same, +:right, -:down, 0:same, +:up)</a:t>
+            </a:r>
+          </a:p>
+          <a:p>
+            <a:pPr marL="457200" indent="-457200"/>
+            <a:r>
+              <a:rPr lang="en-US" sz="3600" dirty="0"/>
+              <a:t>Arithmetic calculates destinations</a:t>
+            </a:r>
+          </a:p>
+          <a:p>
+            <a:pPr marL="800100" lvl="2" indent="0">
+              <a:buNone/>
+            </a:pPr>
+            <a:endParaRPr lang="en-US" sz="3200" dirty="0">
+              <a:latin typeface="Courier New" panose="02070309020205020404" pitchFamily="49" charset="0"/>
+              <a:cs typeface="Courier New" panose="02070309020205020404" pitchFamily="49" charset="0"/>
+            </a:endParaRPr>
+          </a:p>
+        </p:txBody>
+      </p:sp>
+      <p:sp>
+        <p:nvSpPr>
+          <p:cNvPr id="4" name="Date Placeholder 3">
+            <a:extLst>
+              <a:ext uri="{FF2B5EF4-FFF2-40B4-BE49-F238E27FC236}">
+                <a16:creationId xmlns:a16="http://schemas.microsoft.com/office/drawing/2014/main" id="{2B0D7575-DB95-D1B9-970F-D17F1AEE494F}"/>
+              </a:ext>
+            </a:extLst>
+          </p:cNvPr>
+          <p:cNvSpPr>
+            <a:spLocks noGrp="1"/>
+          </p:cNvSpPr>
+          <p:nvPr>
+            <p:ph type="dt" sz="half" idx="10"/>
+          </p:nvPr>
+        </p:nvSpPr>
+        <p:spPr/>
+        <p:txBody>
+          <a:bodyPr/>
+          <a:lstStyle/>
+          <a:p>
+            <a:fld id="{6F8407F0-4949-4EDC-A592-6ECEEFF5A038}" type="datetime1">
+              <a:rPr lang="en-US" smtClean="0"/>
+              <a:t>8/5/2026</a:t>
+            </a:fld>
+            <a:endParaRPr lang="en-US" dirty="0"/>
+          </a:p>
+        </p:txBody>
+      </p:sp>
+      <p:sp>
+        <p:nvSpPr>
+          <p:cNvPr id="5" name="Footer Placeholder 4">
+            <a:extLst>
+              <a:ext uri="{FF2B5EF4-FFF2-40B4-BE49-F238E27FC236}">
+                <a16:creationId xmlns:a16="http://schemas.microsoft.com/office/drawing/2014/main" id="{DD3CA130-7166-B530-51DB-143C46A1F628}"/>
+              </a:ext>
+            </a:extLst>
+          </p:cNvPr>
+          <p:cNvSpPr>
+            <a:spLocks noGrp="1"/>
+          </p:cNvSpPr>
+          <p:nvPr>
+            <p:ph type="ftr" sz="quarter" idx="11"/>
+          </p:nvPr>
+        </p:nvSpPr>
+        <p:spPr/>
+        <p:txBody>
+          <a:bodyPr/>
+          <a:lstStyle/>
+          <a:p>
+            <a:r>
+              <a:rPr lang="en-US"/>
+              <a:t>raysmith@alum.mit.edu                     Session 2 – Building Blocks</a:t>
+            </a:r>
+            <a:endParaRPr lang="en-US" dirty="0"/>
+          </a:p>
+        </p:txBody>
+      </p:sp>
+      <p:sp>
+        <p:nvSpPr>
+          <p:cNvPr id="6" name="Slide Number Placeholder 5">
+            <a:extLst>
+              <a:ext uri="{FF2B5EF4-FFF2-40B4-BE49-F238E27FC236}">
+                <a16:creationId xmlns:a16="http://schemas.microsoft.com/office/drawing/2014/main" id="{683B6B92-1060-278C-DB8A-FCC281440B42}"/>
+              </a:ext>
+            </a:extLst>
+          </p:cNvPr>
+          <p:cNvSpPr>
+            <a:spLocks noGrp="1"/>
+          </p:cNvSpPr>
+          <p:nvPr>
+            <p:ph type="sldNum" sz="quarter" idx="12"/>
+          </p:nvPr>
+        </p:nvSpPr>
+        <p:spPr/>
+        <p:txBody>
+          <a:bodyPr/>
+          <a:lstStyle/>
+          <a:p>
+            <a:fld id="{6D22F896-40B5-4ADD-8801-0D06FADFA095}" type="slidenum">
+              <a:rPr lang="en-US" smtClean="0"/>
+              <a:t>20</a:t>
+            </a:fld>
+            <a:endParaRPr lang="en-US" dirty="0"/>
+          </a:p>
+        </p:txBody>
+      </p:sp>
+    </p:spTree>
+    <p:extLst>
+      <p:ext uri="{BB962C8B-B14F-4D97-AF65-F5344CB8AC3E}">
+        <p14:creationId xmlns:p14="http://schemas.microsoft.com/office/powerpoint/2010/main" val="2584085676"/>
+      </p:ext>
+    </p:extLst>
+  </p:cSld>
+  <p:clrMapOvr>
+    <a:masterClrMapping/>
+  </p:clrMapOvr>
+</p:sld>
+</file>
+
+<file path=ppt/slides/slide21.xml><?xml version="1.0" encoding="utf-8"?>
+<p:sld xmlns:a="http://schemas.openxmlformats.org/drawingml/2006/main" xmlns:r="http://schemas.openxmlformats.org/officeDocument/2006/relationships" xmlns:p="http://schemas.openxmlformats.org/presentationml/2006/main">
+  <p:cSld>
+    <p:spTree>
+      <p:nvGrpSpPr>
+        <p:cNvPr id="1" name="">
+          <a:extLst>
+            <a:ext uri="{FF2B5EF4-FFF2-40B4-BE49-F238E27FC236}">
+              <a16:creationId xmlns:a16="http://schemas.microsoft.com/office/drawing/2014/main" id="{96F9300A-91D4-0213-0591-8BCCA96D6202}"/>
+            </a:ext>
+          </a:extLst>
+        </p:cNvPr>
+        <p:cNvGrpSpPr/>
+        <p:nvPr/>
+      </p:nvGrpSpPr>
+      <p:grpSpPr>
+        <a:xfrm>
+          <a:off x="0" y="0"/>
+          <a:ext cx="0" cy="0"/>
+          <a:chOff x="0" y="0"/>
+          <a:chExt cx="0" cy="0"/>
+        </a:xfrm>
+      </p:grpSpPr>
+      <p:sp>
+        <p:nvSpPr>
+          <p:cNvPr id="2" name="Title 1">
+            <a:extLst>
+              <a:ext uri="{FF2B5EF4-FFF2-40B4-BE49-F238E27FC236}">
+                <a16:creationId xmlns:a16="http://schemas.microsoft.com/office/drawing/2014/main" id="{4B2D49CF-42A2-5BFB-1662-DA26C66EFFE4}"/>
+              </a:ext>
+            </a:extLst>
+          </p:cNvPr>
+          <p:cNvSpPr>
+            <a:spLocks noGrp="1"/>
+          </p:cNvSpPr>
+          <p:nvPr>
+            <p:ph type="title"/>
+          </p:nvPr>
+        </p:nvSpPr>
+        <p:spPr>
+          <a:xfrm>
+            <a:off x="677334" y="609600"/>
+            <a:ext cx="8596668" cy="919655"/>
+          </a:xfrm>
+        </p:spPr>
+        <p:txBody>
+          <a:bodyPr/>
+          <a:lstStyle/>
+          <a:p>
+            <a:r>
+              <a:rPr lang="en-US" dirty="0"/>
+              <a:t> Pawn Move Lists</a:t>
+            </a:r>
+          </a:p>
+        </p:txBody>
+      </p:sp>
+      <p:sp>
+        <p:nvSpPr>
+          <p:cNvPr id="3" name="Content Placeholder 2">
+            <a:extLst>
+              <a:ext uri="{FF2B5EF4-FFF2-40B4-BE49-F238E27FC236}">
+                <a16:creationId xmlns:a16="http://schemas.microsoft.com/office/drawing/2014/main" id="{34AEEDB6-69A7-D882-E9BB-9784EDB8F0E9}"/>
+              </a:ext>
+            </a:extLst>
+          </p:cNvPr>
+          <p:cNvSpPr>
+            <a:spLocks noGrp="1"/>
+          </p:cNvSpPr>
+          <p:nvPr>
+            <p:ph idx="1"/>
+          </p:nvPr>
+        </p:nvSpPr>
+        <p:spPr>
+          <a:xfrm>
+            <a:off x="677333" y="2160589"/>
+            <a:ext cx="9081521" cy="3880773"/>
+          </a:xfrm>
+        </p:spPr>
+        <p:txBody>
+          <a:bodyPr>
+            <a:normAutofit fontScale="92500" lnSpcReduction="20000"/>
+          </a:bodyPr>
+          <a:lstStyle/>
+          <a:p>
+            <a:pPr marL="0" indent="0">
+              <a:buNone/>
+            </a:pPr>
+            <a:r>
+              <a:rPr lang="en-US" sz="3600" dirty="0"/>
+              <a:t> </a:t>
+            </a:r>
+            <a:r>
+              <a:rPr lang="en-US" sz="3600" dirty="0">
+                <a:solidFill>
+                  <a:schemeClr val="accent1"/>
+                </a:solidFill>
+              </a:rPr>
+              <a:t>pawn – list of directions:</a:t>
+            </a:r>
+          </a:p>
+          <a:p>
+            <a:pPr marL="0" indent="0">
+              <a:buNone/>
+            </a:pPr>
+            <a:r>
+              <a:rPr lang="en-US" sz="3600" dirty="0">
+                <a:solidFill>
+                  <a:schemeClr val="accent1"/>
+                </a:solidFill>
+              </a:rPr>
+              <a:t> Third entry for </a:t>
+            </a:r>
+            <a:r>
+              <a:rPr lang="en-US" sz="3600" dirty="0">
+                <a:solidFill>
+                  <a:schemeClr val="accent2"/>
+                </a:solidFill>
+              </a:rPr>
+              <a:t>move</a:t>
+            </a:r>
+            <a:r>
+              <a:rPr lang="en-US" sz="3600" dirty="0">
+                <a:solidFill>
+                  <a:schemeClr val="accent1"/>
+                </a:solidFill>
+              </a:rPr>
+              <a:t> /</a:t>
+            </a:r>
+            <a:r>
+              <a:rPr lang="en-US" sz="3600" dirty="0">
+                <a:solidFill>
+                  <a:schemeClr val="accent5"/>
+                </a:solidFill>
+              </a:rPr>
+              <a:t>capture</a:t>
+            </a:r>
+          </a:p>
+          <a:p>
+            <a:pPr marL="0" indent="0">
+              <a:buNone/>
+            </a:pPr>
+            <a:r>
+              <a:rPr lang="en-US" sz="3600" dirty="0">
+                <a:solidFill>
+                  <a:schemeClr val="accent1"/>
+                </a:solidFill>
+              </a:rPr>
+              <a:t>  </a:t>
+            </a:r>
+          </a:p>
+          <a:p>
+            <a:pPr marL="0" indent="0">
+              <a:buNone/>
+            </a:pPr>
+            <a:r>
+              <a:rPr lang="en-US" sz="3600" dirty="0"/>
+              <a:t>  white:  (0,1,"</a:t>
+            </a:r>
+            <a:r>
+              <a:rPr lang="en-US" sz="3600" dirty="0">
+                <a:solidFill>
+                  <a:srgbClr val="00B050"/>
+                </a:solidFill>
+              </a:rPr>
+              <a:t>move</a:t>
+            </a:r>
+            <a:r>
+              <a:rPr lang="en-US" sz="3600" dirty="0"/>
+              <a:t>"), (-1,1, "</a:t>
+            </a:r>
+            <a:r>
+              <a:rPr lang="en-US" sz="3600" dirty="0">
+                <a:solidFill>
+                  <a:schemeClr val="accent5"/>
+                </a:solidFill>
+              </a:rPr>
+              <a:t>capture</a:t>
+            </a:r>
+            <a:r>
+              <a:rPr lang="en-US" sz="3600" dirty="0"/>
+              <a:t>")</a:t>
+            </a:r>
+          </a:p>
+          <a:p>
+            <a:pPr marL="0" indent="0">
+              <a:buNone/>
+            </a:pPr>
+            <a:r>
+              <a:rPr lang="en-US" sz="3600" dirty="0"/>
+              <a:t>             (1,1,"</a:t>
+            </a:r>
+            <a:r>
+              <a:rPr lang="en-US" sz="3600" dirty="0">
+                <a:solidFill>
+                  <a:schemeClr val="accent5"/>
+                </a:solidFill>
+              </a:rPr>
+              <a:t>capture</a:t>
+            </a:r>
+            <a:r>
+              <a:rPr lang="en-US" sz="3600" dirty="0"/>
+              <a:t>")</a:t>
+            </a:r>
+          </a:p>
+          <a:p>
+            <a:pPr marL="0" indent="0">
+              <a:buNone/>
+            </a:pPr>
+            <a:r>
+              <a:rPr lang="en-US" sz="3600" dirty="0"/>
+              <a:t>  black:  (0,-1,"</a:t>
+            </a:r>
+            <a:r>
+              <a:rPr lang="en-US" sz="3600" dirty="0">
+                <a:solidFill>
+                  <a:schemeClr val="accent2"/>
+                </a:solidFill>
+              </a:rPr>
+              <a:t>move</a:t>
+            </a:r>
+            <a:r>
+              <a:rPr lang="en-US" sz="3600" dirty="0"/>
+              <a:t>"), (-1,-1, "</a:t>
+            </a:r>
+            <a:r>
+              <a:rPr lang="en-US" sz="3600" dirty="0">
+                <a:solidFill>
+                  <a:schemeClr val="accent5"/>
+                </a:solidFill>
+              </a:rPr>
+              <a:t>capture</a:t>
+            </a:r>
+            <a:r>
+              <a:rPr lang="en-US" sz="3600" dirty="0"/>
+              <a:t>"),</a:t>
+            </a:r>
+          </a:p>
+          <a:p>
+            <a:pPr marL="0" indent="0">
+              <a:buNone/>
+            </a:pPr>
+            <a:r>
+              <a:rPr lang="en-US" sz="3600" dirty="0"/>
+              <a:t>             (1,-1,"</a:t>
+            </a:r>
+            <a:r>
+              <a:rPr lang="en-US" sz="3600" dirty="0">
+                <a:solidFill>
+                  <a:schemeClr val="accent5"/>
+                </a:solidFill>
+              </a:rPr>
+              <a:t>capture</a:t>
+            </a:r>
+            <a:r>
+              <a:rPr lang="en-US" sz="3600" dirty="0"/>
+              <a:t>")],</a:t>
+            </a:r>
+          </a:p>
+          <a:p>
+            <a:endParaRPr lang="en-US" sz="3600" dirty="0"/>
+          </a:p>
+        </p:txBody>
+      </p:sp>
+      <p:sp>
+        <p:nvSpPr>
+          <p:cNvPr id="4" name="Date Placeholder 3">
+            <a:extLst>
+              <a:ext uri="{FF2B5EF4-FFF2-40B4-BE49-F238E27FC236}">
+                <a16:creationId xmlns:a16="http://schemas.microsoft.com/office/drawing/2014/main" id="{C36264F9-8A8F-908D-231E-B5B2AB5DE42D}"/>
+              </a:ext>
+            </a:extLst>
+          </p:cNvPr>
+          <p:cNvSpPr>
+            <a:spLocks noGrp="1"/>
+          </p:cNvSpPr>
+          <p:nvPr>
+            <p:ph type="dt" sz="half" idx="10"/>
+          </p:nvPr>
+        </p:nvSpPr>
+        <p:spPr/>
+        <p:txBody>
+          <a:bodyPr/>
+          <a:lstStyle/>
+          <a:p>
+            <a:fld id="{6F8407F0-4949-4EDC-A592-6ECEEFF5A038}" type="datetime1">
+              <a:rPr lang="en-US" smtClean="0"/>
+              <a:t>8/5/2026</a:t>
+            </a:fld>
+            <a:endParaRPr lang="en-US" dirty="0"/>
+          </a:p>
+        </p:txBody>
+      </p:sp>
+      <p:sp>
+        <p:nvSpPr>
+          <p:cNvPr id="5" name="Footer Placeholder 4">
+            <a:extLst>
+              <a:ext uri="{FF2B5EF4-FFF2-40B4-BE49-F238E27FC236}">
+                <a16:creationId xmlns:a16="http://schemas.microsoft.com/office/drawing/2014/main" id="{B5E763EC-CF35-80FC-6010-FC4821ABD43A}"/>
+              </a:ext>
+            </a:extLst>
+          </p:cNvPr>
+          <p:cNvSpPr>
+            <a:spLocks noGrp="1"/>
+          </p:cNvSpPr>
+          <p:nvPr>
+            <p:ph type="ftr" sz="quarter" idx="11"/>
+          </p:nvPr>
+        </p:nvSpPr>
+        <p:spPr/>
+        <p:txBody>
+          <a:bodyPr/>
+          <a:lstStyle/>
+          <a:p>
+            <a:r>
+              <a:rPr lang="en-US"/>
+              <a:t>raysmith@alum.mit.edu                     Session 2 – Building Blocks</a:t>
+            </a:r>
+            <a:endParaRPr lang="en-US" dirty="0"/>
+          </a:p>
+        </p:txBody>
+      </p:sp>
+      <p:sp>
+        <p:nvSpPr>
+          <p:cNvPr id="6" name="Slide Number Placeholder 5">
+            <a:extLst>
+              <a:ext uri="{FF2B5EF4-FFF2-40B4-BE49-F238E27FC236}">
+                <a16:creationId xmlns:a16="http://schemas.microsoft.com/office/drawing/2014/main" id="{AABE5C57-4D0C-0A4B-CDA9-59126E65613F}"/>
+              </a:ext>
+            </a:extLst>
+          </p:cNvPr>
+          <p:cNvSpPr>
+            <a:spLocks noGrp="1"/>
+          </p:cNvSpPr>
+          <p:nvPr>
+            <p:ph type="sldNum" sz="quarter" idx="12"/>
+          </p:nvPr>
+        </p:nvSpPr>
+        <p:spPr/>
+        <p:txBody>
+          <a:bodyPr/>
+          <a:lstStyle/>
+          <a:p>
+            <a:fld id="{6D22F896-40B5-4ADD-8801-0D06FADFA095}" type="slidenum">
+              <a:rPr lang="en-US" smtClean="0"/>
+              <a:t>21</a:t>
+            </a:fld>
+            <a:endParaRPr lang="en-US" dirty="0"/>
+          </a:p>
+        </p:txBody>
+      </p:sp>
+    </p:spTree>
+    <p:extLst>
+      <p:ext uri="{BB962C8B-B14F-4D97-AF65-F5344CB8AC3E}">
+        <p14:creationId xmlns:p14="http://schemas.microsoft.com/office/powerpoint/2010/main" val="895188894"/>
+      </p:ext>
+    </p:extLst>
+  </p:cSld>
+  <p:clrMapOvr>
+    <a:masterClrMapping/>
+  </p:clrMapOvr>
+</p:sld>
+</file>
+
+<file path=ppt/slides/slide22.xml><?xml version="1.0" encoding="utf-8"?>
+<p:sld xmlns:a="http://schemas.openxmlformats.org/drawingml/2006/main" xmlns:r="http://schemas.openxmlformats.org/officeDocument/2006/relationships" xmlns:p="http://schemas.openxmlformats.org/presentationml/2006/main">
+  <p:cSld>
+    <p:spTree>
+      <p:nvGrpSpPr>
+        <p:cNvPr id="1" name="">
+          <a:extLst>
+            <a:ext uri="{FF2B5EF4-FFF2-40B4-BE49-F238E27FC236}">
               <a16:creationId xmlns:a16="http://schemas.microsoft.com/office/drawing/2014/main" id="{8A28471E-41DC-94CC-0E06-9BF01DCEA186}"/>
             </a:ext>
           </a:extLst>
@@ -12432,7 +13294,7 @@
           <a:p>
             <a:fld id="{6F8407F0-4949-4EDC-A592-6ECEEFF5A038}" type="datetime1">
               <a:rPr lang="en-US" smtClean="0"/>
-              <a:t>7/27/2026</a:t>
+              <a:t>8/5/2026</a:t>
             </a:fld>
             <a:endParaRPr lang="en-US" dirty="0"/>
           </a:p>
@@ -12489,7 +13351,7 @@
           <a:p>
             <a:fld id="{6D22F896-40B5-4ADD-8801-0D06FADFA095}" type="slidenum">
               <a:rPr lang="en-US" smtClean="0"/>
-              <a:t>20</a:t>
+              <a:t>22</a:t>
             </a:fld>
             <a:endParaRPr lang="en-US" dirty="0"/>
           </a:p>
@@ -12508,7 +13370,7 @@
 </p:sld>
 </file>
 
-<file path=ppt/slides/slide21.xml><?xml version="1.0" encoding="utf-8"?>
+<file path=ppt/slides/slide23.xml><?xml version="1.0" encoding="utf-8"?>
 <p:sld xmlns:a="http://schemas.openxmlformats.org/drawingml/2006/main" xmlns:r="http://schemas.openxmlformats.org/officeDocument/2006/relationships" xmlns:p="http://schemas.openxmlformats.org/presentationml/2006/main">
   <p:cSld>
     <p:spTree>
@@ -12812,7 +13674,7 @@
           <a:p>
             <a:fld id="{6F8407F0-4949-4EDC-A592-6ECEEFF5A038}" type="datetime1">
               <a:rPr lang="en-US" smtClean="0"/>
-              <a:t>7/27/2026</a:t>
+              <a:t>8/5/2026</a:t>
             </a:fld>
             <a:endParaRPr lang="en-US" dirty="0"/>
           </a:p>
@@ -12870,7 +13732,7 @@
           <a:p>
             <a:fld id="{6D22F896-40B5-4ADD-8801-0D06FADFA095}" type="slidenum">
               <a:rPr lang="en-US" smtClean="0"/>
-              <a:t>21</a:t>
+              <a:t>23</a:t>
             </a:fld>
             <a:endParaRPr lang="en-US" dirty="0"/>
           </a:p>
@@ -12889,12 +13751,18 @@
 </p:sld>
 </file>
 
-<file path=ppt/slides/slide22.xml><?xml version="1.0" encoding="utf-8"?>
+<file path=ppt/slides/slide24.xml><?xml version="1.0" encoding="utf-8"?>
 <p:sld xmlns:a="http://schemas.openxmlformats.org/drawingml/2006/main" xmlns:r="http://schemas.openxmlformats.org/officeDocument/2006/relationships" xmlns:p="http://schemas.openxmlformats.org/presentationml/2006/main">
   <p:cSld>
     <p:spTree>
       <p:nvGrpSpPr>
-        <p:cNvPr id="1" name=""/>
+        <p:cNvPr id="1" name="">
+          <a:extLst>
+            <a:ext uri="{FF2B5EF4-FFF2-40B4-BE49-F238E27FC236}">
+              <a16:creationId xmlns:a16="http://schemas.microsoft.com/office/drawing/2014/main" id="{36B21A72-BDAB-6B36-68F1-1E380118D943}"/>
+            </a:ext>
+          </a:extLst>
+        </p:cNvPr>
         <p:cNvGrpSpPr/>
         <p:nvPr/>
       </p:nvGrpSpPr>
@@ -12911,7 +13779,7 @@
           <p:cNvPr id="2" name="Title 1">
             <a:extLst>
               <a:ext uri="{FF2B5EF4-FFF2-40B4-BE49-F238E27FC236}">
-                <a16:creationId xmlns:a16="http://schemas.microsoft.com/office/drawing/2014/main" id="{AEF4448D-772E-6962-35E6-197D77249835}"/>
+                <a16:creationId xmlns:a16="http://schemas.microsoft.com/office/drawing/2014/main" id="{2A9B1AB9-A718-D43C-4E57-4E8892CBFC30}"/>
               </a:ext>
             </a:extLst>
           </p:cNvPr>
@@ -12934,7 +13802,7 @@
           <a:p>
             <a:r>
               <a:rPr lang="en-US" dirty="0"/>
-              <a:t> More Piece Direction Lists</a:t>
+              <a:t> More Piece Move Lists</a:t>
             </a:r>
           </a:p>
         </p:txBody>
@@ -12944,7 +13812,7 @@
           <p:cNvPr id="3" name="Content Placeholder 2">
             <a:extLst>
               <a:ext uri="{FF2B5EF4-FFF2-40B4-BE49-F238E27FC236}">
-                <a16:creationId xmlns:a16="http://schemas.microsoft.com/office/drawing/2014/main" id="{5C929FC1-7551-818F-30F3-BEB638CAF6B1}"/>
+                <a16:creationId xmlns:a16="http://schemas.microsoft.com/office/drawing/2014/main" id="{3D36E51C-FF3D-AD2C-8E45-F7C97A725F98}"/>
               </a:ext>
             </a:extLst>
           </p:cNvPr>
@@ -12963,7 +13831,7 @@
         </p:spPr>
         <p:txBody>
           <a:bodyPr>
-            <a:normAutofit fontScale="92500" lnSpcReduction="10000"/>
+            <a:normAutofit/>
           </a:bodyPr>
           <a:lstStyle/>
           <a:p>
@@ -12976,16 +13844,7 @@
             </a:r>
             <a:r>
               <a:rPr lang="en-US" sz="2800" dirty="0"/>
-              <a:t>Knight: Only one jump of</a:t>
-            </a:r>
-          </a:p>
-          <a:p>
-            <a:pPr marL="0" indent="0">
-              <a:buNone/>
-            </a:pPr>
-            <a:r>
-              <a:rPr lang="en-US" sz="2800" dirty="0"/>
-              <a:t>			(1,2), (2,1), (2,-1), (1,-2),</a:t>
+              <a:t>Knight: 	(1,2), (2,1), (2,-1), (1,-2),</a:t>
             </a:r>
           </a:p>
           <a:p>
@@ -13009,7 +13868,7 @@
             </a:pPr>
             <a:r>
               <a:rPr lang="en-US" sz="2800" dirty="0"/>
-              <a:t>Rest: Can be any length in direction</a:t>
+              <a:t>Bishop: (1,1), (1,-1), (-1,-1), (-1,1)</a:t>
             </a:r>
           </a:p>
           <a:p>
@@ -13018,16 +13877,7 @@
             </a:pPr>
             <a:r>
               <a:rPr lang="en-US" sz="2800" dirty="0"/>
-              <a:t> Bishop: (1,1), (1,-1), (-1,-1), (-1,1)</a:t>
-            </a:r>
-          </a:p>
-          <a:p>
-            <a:pPr marL="0" indent="0">
-              <a:buNone/>
-            </a:pPr>
-            <a:r>
-              <a:rPr lang="en-US" sz="2800" dirty="0"/>
-              <a:t> Rook: (0,1), (1,0), (0,-1), (-1,0)</a:t>
+              <a:t>Rook: (0,1), (1,0), (0,-1), (-1,0)</a:t>
             </a:r>
           </a:p>
           <a:p>
@@ -13045,9 +13895,30 @@
             </a:pPr>
             <a:r>
               <a:rPr lang="en-US" sz="2800" dirty="0"/>
+              <a:t>       B,R,Q, and K: multiples in  that direction</a:t>
+            </a:r>
+          </a:p>
+          <a:p>
+            <a:pPr marL="0" indent="0">
+              <a:buNone/>
+            </a:pPr>
+            <a:r>
+              <a:rPr lang="en-US" sz="2800" dirty="0"/>
               <a:t>King: =    Queen, only 1 square</a:t>
             </a:r>
           </a:p>
+          <a:p>
+            <a:pPr marL="0" indent="0">
+              <a:buNone/>
+            </a:pPr>
+            <a:endParaRPr lang="en-US" sz="2800" dirty="0"/>
+          </a:p>
+          <a:p>
+            <a:pPr marL="0" indent="0">
+              <a:buNone/>
+            </a:pPr>
+            <a:endParaRPr lang="en-US" sz="2800" dirty="0"/>
+          </a:p>
         </p:txBody>
       </p:sp>
       <p:sp>
@@ -13055,7 +13926,7 @@
           <p:cNvPr id="4" name="Date Placeholder 3">
             <a:extLst>
               <a:ext uri="{FF2B5EF4-FFF2-40B4-BE49-F238E27FC236}">
-                <a16:creationId xmlns:a16="http://schemas.microsoft.com/office/drawing/2014/main" id="{B5F701C6-142B-6843-C8E3-87CF424BC299}"/>
+                <a16:creationId xmlns:a16="http://schemas.microsoft.com/office/drawing/2014/main" id="{D813B930-3FE1-CE20-861D-A6D5B86309CC}"/>
               </a:ext>
             </a:extLst>
           </p:cNvPr>
@@ -13073,7 +13944,7 @@
           <a:p>
             <a:fld id="{6F8407F0-4949-4EDC-A592-6ECEEFF5A038}" type="datetime1">
               <a:rPr lang="en-US" smtClean="0"/>
-              <a:t>7/27/2026</a:t>
+              <a:t>8/8/2026</a:t>
             </a:fld>
             <a:endParaRPr lang="en-US" dirty="0"/>
           </a:p>
@@ -13084,7 +13955,7 @@
           <p:cNvPr id="5" name="Footer Placeholder 4">
             <a:extLst>
               <a:ext uri="{FF2B5EF4-FFF2-40B4-BE49-F238E27FC236}">
-                <a16:creationId xmlns:a16="http://schemas.microsoft.com/office/drawing/2014/main" id="{902ADD2F-A6A2-D693-3030-059512318C9F}"/>
+                <a16:creationId xmlns:a16="http://schemas.microsoft.com/office/drawing/2014/main" id="{1DC8BDF5-8EC0-B146-CD60-65A23C10DD12}"/>
               </a:ext>
             </a:extLst>
           </p:cNvPr>
@@ -13113,7 +13984,7 @@
           <p:cNvPr id="6" name="Slide Number Placeholder 5">
             <a:extLst>
               <a:ext uri="{FF2B5EF4-FFF2-40B4-BE49-F238E27FC236}">
-                <a16:creationId xmlns:a16="http://schemas.microsoft.com/office/drawing/2014/main" id="{556A8243-F5B7-05E9-F08A-3E1E49BD9742}"/>
+                <a16:creationId xmlns:a16="http://schemas.microsoft.com/office/drawing/2014/main" id="{8F78275B-67BB-4BB5-591A-4071B8C89F6A}"/>
               </a:ext>
             </a:extLst>
           </p:cNvPr>
@@ -13131,7 +14002,7 @@
           <a:p>
             <a:fld id="{6D22F896-40B5-4ADD-8801-0D06FADFA095}" type="slidenum">
               <a:rPr lang="en-US" smtClean="0"/>
-              <a:t>22</a:t>
+              <a:t>24</a:t>
             </a:fld>
             <a:endParaRPr lang="en-US" dirty="0"/>
           </a:p>
@@ -13140,7 +14011,7 @@
     </p:spTree>
     <p:extLst>
       <p:ext uri="{BB962C8B-B14F-4D97-AF65-F5344CB8AC3E}">
-        <p14:creationId xmlns:p14="http://schemas.microsoft.com/office/powerpoint/2010/main" val="1345139435"/>
+        <p14:creationId xmlns:p14="http://schemas.microsoft.com/office/powerpoint/2010/main" val="2698541730"/>
       </p:ext>
     </p:extLst>
   </p:cSld>
@@ -13150,7 +14021,7 @@
 </p:sld>
 </file>
 
-<file path=ppt/slides/slide23.xml><?xml version="1.0" encoding="utf-8"?>
+<file path=ppt/slides/slide25.xml><?xml version="1.0" encoding="utf-8"?>
 <p:sld xmlns:a="http://schemas.openxmlformats.org/drawingml/2006/main" xmlns:r="http://schemas.openxmlformats.org/officeDocument/2006/relationships" xmlns:p="http://schemas.openxmlformats.org/presentationml/2006/main">
   <p:cSld>
     <p:spTree>
@@ -13371,7 +14242,7 @@
           <a:p>
             <a:fld id="{6F8407F0-4949-4EDC-A592-6ECEEFF5A038}" type="datetime1">
               <a:rPr lang="en-US" smtClean="0"/>
-              <a:t>7/27/2026</a:t>
+              <a:t>8/5/2026</a:t>
             </a:fld>
             <a:endParaRPr lang="en-US" dirty="0"/>
           </a:p>
@@ -13429,7 +14300,7 @@
           <a:p>
             <a:fld id="{6D22F896-40B5-4ADD-8801-0D06FADFA095}" type="slidenum">
               <a:rPr lang="en-US" smtClean="0"/>
-              <a:t>23</a:t>
+              <a:t>25</a:t>
             </a:fld>
             <a:endParaRPr lang="en-US" dirty="0"/>
           </a:p>
@@ -13448,7 +14319,7 @@
 </p:sld>
 </file>
 
-<file path=ppt/slides/slide24.xml><?xml version="1.0" encoding="utf-8"?>
+<file path=ppt/slides/slide26.xml><?xml version="1.0" encoding="utf-8"?>
 <p:sld xmlns:a="http://schemas.openxmlformats.org/drawingml/2006/main" xmlns:r="http://schemas.openxmlformats.org/officeDocument/2006/relationships" xmlns:p="http://schemas.openxmlformats.org/presentationml/2006/main">
   <p:cSld>
     <p:spTree>
@@ -13488,7 +14359,7 @@
           <a:p>
             <a:fld id="{6F8407F0-4949-4EDC-A592-6ECEEFF5A038}" type="datetime1">
               <a:rPr lang="en-US" smtClean="0"/>
-              <a:t>7/27/2026</a:t>
+              <a:t>8/5/2026</a:t>
             </a:fld>
             <a:endParaRPr lang="en-US" dirty="0"/>
           </a:p>
@@ -13546,7 +14417,7 @@
           <a:p>
             <a:fld id="{6D22F896-40B5-4ADD-8801-0D06FADFA095}" type="slidenum">
               <a:rPr lang="en-US" smtClean="0"/>
-              <a:t>24</a:t>
+              <a:t>26</a:t>
             </a:fld>
             <a:endParaRPr lang="en-US" dirty="0"/>
           </a:p>
@@ -13595,7 +14466,7 @@
 </p:sld>
 </file>
 
-<file path=ppt/slides/slide25.xml><?xml version="1.0" encoding="utf-8"?>
+<file path=ppt/slides/slide27.xml><?xml version="1.0" encoding="utf-8"?>
 <p:sld xmlns:a="http://schemas.openxmlformats.org/drawingml/2006/main" xmlns:r="http://schemas.openxmlformats.org/officeDocument/2006/relationships" xmlns:p="http://schemas.openxmlformats.org/presentationml/2006/main">
   <p:cSld>
     <p:spTree>
@@ -13713,7 +14584,7 @@
           <a:p>
             <a:fld id="{F1811B85-6381-4843-915E-A80D8CF566B9}" type="datetime1">
               <a:rPr lang="en-US" smtClean="0"/>
-              <a:t>7/27/2026</a:t>
+              <a:t>8/5/2026</a:t>
             </a:fld>
             <a:endParaRPr lang="en-US" dirty="0"/>
           </a:p>
@@ -13771,7 +14642,7 @@
           <a:p>
             <a:fld id="{6D22F896-40B5-4ADD-8801-0D06FADFA095}" type="slidenum">
               <a:rPr lang="en-US" smtClean="0"/>
-              <a:t>25</a:t>
+              <a:t>27</a:t>
             </a:fld>
             <a:endParaRPr lang="en-US" dirty="0"/>
           </a:p>
@@ -13790,7 +14661,7 @@
 </p:sld>
 </file>
 
-<file path=ppt/slides/slide26.xml><?xml version="1.0" encoding="utf-8"?>
+<file path=ppt/slides/slide28.xml><?xml version="1.0" encoding="utf-8"?>
 <p:sld xmlns:a="http://schemas.openxmlformats.org/drawingml/2006/main" xmlns:r="http://schemas.openxmlformats.org/officeDocument/2006/relationships" xmlns:p="http://schemas.openxmlformats.org/presentationml/2006/main">
   <p:cSld>
     <p:spTree>
@@ -13865,7 +14736,7 @@
           <a:p>
             <a:fld id="{D4091550-E13A-47A9-8AAC-51D029CF9A78}" type="datetime1">
               <a:rPr lang="en-US" smtClean="0"/>
-              <a:t>7/27/2026</a:t>
+              <a:t>8/5/2026</a:t>
             </a:fld>
             <a:endParaRPr lang="en-US" dirty="0"/>
           </a:p>
@@ -13923,7 +14794,7 @@
           <a:p>
             <a:fld id="{6D22F896-40B5-4ADD-8801-0D06FADFA095}" type="slidenum">
               <a:rPr lang="en-US" smtClean="0"/>
-              <a:t>26</a:t>
+              <a:t>28</a:t>
             </a:fld>
             <a:endParaRPr lang="en-US" dirty="0"/>
           </a:p>
@@ -14066,7 +14937,7 @@
           <a:p>
             <a:fld id="{771FCE44-14AA-407B-9781-80C2DD8F374A}" type="datetime1">
               <a:rPr lang="en-US" smtClean="0"/>
-              <a:t>7/27/2026</a:t>
+              <a:t>8/5/2026</a:t>
             </a:fld>
             <a:endParaRPr lang="en-US" dirty="0"/>
           </a:p>
@@ -14292,7 +15163,7 @@
           <a:p>
             <a:fld id="{771FCE44-14AA-407B-9781-80C2DD8F374A}" type="datetime1">
               <a:rPr lang="en-US" smtClean="0"/>
-              <a:t>7/27/2026</a:t>
+              <a:t>8/5/2026</a:t>
             </a:fld>
             <a:endParaRPr lang="en-US" dirty="0"/>
           </a:p>
@@ -14530,7 +15401,7 @@
           <a:p>
             <a:fld id="{771FCE44-14AA-407B-9781-80C2DD8F374A}" type="datetime1">
               <a:rPr lang="en-US" smtClean="0"/>
-              <a:t>7/27/2026</a:t>
+              <a:t>8/5/2026</a:t>
             </a:fld>
             <a:endParaRPr lang="en-US" dirty="0"/>
           </a:p>
@@ -14660,7 +15531,7 @@
             <a:fld id="{6F8407F0-4949-4EDC-A592-6ECEEFF5A038}" type="datetime1">
               <a:rPr lang="en-US" smtClean="0"/>
               <a:pPr/>
-              <a:t>7/27/2026</a:t>
+              <a:t>8/5/2026</a:t>
             </a:fld>
             <a:endParaRPr lang="en-US" dirty="0"/>
           </a:p>
@@ -14815,7 +15686,7 @@
             <a:fld id="{6F8407F0-4949-4EDC-A592-6ECEEFF5A038}" type="datetime1">
               <a:rPr lang="en-US" smtClean="0"/>
               <a:pPr/>
-              <a:t>7/27/2026</a:t>
+              <a:t>8/5/2026</a:t>
             </a:fld>
             <a:endParaRPr lang="en-US" dirty="0"/>
           </a:p>
@@ -15142,7 +16013,7 @@
           <a:p>
             <a:fld id="{6F8407F0-4949-4EDC-A592-6ECEEFF5A038}" type="datetime1">
               <a:rPr lang="en-US" smtClean="0"/>
-              <a:t>7/27/2026</a:t>
+              <a:t>8/5/2026</a:t>
             </a:fld>
             <a:endParaRPr lang="en-US" dirty="0"/>
           </a:p>
@@ -15387,7 +16258,7 @@
           <a:p>
             <a:fld id="{6F8407F0-4949-4EDC-A592-6ECEEFF5A038}" type="datetime1">
               <a:rPr lang="en-US" smtClean="0"/>
-              <a:t>7/27/2026</a:t>
+              <a:t>8/5/2026</a:t>
             </a:fld>
             <a:endParaRPr lang="en-US" dirty="0"/>
           </a:p>

</xml_diff>

<commit_message>
A few parsing corrections
</commit_message>
<xml_diff>
--- a/Docs/Chess Display and Computers.pptx
+++ b/Docs/Chess Display and Computers.pptx
@@ -442,7 +442,7 @@
           <a:p>
             <a:fld id="{5397933D-7A1B-4403-8C00-DE52D8FE2162}" type="datetime1">
               <a:rPr lang="en-US" smtClean="0"/>
-              <a:t>8/5/2026</a:t>
+              <a:t>8/8/2026</a:t>
             </a:fld>
             <a:endParaRPr lang="en-US" dirty="0"/>
           </a:p>
@@ -807,7 +807,7 @@
           <a:p>
             <a:fld id="{DC084F0E-41CF-4207-8B70-198F21418836}" type="datetime1">
               <a:rPr lang="en-US" smtClean="0"/>
-              <a:t>8/5/2026</a:t>
+              <a:t>8/8/2026</a:t>
             </a:fld>
             <a:endParaRPr lang="en-US" dirty="0"/>
           </a:p>
@@ -995,7 +995,7 @@
           <a:p>
             <a:fld id="{E734D050-5128-424E-B0C7-5BFB4917C3AB}" type="datetime1">
               <a:rPr lang="en-US" smtClean="0"/>
-              <a:t>8/5/2026</a:t>
+              <a:t>8/8/2026</a:t>
             </a:fld>
             <a:endParaRPr lang="en-US" dirty="0"/>
           </a:p>
@@ -1595,7 +1595,7 @@
           <a:p>
             <a:fld id="{E734D050-5128-424E-B0C7-5BFB4917C3AB}" type="datetime1">
               <a:rPr lang="en-US" smtClean="0"/>
-              <a:t>8/5/2026</a:t>
+              <a:t>8/8/2026</a:t>
             </a:fld>
             <a:endParaRPr lang="en-US" dirty="0"/>
           </a:p>
@@ -1769,7 +1769,7 @@
           <a:p>
             <a:fld id="{5397933D-7A1B-4403-8C00-DE52D8FE2162}" type="datetime1">
               <a:rPr lang="en-US" smtClean="0"/>
-              <a:t>8/5/2026</a:t>
+              <a:t>8/8/2026</a:t>
             </a:fld>
             <a:endParaRPr lang="en-US" dirty="0"/>
           </a:p>
@@ -1929,7 +1929,7 @@
           <a:p>
             <a:fld id="{5397933D-7A1B-4403-8C00-DE52D8FE2162}" type="datetime1">
               <a:rPr lang="en-US" smtClean="0"/>
-              <a:t>8/5/2026</a:t>
+              <a:t>8/8/2026</a:t>
             </a:fld>
             <a:endParaRPr lang="en-US" dirty="0"/>
           </a:p>
@@ -2088,7 +2088,7 @@
           <a:p>
             <a:fld id="{81E0ADA2-1B64-45DB-B2E6-F6A11AB7EB98}" type="datetime1">
               <a:rPr lang="en-US" smtClean="0"/>
-              <a:t>8/5/2026</a:t>
+              <a:t>8/8/2026</a:t>
             </a:fld>
             <a:endParaRPr lang="en-US" dirty="0"/>
           </a:p>
@@ -2246,7 +2246,7 @@
           <a:p>
             <a:fld id="{E734D050-5128-424E-B0C7-5BFB4917C3AB}" type="datetime1">
               <a:rPr lang="en-US" smtClean="0"/>
-              <a:t>8/5/2026</a:t>
+              <a:t>8/8/2026</a:t>
             </a:fld>
             <a:endParaRPr lang="en-US" dirty="0"/>
           </a:p>
@@ -2434,7 +2434,7 @@
           <a:p>
             <a:fld id="{E734D050-5128-424E-B0C7-5BFB4917C3AB}" type="datetime1">
               <a:rPr lang="en-US" smtClean="0"/>
-              <a:t>8/5/2026</a:t>
+              <a:t>8/8/2026</a:t>
             </a:fld>
             <a:endParaRPr lang="en-US" dirty="0"/>
           </a:p>
@@ -2637,7 +2637,7 @@
           <a:p>
             <a:fld id="{E734D050-5128-424E-B0C7-5BFB4917C3AB}" type="datetime1">
               <a:rPr lang="en-US" smtClean="0"/>
-              <a:t>8/5/2026</a:t>
+              <a:t>8/8/2026</a:t>
             </a:fld>
             <a:endParaRPr lang="en-US" dirty="0"/>
           </a:p>
@@ -2840,7 +2840,7 @@
           <a:p>
             <a:fld id="{E734D050-5128-424E-B0C7-5BFB4917C3AB}" type="datetime1">
               <a:rPr lang="en-US" smtClean="0"/>
-              <a:t>8/5/2026</a:t>
+              <a:t>8/8/2026</a:t>
             </a:fld>
             <a:endParaRPr lang="en-US" dirty="0"/>
           </a:p>
@@ -3040,7 +3040,7 @@
           <a:p>
             <a:fld id="{E734D050-5128-424E-B0C7-5BFB4917C3AB}" type="datetime1">
               <a:rPr lang="en-US" smtClean="0"/>
-              <a:t>8/5/2026</a:t>
+              <a:t>8/8/2026</a:t>
             </a:fld>
             <a:endParaRPr lang="en-US" dirty="0"/>
           </a:p>
@@ -3240,7 +3240,7 @@
           <a:p>
             <a:fld id="{E734D050-5128-424E-B0C7-5BFB4917C3AB}" type="datetime1">
               <a:rPr lang="en-US" smtClean="0"/>
-              <a:t>8/5/2026</a:t>
+              <a:t>8/8/2026</a:t>
             </a:fld>
             <a:endParaRPr lang="en-US" dirty="0"/>
           </a:p>
@@ -3440,7 +3440,7 @@
           <a:p>
             <a:fld id="{E734D050-5128-424E-B0C7-5BFB4917C3AB}" type="datetime1">
               <a:rPr lang="en-US" smtClean="0"/>
-              <a:t>8/5/2026</a:t>
+              <a:t>8/8/2026</a:t>
             </a:fld>
             <a:endParaRPr lang="en-US" dirty="0"/>
           </a:p>
@@ -3640,7 +3640,7 @@
           <a:p>
             <a:fld id="{E734D050-5128-424E-B0C7-5BFB4917C3AB}" type="datetime1">
               <a:rPr lang="en-US" smtClean="0"/>
-              <a:t>8/5/2026</a:t>
+              <a:t>8/8/2026</a:t>
             </a:fld>
             <a:endParaRPr lang="en-US" dirty="0"/>
           </a:p>
@@ -4494,7 +4494,7 @@
           <a:p>
             <a:fld id="{5110D8A6-D61F-4DCA-82DB-6A888A9B2487}" type="datetime1">
               <a:rPr lang="en-US" smtClean="0"/>
-              <a:t>8/5/2026</a:t>
+              <a:t>8/8/2026</a:t>
             </a:fld>
             <a:endParaRPr lang="en-US" dirty="0"/>
           </a:p>
@@ -4761,7 +4761,7 @@
           <a:p>
             <a:fld id="{62C5B04C-660C-4601-8C32-DAC504F51286}" type="datetime1">
               <a:rPr lang="en-US" smtClean="0"/>
-              <a:t>8/5/2026</a:t>
+              <a:t>8/8/2026</a:t>
             </a:fld>
             <a:endParaRPr lang="en-US" dirty="0"/>
           </a:p>
@@ -5080,7 +5080,7 @@
           <a:p>
             <a:fld id="{28495457-F83B-45BB-B822-2DF2A1FD0C27}" type="datetime1">
               <a:rPr lang="en-US" smtClean="0"/>
-              <a:t>8/5/2026</a:t>
+              <a:t>8/8/2026</a:t>
             </a:fld>
             <a:endParaRPr lang="en-US" dirty="0"/>
           </a:p>
@@ -5426,7 +5426,7 @@
           <a:p>
             <a:fld id="{AF75F462-1497-413B-A43E-E69E6D8E4BEF}" type="datetime1">
               <a:rPr lang="en-US" smtClean="0"/>
-              <a:t>8/5/2026</a:t>
+              <a:t>8/8/2026</a:t>
             </a:fld>
             <a:endParaRPr lang="en-US" dirty="0"/>
           </a:p>
@@ -5745,7 +5745,7 @@
           <a:p>
             <a:fld id="{F552C08A-409D-4E56-98A3-A36D8B5C9F4C}" type="datetime1">
               <a:rPr lang="en-US" smtClean="0"/>
-              <a:t>8/5/2026</a:t>
+              <a:t>8/8/2026</a:t>
             </a:fld>
             <a:endParaRPr lang="en-US" dirty="0"/>
           </a:p>
@@ -6143,7 +6143,7 @@
           <a:p>
             <a:fld id="{8469E2CF-C14A-49FB-8201-FEEF3BF16570}" type="datetime1">
               <a:rPr lang="en-US" smtClean="0"/>
-              <a:t>8/5/2026</a:t>
+              <a:t>8/8/2026</a:t>
             </a:fld>
             <a:endParaRPr lang="en-US" dirty="0"/>
           </a:p>
@@ -6318,7 +6318,7 @@
           <a:p>
             <a:fld id="{B4FD04B1-0384-44B0-8537-B8F12FD50EF8}" type="datetime1">
               <a:rPr lang="en-US" smtClean="0"/>
-              <a:t>8/5/2026</a:t>
+              <a:t>8/8/2026</a:t>
             </a:fld>
             <a:endParaRPr lang="en-US" dirty="0"/>
           </a:p>
@@ -6502,7 +6502,7 @@
           <a:p>
             <a:fld id="{DC5F4745-C362-4373-8D92-8EF41093E018}" type="datetime1">
               <a:rPr lang="en-US" smtClean="0"/>
-              <a:t>8/5/2026</a:t>
+              <a:t>8/8/2026</a:t>
             </a:fld>
             <a:endParaRPr lang="en-US" dirty="0"/>
           </a:p>
@@ -6682,7 +6682,7 @@
           <a:p>
             <a:fld id="{6F8407F0-4949-4EDC-A592-6ECEEFF5A038}" type="datetime1">
               <a:rPr lang="en-US" smtClean="0"/>
-              <a:t>8/5/2026</a:t>
+              <a:t>8/8/2026</a:t>
             </a:fld>
             <a:endParaRPr lang="en-US" dirty="0"/>
           </a:p>
@@ -6933,7 +6933,7 @@
           <a:p>
             <a:fld id="{298A7F69-C248-41A3-8602-E8D54188EDB0}" type="datetime1">
               <a:rPr lang="en-US" smtClean="0"/>
-              <a:t>8/5/2026</a:t>
+              <a:t>8/8/2026</a:t>
             </a:fld>
             <a:endParaRPr lang="en-US" dirty="0"/>
           </a:p>
@@ -7169,7 +7169,7 @@
           <a:p>
             <a:fld id="{1F20B086-39C4-4128-985B-FB07F33D3CF3}" type="datetime1">
               <a:rPr lang="en-US" smtClean="0"/>
-              <a:t>8/5/2026</a:t>
+              <a:t>8/8/2026</a:t>
             </a:fld>
             <a:endParaRPr lang="en-US" dirty="0"/>
           </a:p>
@@ -7547,7 +7547,7 @@
           <a:p>
             <a:fld id="{2A2ADCF5-0A36-4D40-B549-3F06F2B68F47}" type="datetime1">
               <a:rPr lang="en-US" smtClean="0"/>
-              <a:t>8/5/2026</a:t>
+              <a:t>8/8/2026</a:t>
             </a:fld>
             <a:endParaRPr lang="en-US" dirty="0"/>
           </a:p>
@@ -7674,7 +7674,7 @@
           <a:p>
             <a:fld id="{7D89728E-A64F-4CB2-A929-EC8F77743E5A}" type="datetime1">
               <a:rPr lang="en-US" smtClean="0"/>
-              <a:t>8/5/2026</a:t>
+              <a:t>8/8/2026</a:t>
             </a:fld>
             <a:endParaRPr lang="en-US" dirty="0"/>
           </a:p>
@@ -7773,7 +7773,7 @@
           <a:p>
             <a:fld id="{F1811B85-6381-4843-915E-A80D8CF566B9}" type="datetime1">
               <a:rPr lang="en-US" smtClean="0"/>
-              <a:t>8/5/2026</a:t>
+              <a:t>8/8/2026</a:t>
             </a:fld>
             <a:endParaRPr lang="en-US" dirty="0"/>
           </a:p>
@@ -8032,7 +8032,7 @@
           <a:p>
             <a:fld id="{038FA659-E42E-4DAC-9069-4C6BD9C68659}" type="datetime1">
               <a:rPr lang="en-US" smtClean="0"/>
-              <a:t>8/5/2026</a:t>
+              <a:t>8/8/2026</a:t>
             </a:fld>
             <a:endParaRPr lang="en-US" dirty="0"/>
           </a:p>
@@ -8298,7 +8298,7 @@
           <a:p>
             <a:fld id="{E08F6933-E9E6-4227-B3A4-00207D316420}" type="datetime1">
               <a:rPr lang="en-US" smtClean="0"/>
-              <a:t>8/5/2026</a:t>
+              <a:t>8/8/2026</a:t>
             </a:fld>
             <a:endParaRPr lang="en-US" dirty="0"/>
           </a:p>
@@ -9101,7 +9101,7 @@
           <a:p>
             <a:fld id="{A0393A93-C82D-47F0-A099-2DE871639089}" type="datetime1">
               <a:rPr lang="en-US" smtClean="0"/>
-              <a:t>8/5/2026</a:t>
+              <a:t>8/8/2026</a:t>
             </a:fld>
             <a:endParaRPr lang="en-US" dirty="0"/>
           </a:p>
@@ -9691,7 +9691,7 @@
           <a:p>
             <a:fld id="{AC2EE02F-DFA0-4A0E-B523-2B95372C2781}" type="datetime1">
               <a:rPr lang="en-US" smtClean="0"/>
-              <a:t>8/5/2026</a:t>
+              <a:t>8/8/2026</a:t>
             </a:fld>
             <a:endParaRPr lang="en-US" dirty="0"/>
           </a:p>
@@ -9918,7 +9918,7 @@
           <a:p>
             <a:fld id="{771FCE44-14AA-407B-9781-80C2DD8F374A}" type="datetime1">
               <a:rPr lang="en-US" smtClean="0"/>
-              <a:t>8/5/2026</a:t>
+              <a:t>8/8/2026</a:t>
             </a:fld>
             <a:endParaRPr lang="en-US" dirty="0"/>
           </a:p>
@@ -10128,7 +10128,7 @@
           <a:p>
             <a:fld id="{771FCE44-14AA-407B-9781-80C2DD8F374A}" type="datetime1">
               <a:rPr lang="en-US" smtClean="0"/>
-              <a:t>8/5/2026</a:t>
+              <a:t>8/8/2026</a:t>
             </a:fld>
             <a:endParaRPr lang="en-US" dirty="0"/>
           </a:p>
@@ -10424,7 +10424,7 @@
           <a:p>
             <a:fld id="{771FCE44-14AA-407B-9781-80C2DD8F374A}" type="datetime1">
               <a:rPr lang="en-US" smtClean="0"/>
-              <a:t>8/5/2026</a:t>
+              <a:t>8/8/2026</a:t>
             </a:fld>
             <a:endParaRPr lang="en-US" dirty="0"/>
           </a:p>
@@ -10655,7 +10655,7 @@
           <a:p>
             <a:fld id="{771FCE44-14AA-407B-9781-80C2DD8F374A}" type="datetime1">
               <a:rPr lang="en-US" smtClean="0"/>
-              <a:t>8/5/2026</a:t>
+              <a:t>8/8/2026</a:t>
             </a:fld>
             <a:endParaRPr lang="en-US" dirty="0"/>
           </a:p>
@@ -10872,7 +10872,7 @@
           <a:p>
             <a:fld id="{771FCE44-14AA-407B-9781-80C2DD8F374A}" type="datetime1">
               <a:rPr lang="en-US" smtClean="0"/>
-              <a:t>8/5/2026</a:t>
+              <a:t>8/8/2026</a:t>
             </a:fld>
             <a:endParaRPr lang="en-US" dirty="0"/>
           </a:p>
@@ -11043,7 +11043,7 @@
         </p:spPr>
         <p:txBody>
           <a:bodyPr>
-            <a:normAutofit/>
+            <a:normAutofit lnSpcReduction="10000"/>
           </a:bodyPr>
           <a:lstStyle/>
           <a:p>
@@ -11067,21 +11067,35 @@
             <a:pPr lvl="1"/>
             <a:r>
               <a:rPr lang="en-US" sz="3600" dirty="0"/>
-              <a:t>From right end: + check, # checkmate</a:t>
+              <a:t>From  tail: + check, # checkmate</a:t>
             </a:r>
           </a:p>
           <a:p>
             <a:pPr lvl="1"/>
             <a:r>
               <a:rPr lang="en-US" sz="3600" dirty="0"/>
-              <a:t>Unique: O-O, O-O-O - DONE</a:t>
+              <a:t>Unique: O-O, O-O-O – DONE</a:t>
             </a:r>
           </a:p>
           <a:p>
             <a:pPr lvl="1"/>
             <a:r>
               <a:rPr lang="en-US" sz="3600" dirty="0"/>
-              <a:t>From right end: destination e.g., e8</a:t>
+              <a:t>From tail: promotion e.g., =Q</a:t>
+            </a:r>
+          </a:p>
+          <a:p>
+            <a:pPr lvl="1"/>
+            <a:r>
+              <a:rPr lang="en-US" sz="3600" dirty="0"/>
+              <a:t>From tail: destination e.g., e8</a:t>
+            </a:r>
+          </a:p>
+          <a:p>
+            <a:pPr lvl="1"/>
+            <a:r>
+              <a:rPr lang="en-US" sz="3600" dirty="0"/>
+              <a:t>From tail: capture (x)</a:t>
             </a:r>
           </a:p>
           <a:p>
@@ -11186,13 +11200,13 @@
   <p:clrMapOvr>
     <a:masterClrMapping/>
   </p:clrMapOvr>
-  <mc:AlternateContent xmlns:mc="http://schemas.openxmlformats.org/markup-compatibility/2006">
-    <mc:Choice xmlns:p14="http://schemas.microsoft.com/office/powerpoint/2010/main" Requires="p14">
+  <mc:AlternateContent xmlns:mc="http://schemas.openxmlformats.org/markup-compatibility/2006" xmlns:p14="http://schemas.microsoft.com/office/powerpoint/2010/main">
+    <mc:Choice Requires="p14">
       <p:transition spd="med" p14:dur="700">
         <p:fade/>
       </p:transition>
     </mc:Choice>
-    <mc:Fallback>
+    <mc:Fallback xmlns="">
       <p:transition spd="med">
         <p:fade/>
       </p:transition>
@@ -11406,13 +11420,13 @@
   <p:clrMapOvr>
     <a:masterClrMapping/>
   </p:clrMapOvr>
-  <mc:AlternateContent xmlns:mc="http://schemas.openxmlformats.org/markup-compatibility/2006">
-    <mc:Choice xmlns:p14="http://schemas.microsoft.com/office/powerpoint/2010/main" Requires="p14">
+  <mc:AlternateContent xmlns:mc="http://schemas.openxmlformats.org/markup-compatibility/2006" xmlns:p14="http://schemas.microsoft.com/office/powerpoint/2010/main">
+    <mc:Choice Requires="p14">
       <p:transition spd="med" p14:dur="700">
         <p:fade/>
       </p:transition>
     </mc:Choice>
-    <mc:Fallback>
+    <mc:Fallback xmlns="">
       <p:transition spd="med">
         <p:fade/>
       </p:transition>
@@ -11522,15 +11536,7 @@
           <a:p>
             <a:r>
               <a:rPr lang="en-US" sz="3800" dirty="0"/>
-              <a:t>Determine that the only black rook in the file-f that can move to e8 is </a:t>
-            </a:r>
-            <a:r>
-              <a:rPr lang="en-US" sz="3800"/>
-              <a:t>the rook </a:t>
-            </a:r>
-            <a:r>
-              <a:rPr lang="en-US" sz="3800" dirty="0"/>
-              <a:t>starting in c8</a:t>
+              <a:t>Determine that the only black rook in the file-f that can move to e8 is the rook starting in f8</a:t>
             </a:r>
           </a:p>
           <a:p>
@@ -11564,7 +11570,7 @@
           <a:p>
             <a:fld id="{771FCE44-14AA-407B-9781-80C2DD8F374A}" type="datetime1">
               <a:rPr lang="en-US" smtClean="0"/>
-              <a:t>8/5/2026</a:t>
+              <a:t>8/8/2026</a:t>
             </a:fld>
             <a:endParaRPr lang="en-US" dirty="0"/>
           </a:p>
@@ -11775,7 +11781,7 @@
           <a:p>
             <a:fld id="{6F8407F0-4949-4EDC-A592-6ECEEFF5A038}" type="datetime1">
               <a:rPr lang="en-US" smtClean="0"/>
-              <a:t>8/5/2026</a:t>
+              <a:t>8/8/2026</a:t>
             </a:fld>
             <a:endParaRPr lang="en-US" dirty="0"/>
           </a:p>
@@ -11997,7 +12003,7 @@
           <a:p>
             <a:fld id="{6F8407F0-4949-4EDC-A592-6ECEEFF5A038}" type="datetime1">
               <a:rPr lang="en-US" smtClean="0"/>
-              <a:t>8/5/2026</a:t>
+              <a:t>8/8/2026</a:t>
             </a:fld>
             <a:endParaRPr lang="en-US" dirty="0"/>
           </a:p>
@@ -12189,7 +12195,7 @@
           <a:p>
             <a:fld id="{771FCE44-14AA-407B-9781-80C2DD8F374A}" type="datetime1">
               <a:rPr lang="en-US" smtClean="0"/>
-              <a:t>8/5/2026</a:t>
+              <a:t>8/8/2026</a:t>
             </a:fld>
             <a:endParaRPr lang="en-US" dirty="0"/>
           </a:p>
@@ -12481,7 +12487,7 @@
           <a:p>
             <a:fld id="{6F8407F0-4949-4EDC-A592-6ECEEFF5A038}" type="datetime1">
               <a:rPr lang="en-US" smtClean="0"/>
-              <a:t>8/5/2026</a:t>
+              <a:t>8/8/2026</a:t>
             </a:fld>
             <a:endParaRPr lang="en-US" dirty="0"/>
           </a:p>
@@ -12844,7 +12850,7 @@
           <a:p>
             <a:fld id="{6F8407F0-4949-4EDC-A592-6ECEEFF5A038}" type="datetime1">
               <a:rPr lang="en-US" smtClean="0"/>
-              <a:t>8/5/2026</a:t>
+              <a:t>8/8/2026</a:t>
             </a:fld>
             <a:endParaRPr lang="en-US" dirty="0"/>
           </a:p>
@@ -13294,7 +13300,7 @@
           <a:p>
             <a:fld id="{6F8407F0-4949-4EDC-A592-6ECEEFF5A038}" type="datetime1">
               <a:rPr lang="en-US" smtClean="0"/>
-              <a:t>8/5/2026</a:t>
+              <a:t>8/8/2026</a:t>
             </a:fld>
             <a:endParaRPr lang="en-US" dirty="0"/>
           </a:p>
@@ -13674,7 +13680,7 @@
           <a:p>
             <a:fld id="{6F8407F0-4949-4EDC-A592-6ECEEFF5A038}" type="datetime1">
               <a:rPr lang="en-US" smtClean="0"/>
-              <a:t>8/5/2026</a:t>
+              <a:t>8/8/2026</a:t>
             </a:fld>
             <a:endParaRPr lang="en-US" dirty="0"/>
           </a:p>
@@ -13895,7 +13901,7 @@
             </a:pPr>
             <a:r>
               <a:rPr lang="en-US" sz="2800" dirty="0"/>
-              <a:t>       B,R,Q, and K: multiples in  that direction</a:t>
+              <a:t>       B,R,Q: multiples in  that direction</a:t>
             </a:r>
           </a:p>
           <a:p>
@@ -14242,7 +14248,7 @@
           <a:p>
             <a:fld id="{6F8407F0-4949-4EDC-A592-6ECEEFF5A038}" type="datetime1">
               <a:rPr lang="en-US" smtClean="0"/>
-              <a:t>8/5/2026</a:t>
+              <a:t>8/8/2026</a:t>
             </a:fld>
             <a:endParaRPr lang="en-US" dirty="0"/>
           </a:p>
@@ -14359,7 +14365,7 @@
           <a:p>
             <a:fld id="{6F8407F0-4949-4EDC-A592-6ECEEFF5A038}" type="datetime1">
               <a:rPr lang="en-US" smtClean="0"/>
-              <a:t>8/5/2026</a:t>
+              <a:t>8/8/2026</a:t>
             </a:fld>
             <a:endParaRPr lang="en-US" dirty="0"/>
           </a:p>
@@ -14584,7 +14590,7 @@
           <a:p>
             <a:fld id="{F1811B85-6381-4843-915E-A80D8CF566B9}" type="datetime1">
               <a:rPr lang="en-US" smtClean="0"/>
-              <a:t>8/5/2026</a:t>
+              <a:t>8/8/2026</a:t>
             </a:fld>
             <a:endParaRPr lang="en-US" dirty="0"/>
           </a:p>
@@ -14736,7 +14742,7 @@
           <a:p>
             <a:fld id="{D4091550-E13A-47A9-8AAC-51D029CF9A78}" type="datetime1">
               <a:rPr lang="en-US" smtClean="0"/>
-              <a:t>8/5/2026</a:t>
+              <a:t>8/8/2026</a:t>
             </a:fld>
             <a:endParaRPr lang="en-US" dirty="0"/>
           </a:p>
@@ -14937,7 +14943,7 @@
           <a:p>
             <a:fld id="{771FCE44-14AA-407B-9781-80C2DD8F374A}" type="datetime1">
               <a:rPr lang="en-US" smtClean="0"/>
-              <a:t>8/5/2026</a:t>
+              <a:t>8/8/2026</a:t>
             </a:fld>
             <a:endParaRPr lang="en-US" dirty="0"/>
           </a:p>
@@ -15163,7 +15169,7 @@
           <a:p>
             <a:fld id="{771FCE44-14AA-407B-9781-80C2DD8F374A}" type="datetime1">
               <a:rPr lang="en-US" smtClean="0"/>
-              <a:t>8/5/2026</a:t>
+              <a:t>8/8/2026</a:t>
             </a:fld>
             <a:endParaRPr lang="en-US" dirty="0"/>
           </a:p>
@@ -15401,7 +15407,7 @@
           <a:p>
             <a:fld id="{771FCE44-14AA-407B-9781-80C2DD8F374A}" type="datetime1">
               <a:rPr lang="en-US" smtClean="0"/>
-              <a:t>8/5/2026</a:t>
+              <a:t>8/8/2026</a:t>
             </a:fld>
             <a:endParaRPr lang="en-US" dirty="0"/>
           </a:p>
@@ -15531,7 +15537,7 @@
             <a:fld id="{6F8407F0-4949-4EDC-A592-6ECEEFF5A038}" type="datetime1">
               <a:rPr lang="en-US" smtClean="0"/>
               <a:pPr/>
-              <a:t>8/5/2026</a:t>
+              <a:t>8/8/2026</a:t>
             </a:fld>
             <a:endParaRPr lang="en-US" dirty="0"/>
           </a:p>
@@ -15686,7 +15692,7 @@
             <a:fld id="{6F8407F0-4949-4EDC-A592-6ECEEFF5A038}" type="datetime1">
               <a:rPr lang="en-US" smtClean="0"/>
               <a:pPr/>
-              <a:t>8/5/2026</a:t>
+              <a:t>8/8/2026</a:t>
             </a:fld>
             <a:endParaRPr lang="en-US" dirty="0"/>
           </a:p>
@@ -16013,7 +16019,7 @@
           <a:p>
             <a:fld id="{6F8407F0-4949-4EDC-A592-6ECEEFF5A038}" type="datetime1">
               <a:rPr lang="en-US" smtClean="0"/>
-              <a:t>8/5/2026</a:t>
+              <a:t>8/8/2026</a:t>
             </a:fld>
             <a:endParaRPr lang="en-US" dirty="0"/>
           </a:p>
@@ -16258,7 +16264,7 @@
           <a:p>
             <a:fld id="{6F8407F0-4949-4EDC-A592-6ECEEFF5A038}" type="datetime1">
               <a:rPr lang="en-US" smtClean="0"/>
-              <a:t>8/5/2026</a:t>
+              <a:t>8/8/2026</a:t>
             </a:fld>
             <a:endParaRPr lang="en-US" dirty="0"/>
           </a:p>

</xml_diff>

<commit_message>
A few more move parsing chanes.
</commit_message>
<xml_diff>
--- a/Docs/Chess Display and Computers.pptx
+++ b/Docs/Chess Display and Computers.pptx
@@ -11303,13 +11303,17 @@
           <a:p>
             <a:r>
               <a:rPr lang="en-US" sz="3800" dirty="0"/>
-              <a:t>From left end: Piece, e.g., K</a:t>
-            </a:r>
-          </a:p>
-          <a:p>
+              <a:t>From left: Piece, e.g., K</a:t>
+            </a:r>
+          </a:p>
+          <a:p>
+            <a:r>
+              <a:rPr lang="en-US" sz="3800"/>
+              <a:t>From left: </a:t>
+            </a:r>
             <a:r>
               <a:rPr lang="en-US" sz="3800" dirty="0"/>
-              <a:t>From left end: source file, e.g., f</a:t>
+              <a:t>source file, e.g., f</a:t>
             </a:r>
           </a:p>
           <a:p>

</xml_diff>